<commit_message>
Adiciona evidências reais do pipeline
</commit_message>
<xml_diff>
--- a/documentacao/EcoActions-Documentacao-Tecnica.pptx
+++ b/documentacao/EcoActions-Documentacao-Tecnica.pptx
@@ -2,21 +2,21 @@
 <file path=ppt/presentation.xml><?xml version="1.0" encoding="utf-8"?>
 <p:presentation xmlns:p="http://schemas.openxmlformats.org/presentationml/2006/main">
   <p:sldMasterIdLst>
-    <p:sldMasterId xmlns:r="http://schemas.openxmlformats.org/officeDocument/2006/relationships" id="2147483648" r:id="R4922df15c2d24284"/>
+    <p:sldMasterId xmlns:r="http://schemas.openxmlformats.org/officeDocument/2006/relationships" id="2147483648" r:id="R66f2ceb4fba9437d"/>
   </p:sldMasterIdLst>
   <p:notesMasterIdLst>
-    <p:notesMasterId xmlns:r="http://schemas.openxmlformats.org/officeDocument/2006/relationships" r:id="R7ac8b85d79c5425b"/>
+    <p:notesMasterId xmlns:r="http://schemas.openxmlformats.org/officeDocument/2006/relationships" r:id="R0916ffa5b3cc48b7"/>
   </p:notesMasterIdLst>
   <p:sldIdLst>
-    <p:sldId xmlns:r="http://schemas.openxmlformats.org/officeDocument/2006/relationships" id="256" r:id="Raf27b2890bcf4dac"/>
-    <p:sldId xmlns:r="http://schemas.openxmlformats.org/officeDocument/2006/relationships" id="257" r:id="R303d8fc8118d466d"/>
-    <p:sldId xmlns:r="http://schemas.openxmlformats.org/officeDocument/2006/relationships" id="258" r:id="Rab2acdc4d9fa4dd5"/>
-    <p:sldId xmlns:r="http://schemas.openxmlformats.org/officeDocument/2006/relationships" id="259" r:id="R082a1f9cb46a434a"/>
-    <p:sldId xmlns:r="http://schemas.openxmlformats.org/officeDocument/2006/relationships" id="260" r:id="Rcc30de4879334474"/>
-    <p:sldId xmlns:r="http://schemas.openxmlformats.org/officeDocument/2006/relationships" id="261" r:id="Ra14e7187358f47a9"/>
-    <p:sldId xmlns:r="http://schemas.openxmlformats.org/officeDocument/2006/relationships" id="262" r:id="Rea9c6c11b3d04aea"/>
-    <p:sldId xmlns:r="http://schemas.openxmlformats.org/officeDocument/2006/relationships" id="263" r:id="R4eeffdda4f1c4235"/>
-    <p:sldId xmlns:r="http://schemas.openxmlformats.org/officeDocument/2006/relationships" id="264" r:id="R5f803f542cb64544"/>
+    <p:sldId xmlns:r="http://schemas.openxmlformats.org/officeDocument/2006/relationships" id="256" r:id="R68d4d6813a134145"/>
+    <p:sldId xmlns:r="http://schemas.openxmlformats.org/officeDocument/2006/relationships" id="257" r:id="R62e64b542cf949ed"/>
+    <p:sldId xmlns:r="http://schemas.openxmlformats.org/officeDocument/2006/relationships" id="258" r:id="Ree87451b27d841d4"/>
+    <p:sldId xmlns:r="http://schemas.openxmlformats.org/officeDocument/2006/relationships" id="259" r:id="R7948cb8ccb844723"/>
+    <p:sldId xmlns:r="http://schemas.openxmlformats.org/officeDocument/2006/relationships" id="260" r:id="Rfc5f04e6ca2f4be0"/>
+    <p:sldId xmlns:r="http://schemas.openxmlformats.org/officeDocument/2006/relationships" id="261" r:id="Rd4a8dcda44e24e89"/>
+    <p:sldId xmlns:r="http://schemas.openxmlformats.org/officeDocument/2006/relationships" id="262" r:id="Rbd006a3c7dfa40e4"/>
+    <p:sldId xmlns:r="http://schemas.openxmlformats.org/officeDocument/2006/relationships" id="263" r:id="Ref04adb46c0f4b2a"/>
+    <p:sldId xmlns:r="http://schemas.openxmlformats.org/officeDocument/2006/relationships" id="264" r:id="Rff2aed8942204374"/>
   </p:sldIdLst>
   <p:sldSz cx="12192000" cy="6858000"/>
   <p:notesSz cx="6858000" cy="9144000"/>
@@ -1021,7 +1021,7 @@
           <p:cNvPr id="3" name="Title">
             <a:extLst xmlns:a="http://schemas.openxmlformats.org/drawingml/2006/main">
               <a:ext uri="{FF2B5EF4-FFF2-40B4-BE49-F238E27FC236}">
-                <a16:creationId xmlns:a16="http://schemas.microsoft.com/office/drawing/2014/main" id="{DEAD1311-18C7-434B-9C18-C4695B7E4825}"/>
+                <a16:creationId xmlns:a16="http://schemas.microsoft.com/office/drawing/2014/main" id="{33C62055-0114-4E63-A698-0A20BB1663EC}"/>
               </a:ext>
             </a:extLst>
           </p:cNvPr>
@@ -1178,7 +1178,7 @@
           <p:cNvPr id="2" name="Subtitle">
             <a:extLst xmlns:a="http://schemas.openxmlformats.org/drawingml/2006/main">
               <a:ext uri="{FF2B5EF4-FFF2-40B4-BE49-F238E27FC236}">
-                <a16:creationId xmlns:a16="http://schemas.microsoft.com/office/drawing/2014/main" id="{2458ABF7-A416-4B8C-8639-8E24CBED3799}"/>
+                <a16:creationId xmlns:a16="http://schemas.microsoft.com/office/drawing/2014/main" id="{53B23E61-B672-4FBE-B90A-A7A0BFC080A2}"/>
               </a:ext>
             </a:extLst>
           </p:cNvPr>
@@ -1352,7 +1352,7 @@
           <p:cNvPr id="2" name="Section title">
             <a:extLst xmlns:a="http://schemas.openxmlformats.org/drawingml/2006/main">
               <a:ext uri="{FF2B5EF4-FFF2-40B4-BE49-F238E27FC236}">
-                <a16:creationId xmlns:a16="http://schemas.microsoft.com/office/drawing/2014/main" id="{53BD6B22-4B34-40FD-BFE1-303446EAC235}"/>
+                <a16:creationId xmlns:a16="http://schemas.microsoft.com/office/drawing/2014/main" id="{44531D24-DA29-44A3-B5E8-67874755B8E7}"/>
               </a:ext>
             </a:extLst>
           </p:cNvPr>
@@ -1526,7 +1526,7 @@
           <p:cNvPr id="3" name="Title">
             <a:extLst xmlns:a="http://schemas.openxmlformats.org/drawingml/2006/main">
               <a:ext uri="{FF2B5EF4-FFF2-40B4-BE49-F238E27FC236}">
-                <a16:creationId xmlns:a16="http://schemas.microsoft.com/office/drawing/2014/main" id="{ED6F394E-9392-4861-8B9F-4EADDDEF95C5}"/>
+                <a16:creationId xmlns:a16="http://schemas.microsoft.com/office/drawing/2014/main" id="{76E3ACBC-B2F8-4BA8-87F1-514C88B39595}"/>
               </a:ext>
             </a:extLst>
           </p:cNvPr>
@@ -1683,7 +1683,7 @@
           <p:cNvPr id="2" name="Body">
             <a:extLst xmlns:a="http://schemas.openxmlformats.org/drawingml/2006/main">
               <a:ext uri="{FF2B5EF4-FFF2-40B4-BE49-F238E27FC236}">
-                <a16:creationId xmlns:a16="http://schemas.microsoft.com/office/drawing/2014/main" id="{CFD620C7-880D-4BAF-BE25-46F4A3EAAE4D}"/>
+                <a16:creationId xmlns:a16="http://schemas.microsoft.com/office/drawing/2014/main" id="{991D9D06-D4B8-4F7F-ACA6-F18D76658AAF}"/>
               </a:ext>
             </a:extLst>
           </p:cNvPr>
@@ -1857,7 +1857,7 @@
           <p:cNvPr id="4" name="Title">
             <a:extLst xmlns:a="http://schemas.openxmlformats.org/drawingml/2006/main">
               <a:ext uri="{FF2B5EF4-FFF2-40B4-BE49-F238E27FC236}">
-                <a16:creationId xmlns:a16="http://schemas.microsoft.com/office/drawing/2014/main" id="{78F67113-A857-42E0-8BA3-D3ECB1355EE0}"/>
+                <a16:creationId xmlns:a16="http://schemas.microsoft.com/office/drawing/2014/main" id="{F0BAF612-8163-4D12-9B4B-3A460A9B0644}"/>
               </a:ext>
             </a:extLst>
           </p:cNvPr>
@@ -2014,7 +2014,7 @@
           <p:cNvPr id="2" name="Left column">
             <a:extLst xmlns:a="http://schemas.openxmlformats.org/drawingml/2006/main">
               <a:ext uri="{FF2B5EF4-FFF2-40B4-BE49-F238E27FC236}">
-                <a16:creationId xmlns:a16="http://schemas.microsoft.com/office/drawing/2014/main" id="{8AFD0679-A6C7-4554-82DE-A1A56C6BD4AB}"/>
+                <a16:creationId xmlns:a16="http://schemas.microsoft.com/office/drawing/2014/main" id="{E245B38E-74B3-4175-8A81-F9971F5002B7}"/>
               </a:ext>
             </a:extLst>
           </p:cNvPr>
@@ -2171,7 +2171,7 @@
           <p:cNvPr id="3" name="Right column">
             <a:extLst xmlns:a="http://schemas.openxmlformats.org/drawingml/2006/main">
               <a:ext uri="{FF2B5EF4-FFF2-40B4-BE49-F238E27FC236}">
-                <a16:creationId xmlns:a16="http://schemas.microsoft.com/office/drawing/2014/main" id="{4D9077B6-AEC9-41ED-8C1B-CF0DB42249F1}"/>
+                <a16:creationId xmlns:a16="http://schemas.microsoft.com/office/drawing/2014/main" id="{0FB6ECBA-624A-49B7-8457-E43EEBB4885A}"/>
               </a:ext>
             </a:extLst>
           </p:cNvPr>
@@ -2345,7 +2345,7 @@
           <p:cNvPr id="3" name="Title">
             <a:extLst xmlns:a="http://schemas.openxmlformats.org/drawingml/2006/main">
               <a:ext uri="{FF2B5EF4-FFF2-40B4-BE49-F238E27FC236}">
-                <a16:creationId xmlns:a16="http://schemas.microsoft.com/office/drawing/2014/main" id="{8960AA1D-F3ED-4FF7-B613-B8ED8B396C6A}"/>
+                <a16:creationId xmlns:a16="http://schemas.microsoft.com/office/drawing/2014/main" id="{6FF57BE7-92E2-46F4-9676-793C36A2FB08}"/>
               </a:ext>
             </a:extLst>
           </p:cNvPr>
@@ -2502,7 +2502,7 @@
           <p:cNvPr id="2" name="Left column">
             <a:extLst xmlns:a="http://schemas.openxmlformats.org/drawingml/2006/main">
               <a:ext uri="{FF2B5EF4-FFF2-40B4-BE49-F238E27FC236}">
-                <a16:creationId xmlns:a16="http://schemas.microsoft.com/office/drawing/2014/main" id="{23CFE592-D96E-4770-AF10-850243E700F8}"/>
+                <a16:creationId xmlns:a16="http://schemas.microsoft.com/office/drawing/2014/main" id="{DB8042FF-ABD7-4B15-8F52-6A1C8E7C7769}"/>
               </a:ext>
             </a:extLst>
           </p:cNvPr>
@@ -2697,12 +2697,12 @@
   </p:cSld>
   <p:clrMap bg1="lt1" tx1="dk1" bg2="lt2" tx2="dk2" accent1="accent1" accent2="accent2" accent3="accent3" accent4="accent4" accent5="accent5" accent6="accent6" hlink="hlink" folHlink="folHlink"/>
   <p:sldLayoutIdLst>
-    <p:sldLayoutId xmlns:r="http://schemas.openxmlformats.org/officeDocument/2006/relationships" id="2147483649" r:id="R50d247a6d08946de"/>
-    <p:sldLayoutId xmlns:r="http://schemas.openxmlformats.org/officeDocument/2006/relationships" id="2147483650" r:id="Ra48ba21edd3744a6"/>
-    <p:sldLayoutId xmlns:r="http://schemas.openxmlformats.org/officeDocument/2006/relationships" id="2147483651" r:id="Racbd61cc698c443b"/>
-    <p:sldLayoutId xmlns:r="http://schemas.openxmlformats.org/officeDocument/2006/relationships" id="2147483652" r:id="R155a6243697740f4"/>
-    <p:sldLayoutId xmlns:r="http://schemas.openxmlformats.org/officeDocument/2006/relationships" id="2147483653" r:id="R9de82dd01531432e"/>
-    <p:sldLayoutId xmlns:r="http://schemas.openxmlformats.org/officeDocument/2006/relationships" id="2147483654" r:id="Rea399b36329840d4"/>
+    <p:sldLayoutId xmlns:r="http://schemas.openxmlformats.org/officeDocument/2006/relationships" id="2147483649" r:id="Rab7196e254404550"/>
+    <p:sldLayoutId xmlns:r="http://schemas.openxmlformats.org/officeDocument/2006/relationships" id="2147483650" r:id="Rfac16ee7d6814a43"/>
+    <p:sldLayoutId xmlns:r="http://schemas.openxmlformats.org/officeDocument/2006/relationships" id="2147483651" r:id="Rd3cc563ee5db4da0"/>
+    <p:sldLayoutId xmlns:r="http://schemas.openxmlformats.org/officeDocument/2006/relationships" id="2147483652" r:id="R22c562db4b5548b3"/>
+    <p:sldLayoutId xmlns:r="http://schemas.openxmlformats.org/officeDocument/2006/relationships" id="2147483653" r:id="R5f4681634dda4c7a"/>
+    <p:sldLayoutId xmlns:r="http://schemas.openxmlformats.org/officeDocument/2006/relationships" id="2147483654" r:id="Rd02a164f28454679"/>
   </p:sldLayoutIdLst>
   <p:txStyles>
     <p:titleStyle>
@@ -3253,7 +3253,7 @@
           <p:cNvPr id="8" name="">
             <a:extLst xmlns:a="http://schemas.openxmlformats.org/drawingml/2006/main">
               <a:ext uri="{FF2B5EF4-FFF2-40B4-BE49-F238E27FC236}">
-                <a16:creationId xmlns:a16="http://schemas.microsoft.com/office/drawing/2014/main" id="{E2618E04-A227-40A9-BAEA-6870C20B2386}"/>
+                <a16:creationId xmlns:a16="http://schemas.microsoft.com/office/drawing/2014/main" id="{DE6D3457-6EDB-41C8-80E7-6C10C2665817}"/>
               </a:ext>
             </a:extLst>
           </p:cNvPr>
@@ -3263,7 +3263,7 @@
           <p:nvPr/>
         </p:nvPicPr>
         <p:blipFill>
-          <a:blip xmlns:r="http://schemas.openxmlformats.org/officeDocument/2006/relationships" xmlns:a="http://schemas.openxmlformats.org/drawingml/2006/main" r:embed="R99afea984aad4611"/>
+          <a:blip xmlns:r="http://schemas.openxmlformats.org/officeDocument/2006/relationships" xmlns:a="http://schemas.openxmlformats.org/drawingml/2006/main" r:embed="Rad7bcaf693c34a62"/>
           <a:srcRect xmlns:a="http://schemas.openxmlformats.org/drawingml/2006/main" l="0" t="27" r="0" b="27"/>
           <a:stretch xmlns:a="http://schemas.openxmlformats.org/drawingml/2006/main">
             <a:fillRect l="0" t="0" r="0" b="0"/>
@@ -3284,7 +3284,7 @@
           <p:cNvPr id="2" name="">
             <a:extLst xmlns:a="http://schemas.openxmlformats.org/drawingml/2006/main">
               <a:ext uri="{FF2B5EF4-FFF2-40B4-BE49-F238E27FC236}">
-                <a16:creationId xmlns:a16="http://schemas.microsoft.com/office/drawing/2014/main" id="{02F99E83-42BE-44CB-9EC5-8F38327F0752}"/>
+                <a16:creationId xmlns:a16="http://schemas.microsoft.com/office/drawing/2014/main" id="{83B0372D-E224-46EC-BA55-83DC0595815C}"/>
               </a:ext>
             </a:extLst>
           </p:cNvPr>
@@ -3353,7 +3353,7 @@
           <p:cNvPr id="3" name="">
             <a:extLst xmlns:a="http://schemas.openxmlformats.org/drawingml/2006/main">
               <a:ext uri="{FF2B5EF4-FFF2-40B4-BE49-F238E27FC236}">
-                <a16:creationId xmlns:a16="http://schemas.microsoft.com/office/drawing/2014/main" id="{F0DF2626-5B8B-4407-840D-369E309E36C3}"/>
+                <a16:creationId xmlns:a16="http://schemas.microsoft.com/office/drawing/2014/main" id="{0FE1125B-0886-40D7-BC40-E86E032A6937}"/>
               </a:ext>
             </a:extLst>
           </p:cNvPr>
@@ -3422,7 +3422,7 @@
           <p:cNvPr id="4" name="">
             <a:extLst xmlns:a="http://schemas.openxmlformats.org/drawingml/2006/main">
               <a:ext uri="{FF2B5EF4-FFF2-40B4-BE49-F238E27FC236}">
-                <a16:creationId xmlns:a16="http://schemas.microsoft.com/office/drawing/2014/main" id="{7F848A32-5EE4-4668-A1EB-A2349C06AC10}"/>
+                <a16:creationId xmlns:a16="http://schemas.microsoft.com/office/drawing/2014/main" id="{F57FB64C-B41E-4372-B5D4-DF17A8C207D3}"/>
               </a:ext>
             </a:extLst>
           </p:cNvPr>
@@ -3491,7 +3491,7 @@
           <p:cNvPr id="5" name="">
             <a:extLst xmlns:a="http://schemas.openxmlformats.org/drawingml/2006/main">
               <a:ext uri="{FF2B5EF4-FFF2-40B4-BE49-F238E27FC236}">
-                <a16:creationId xmlns:a16="http://schemas.microsoft.com/office/drawing/2014/main" id="{1BD43064-4256-4643-81C8-0FD981653866}"/>
+                <a16:creationId xmlns:a16="http://schemas.microsoft.com/office/drawing/2014/main" id="{42C078E0-F4D4-4391-936A-CE9FBC8928ED}"/>
               </a:ext>
             </a:extLst>
           </p:cNvPr>
@@ -3524,7 +3524,7 @@
           <p:cNvPr id="6" name="">
             <a:extLst xmlns:a="http://schemas.openxmlformats.org/drawingml/2006/main">
               <a:ext uri="{FF2B5EF4-FFF2-40B4-BE49-F238E27FC236}">
-                <a16:creationId xmlns:a16="http://schemas.microsoft.com/office/drawing/2014/main" id="{28EC22CD-A862-4E98-99F5-ED6A40B1211E}"/>
+                <a16:creationId xmlns:a16="http://schemas.microsoft.com/office/drawing/2014/main" id="{DC457E2D-70A7-4199-82C7-A2FBCCCE22FD}"/>
               </a:ext>
             </a:extLst>
           </p:cNvPr>
@@ -3616,7 +3616,7 @@
           <p:cNvPr id="7" name="">
             <a:extLst xmlns:a="http://schemas.openxmlformats.org/drawingml/2006/main">
               <a:ext uri="{FF2B5EF4-FFF2-40B4-BE49-F238E27FC236}">
-                <a16:creationId xmlns:a16="http://schemas.microsoft.com/office/drawing/2014/main" id="{4159726C-FB4F-4FFA-BEB2-EF545B27DC3D}"/>
+                <a16:creationId xmlns:a16="http://schemas.microsoft.com/office/drawing/2014/main" id="{AC60831A-DDC2-4AC7-A829-CEBCD09DD127}"/>
               </a:ext>
             </a:extLst>
           </p:cNvPr>
@@ -3683,7 +3683,7 @@
     </p:spTree>
     <p:extLst>
       <p:ext uri="{BB962C8B-B14F-4D97-AF65-F5344CB8AC3E}">
-        <p14:creationId xmlns:p14="http://schemas.microsoft.com/office/powerpoint/2010/main" val="635208009"/>
+        <p14:creationId xmlns:p14="http://schemas.microsoft.com/office/powerpoint/2010/main" val="1035066233"/>
       </p:ext>
     </p:extLst>
   </p:cSld>
@@ -3714,7 +3714,7 @@
           <p:cNvPr id="24" name="">
             <a:extLst xmlns:a="http://schemas.openxmlformats.org/drawingml/2006/main">
               <a:ext uri="{FF2B5EF4-FFF2-40B4-BE49-F238E27FC236}">
-                <a16:creationId xmlns:a16="http://schemas.microsoft.com/office/drawing/2014/main" id="{359A22FA-5FBA-4049-8CCD-2913527AED65}"/>
+                <a16:creationId xmlns:a16="http://schemas.microsoft.com/office/drawing/2014/main" id="{70D0751E-7583-4780-A9DA-1464DA1B9009}"/>
               </a:ext>
             </a:extLst>
           </p:cNvPr>
@@ -3783,7 +3783,7 @@
           <p:cNvPr id="2" name="">
             <a:extLst xmlns:a="http://schemas.openxmlformats.org/drawingml/2006/main">
               <a:ext uri="{FF2B5EF4-FFF2-40B4-BE49-F238E27FC236}">
-                <a16:creationId xmlns:a16="http://schemas.microsoft.com/office/drawing/2014/main" id="{03014A54-D30F-4B73-B3C9-2AB581AB7477}"/>
+                <a16:creationId xmlns:a16="http://schemas.microsoft.com/office/drawing/2014/main" id="{BB76DB73-A989-49BA-821A-4F0AF2E6FFCE}"/>
               </a:ext>
             </a:extLst>
           </p:cNvPr>
@@ -3852,7 +3852,7 @@
           <p:cNvPr id="3" name="">
             <a:extLst xmlns:a="http://schemas.openxmlformats.org/drawingml/2006/main">
               <a:ext uri="{FF2B5EF4-FFF2-40B4-BE49-F238E27FC236}">
-                <a16:creationId xmlns:a16="http://schemas.microsoft.com/office/drawing/2014/main" id="{B411D40B-351C-4181-B7A9-04411057F339}"/>
+                <a16:creationId xmlns:a16="http://schemas.microsoft.com/office/drawing/2014/main" id="{5B1CE859-EE05-4D01-82F2-C7B9504E7628}"/>
               </a:ext>
             </a:extLst>
           </p:cNvPr>
@@ -3921,7 +3921,7 @@
           <p:cNvPr id="4" name="">
             <a:extLst xmlns:a="http://schemas.openxmlformats.org/drawingml/2006/main">
               <a:ext uri="{FF2B5EF4-FFF2-40B4-BE49-F238E27FC236}">
-                <a16:creationId xmlns:a16="http://schemas.microsoft.com/office/drawing/2014/main" id="{645D8DCF-F368-426E-B46E-3EBE7B53ADCF}"/>
+                <a16:creationId xmlns:a16="http://schemas.microsoft.com/office/drawing/2014/main" id="{E1D0ABA5-4D88-423F-9409-7773E08BE1BE}"/>
               </a:ext>
             </a:extLst>
           </p:cNvPr>
@@ -3954,7 +3954,7 @@
           <p:cNvPr id="5" name="">
             <a:extLst xmlns:a="http://schemas.openxmlformats.org/drawingml/2006/main">
               <a:ext uri="{FF2B5EF4-FFF2-40B4-BE49-F238E27FC236}">
-                <a16:creationId xmlns:a16="http://schemas.microsoft.com/office/drawing/2014/main" id="{C6B7C7AB-0A65-4CC6-8249-1831EC648D6A}"/>
+                <a16:creationId xmlns:a16="http://schemas.microsoft.com/office/drawing/2014/main" id="{0BFBD9D8-9C86-4F80-9E04-8089A7B0E88B}"/>
               </a:ext>
             </a:extLst>
           </p:cNvPr>
@@ -4023,7 +4023,7 @@
           <p:cNvPr id="6" name="">
             <a:extLst xmlns:a="http://schemas.openxmlformats.org/drawingml/2006/main">
               <a:ext uri="{FF2B5EF4-FFF2-40B4-BE49-F238E27FC236}">
-                <a16:creationId xmlns:a16="http://schemas.microsoft.com/office/drawing/2014/main" id="{65838A61-28CB-4F20-9D74-A889BE2DA225}"/>
+                <a16:creationId xmlns:a16="http://schemas.microsoft.com/office/drawing/2014/main" id="{B25316CE-8275-4371-ABCE-89FB3A8D29D4}"/>
               </a:ext>
             </a:extLst>
           </p:cNvPr>
@@ -4092,7 +4092,7 @@
           <p:cNvPr id="7" name="">
             <a:extLst xmlns:a="http://schemas.openxmlformats.org/drawingml/2006/main">
               <a:ext uri="{FF2B5EF4-FFF2-40B4-BE49-F238E27FC236}">
-                <a16:creationId xmlns:a16="http://schemas.microsoft.com/office/drawing/2014/main" id="{C385C3FA-D274-4D86-95C7-F7A30C612C8F}"/>
+                <a16:creationId xmlns:a16="http://schemas.microsoft.com/office/drawing/2014/main" id="{D464D553-1C44-440C-B202-421C3A191919}"/>
               </a:ext>
             </a:extLst>
           </p:cNvPr>
@@ -4127,7 +4127,7 @@
           <p:cNvPr id="8" name="">
             <a:extLst xmlns:a="http://schemas.openxmlformats.org/drawingml/2006/main">
               <a:ext uri="{FF2B5EF4-FFF2-40B4-BE49-F238E27FC236}">
-                <a16:creationId xmlns:a16="http://schemas.microsoft.com/office/drawing/2014/main" id="{BF4BD502-CE98-4DE2-8CC3-CAECE72F92B5}"/>
+                <a16:creationId xmlns:a16="http://schemas.microsoft.com/office/drawing/2014/main" id="{B6A7C350-F59E-401B-8E86-0AAE77DC7C5C}"/>
               </a:ext>
             </a:extLst>
           </p:cNvPr>
@@ -4196,7 +4196,7 @@
           <p:cNvPr id="9" name="">
             <a:extLst xmlns:a="http://schemas.openxmlformats.org/drawingml/2006/main">
               <a:ext uri="{FF2B5EF4-FFF2-40B4-BE49-F238E27FC236}">
-                <a16:creationId xmlns:a16="http://schemas.microsoft.com/office/drawing/2014/main" id="{8151E8FB-A8BB-46A6-A360-FA168ABD380E}"/>
+                <a16:creationId xmlns:a16="http://schemas.microsoft.com/office/drawing/2014/main" id="{26AD7EDD-927F-4B46-8DCE-1DF6240B0459}"/>
               </a:ext>
             </a:extLst>
           </p:cNvPr>
@@ -4265,7 +4265,7 @@
           <p:cNvPr id="10" name="">
             <a:extLst xmlns:a="http://schemas.openxmlformats.org/drawingml/2006/main">
               <a:ext uri="{FF2B5EF4-FFF2-40B4-BE49-F238E27FC236}">
-                <a16:creationId xmlns:a16="http://schemas.microsoft.com/office/drawing/2014/main" id="{39FBE581-2EDB-4C69-8858-B4E5CB815644}"/>
+                <a16:creationId xmlns:a16="http://schemas.microsoft.com/office/drawing/2014/main" id="{924A4917-0CCB-41D0-A8F0-77E728FCBD29}"/>
               </a:ext>
             </a:extLst>
           </p:cNvPr>
@@ -4300,7 +4300,7 @@
           <p:cNvPr id="11" name="">
             <a:extLst xmlns:a="http://schemas.openxmlformats.org/drawingml/2006/main">
               <a:ext uri="{FF2B5EF4-FFF2-40B4-BE49-F238E27FC236}">
-                <a16:creationId xmlns:a16="http://schemas.microsoft.com/office/drawing/2014/main" id="{02677D03-B1DA-41A4-A5EB-9E95963A1842}"/>
+                <a16:creationId xmlns:a16="http://schemas.microsoft.com/office/drawing/2014/main" id="{C9628461-05F1-4F81-A839-29DD3F501811}"/>
               </a:ext>
             </a:extLst>
           </p:cNvPr>
@@ -4369,7 +4369,7 @@
           <p:cNvPr id="12" name="">
             <a:extLst xmlns:a="http://schemas.openxmlformats.org/drawingml/2006/main">
               <a:ext uri="{FF2B5EF4-FFF2-40B4-BE49-F238E27FC236}">
-                <a16:creationId xmlns:a16="http://schemas.microsoft.com/office/drawing/2014/main" id="{FECD3AFF-DA92-4A98-87E0-1561F6E8AD77}"/>
+                <a16:creationId xmlns:a16="http://schemas.microsoft.com/office/drawing/2014/main" id="{58C21778-0E85-4220-8CAE-831B91895577}"/>
               </a:ext>
             </a:extLst>
           </p:cNvPr>
@@ -4461,7 +4461,7 @@
           <p:cNvPr id="13" name="">
             <a:extLst xmlns:a="http://schemas.openxmlformats.org/drawingml/2006/main">
               <a:ext uri="{FF2B5EF4-FFF2-40B4-BE49-F238E27FC236}">
-                <a16:creationId xmlns:a16="http://schemas.microsoft.com/office/drawing/2014/main" id="{398A1D15-EAC1-409C-BDD1-A1DFB64291D9}"/>
+                <a16:creationId xmlns:a16="http://schemas.microsoft.com/office/drawing/2014/main" id="{0D6F1592-CC34-49BB-8D14-296E9B3EDA1B}"/>
               </a:ext>
             </a:extLst>
           </p:cNvPr>
@@ -4496,7 +4496,7 @@
           <p:cNvPr id="14" name="">
             <a:extLst xmlns:a="http://schemas.openxmlformats.org/drawingml/2006/main">
               <a:ext uri="{FF2B5EF4-FFF2-40B4-BE49-F238E27FC236}">
-                <a16:creationId xmlns:a16="http://schemas.microsoft.com/office/drawing/2014/main" id="{369CE32D-BD7A-4A4F-A719-BD0C73593BEB}"/>
+                <a16:creationId xmlns:a16="http://schemas.microsoft.com/office/drawing/2014/main" id="{26642A2C-2DBC-454F-9D56-2E6F236673D6}"/>
               </a:ext>
             </a:extLst>
           </p:cNvPr>
@@ -4565,7 +4565,7 @@
           <p:cNvPr id="15" name="">
             <a:extLst xmlns:a="http://schemas.openxmlformats.org/drawingml/2006/main">
               <a:ext uri="{FF2B5EF4-FFF2-40B4-BE49-F238E27FC236}">
-                <a16:creationId xmlns:a16="http://schemas.microsoft.com/office/drawing/2014/main" id="{7491E993-8E33-495A-8094-A62334DD80CA}"/>
+                <a16:creationId xmlns:a16="http://schemas.microsoft.com/office/drawing/2014/main" id="{4DBA9669-3EF1-4077-A838-7E62CFE47809}"/>
               </a:ext>
             </a:extLst>
           </p:cNvPr>
@@ -4634,7 +4634,7 @@
           <p:cNvPr id="16" name="">
             <a:extLst xmlns:a="http://schemas.openxmlformats.org/drawingml/2006/main">
               <a:ext uri="{FF2B5EF4-FFF2-40B4-BE49-F238E27FC236}">
-                <a16:creationId xmlns:a16="http://schemas.microsoft.com/office/drawing/2014/main" id="{55C539C9-EA1B-4AB8-B706-B637668C2A3C}"/>
+                <a16:creationId xmlns:a16="http://schemas.microsoft.com/office/drawing/2014/main" id="{5DB9EE99-A873-454F-B70E-14594D7511AC}"/>
               </a:ext>
             </a:extLst>
           </p:cNvPr>
@@ -4669,7 +4669,7 @@
           <p:cNvPr id="17" name="">
             <a:extLst xmlns:a="http://schemas.openxmlformats.org/drawingml/2006/main">
               <a:ext uri="{FF2B5EF4-FFF2-40B4-BE49-F238E27FC236}">
-                <a16:creationId xmlns:a16="http://schemas.microsoft.com/office/drawing/2014/main" id="{5388E0CD-FD8C-4E3F-8912-D0609A5C9810}"/>
+                <a16:creationId xmlns:a16="http://schemas.microsoft.com/office/drawing/2014/main" id="{C051D11B-42DD-420F-8E29-12D1160D3199}"/>
               </a:ext>
             </a:extLst>
           </p:cNvPr>
@@ -4738,7 +4738,7 @@
           <p:cNvPr id="18" name="">
             <a:extLst xmlns:a="http://schemas.openxmlformats.org/drawingml/2006/main">
               <a:ext uri="{FF2B5EF4-FFF2-40B4-BE49-F238E27FC236}">
-                <a16:creationId xmlns:a16="http://schemas.microsoft.com/office/drawing/2014/main" id="{85227165-F9E9-4A74-931C-AFF7A3B77EDA}"/>
+                <a16:creationId xmlns:a16="http://schemas.microsoft.com/office/drawing/2014/main" id="{8FCF6776-81BF-4CFE-AE07-369B29E1B719}"/>
               </a:ext>
             </a:extLst>
           </p:cNvPr>
@@ -4807,7 +4807,7 @@
           <p:cNvPr id="19" name="">
             <a:extLst xmlns:a="http://schemas.openxmlformats.org/drawingml/2006/main">
               <a:ext uri="{FF2B5EF4-FFF2-40B4-BE49-F238E27FC236}">
-                <a16:creationId xmlns:a16="http://schemas.microsoft.com/office/drawing/2014/main" id="{B5372B62-F6FF-4266-96D9-133DACFB1370}"/>
+                <a16:creationId xmlns:a16="http://schemas.microsoft.com/office/drawing/2014/main" id="{8CAD27B8-6D4F-4619-8044-1413DF0AD556}"/>
               </a:ext>
             </a:extLst>
           </p:cNvPr>
@@ -4842,7 +4842,7 @@
           <p:cNvPr id="20" name="">
             <a:extLst xmlns:a="http://schemas.openxmlformats.org/drawingml/2006/main">
               <a:ext uri="{FF2B5EF4-FFF2-40B4-BE49-F238E27FC236}">
-                <a16:creationId xmlns:a16="http://schemas.microsoft.com/office/drawing/2014/main" id="{5F38B2AD-2A10-4DC3-98F8-30BBBC88A9E9}"/>
+                <a16:creationId xmlns:a16="http://schemas.microsoft.com/office/drawing/2014/main" id="{08F8F580-BC67-4588-9000-B74B700FF875}"/>
               </a:ext>
             </a:extLst>
           </p:cNvPr>
@@ -4911,7 +4911,7 @@
           <p:cNvPr id="21" name="">
             <a:extLst xmlns:a="http://schemas.openxmlformats.org/drawingml/2006/main">
               <a:ext uri="{FF2B5EF4-FFF2-40B4-BE49-F238E27FC236}">
-                <a16:creationId xmlns:a16="http://schemas.microsoft.com/office/drawing/2014/main" id="{54E94DF4-BD95-407F-9015-6B95FCB585F7}"/>
+                <a16:creationId xmlns:a16="http://schemas.microsoft.com/office/drawing/2014/main" id="{CFBAC044-BAF6-4F1B-811A-E5B6758D046C}"/>
               </a:ext>
             </a:extLst>
           </p:cNvPr>
@@ -4980,7 +4980,7 @@
           <p:cNvPr id="22" name="">
             <a:extLst xmlns:a="http://schemas.openxmlformats.org/drawingml/2006/main">
               <a:ext uri="{FF2B5EF4-FFF2-40B4-BE49-F238E27FC236}">
-                <a16:creationId xmlns:a16="http://schemas.microsoft.com/office/drawing/2014/main" id="{2A1A5EAA-A439-4289-92C7-5BA5B03D53AA}"/>
+                <a16:creationId xmlns:a16="http://schemas.microsoft.com/office/drawing/2014/main" id="{84B74DFF-FB5A-4887-8CCD-3CCDEE7D94B5}"/>
               </a:ext>
             </a:extLst>
           </p:cNvPr>
@@ -5049,7 +5049,7 @@
           <p:cNvPr id="23" name="">
             <a:extLst xmlns:a="http://schemas.openxmlformats.org/drawingml/2006/main">
               <a:ext uri="{FF2B5EF4-FFF2-40B4-BE49-F238E27FC236}">
-                <a16:creationId xmlns:a16="http://schemas.microsoft.com/office/drawing/2014/main" id="{3D34130F-84B1-44E3-BD5A-D859D7EDBF06}"/>
+                <a16:creationId xmlns:a16="http://schemas.microsoft.com/office/drawing/2014/main" id="{ED4B4BF6-6169-4D5A-B8FB-1DC234F487CC}"/>
               </a:ext>
             </a:extLst>
           </p:cNvPr>
@@ -5116,7 +5116,7 @@
     </p:spTree>
     <p:extLst>
       <p:ext uri="{BB962C8B-B14F-4D97-AF65-F5344CB8AC3E}">
-        <p14:creationId xmlns:p14="http://schemas.microsoft.com/office/powerpoint/2010/main" val="987009590"/>
+        <p14:creationId xmlns:p14="http://schemas.microsoft.com/office/powerpoint/2010/main" val="135227257"/>
       </p:ext>
     </p:extLst>
   </p:cSld>
@@ -5147,7 +5147,7 @@
           <p:cNvPr id="24" name="">
             <a:extLst xmlns:a="http://schemas.openxmlformats.org/drawingml/2006/main">
               <a:ext uri="{FF2B5EF4-FFF2-40B4-BE49-F238E27FC236}">
-                <a16:creationId xmlns:a16="http://schemas.microsoft.com/office/drawing/2014/main" id="{3A4D8F2E-7C8A-43C0-890A-4E363BCF81BB}"/>
+                <a16:creationId xmlns:a16="http://schemas.microsoft.com/office/drawing/2014/main" id="{B5709689-D7CE-4093-A72D-F0ECD9AB2AD7}"/>
               </a:ext>
             </a:extLst>
           </p:cNvPr>
@@ -5216,7 +5216,7 @@
           <p:cNvPr id="2" name="">
             <a:extLst xmlns:a="http://schemas.openxmlformats.org/drawingml/2006/main">
               <a:ext uri="{FF2B5EF4-FFF2-40B4-BE49-F238E27FC236}">
-                <a16:creationId xmlns:a16="http://schemas.microsoft.com/office/drawing/2014/main" id="{EE505757-86C4-4C31-A97A-1D2AFCC3866A}"/>
+                <a16:creationId xmlns:a16="http://schemas.microsoft.com/office/drawing/2014/main" id="{128591DD-10B8-4394-91F0-E313392DD79B}"/>
               </a:ext>
             </a:extLst>
           </p:cNvPr>
@@ -5285,7 +5285,7 @@
           <p:cNvPr id="3" name="">
             <a:extLst xmlns:a="http://schemas.openxmlformats.org/drawingml/2006/main">
               <a:ext uri="{FF2B5EF4-FFF2-40B4-BE49-F238E27FC236}">
-                <a16:creationId xmlns:a16="http://schemas.microsoft.com/office/drawing/2014/main" id="{86DAB7EA-1EEF-49D1-8987-1CFAF8813DF8}"/>
+                <a16:creationId xmlns:a16="http://schemas.microsoft.com/office/drawing/2014/main" id="{98F520D6-D895-4CA3-8F8E-C6B3A4ECBFA6}"/>
               </a:ext>
             </a:extLst>
           </p:cNvPr>
@@ -5354,7 +5354,7 @@
           <p:cNvPr id="4" name="">
             <a:extLst xmlns:a="http://schemas.openxmlformats.org/drawingml/2006/main">
               <a:ext uri="{FF2B5EF4-FFF2-40B4-BE49-F238E27FC236}">
-                <a16:creationId xmlns:a16="http://schemas.microsoft.com/office/drawing/2014/main" id="{111F344F-9338-47B2-90A2-1340B2542FA8}"/>
+                <a16:creationId xmlns:a16="http://schemas.microsoft.com/office/drawing/2014/main" id="{B2749057-888C-4B67-BD50-F7EAAE39494E}"/>
               </a:ext>
             </a:extLst>
           </p:cNvPr>
@@ -5387,7 +5387,7 @@
           <p:cNvPr id="5" name="">
             <a:extLst xmlns:a="http://schemas.openxmlformats.org/drawingml/2006/main">
               <a:ext uri="{FF2B5EF4-FFF2-40B4-BE49-F238E27FC236}">
-                <a16:creationId xmlns:a16="http://schemas.microsoft.com/office/drawing/2014/main" id="{5F673A72-8F30-4FBA-85E9-B5ED8BCED353}"/>
+                <a16:creationId xmlns:a16="http://schemas.microsoft.com/office/drawing/2014/main" id="{C6332136-70DB-4E10-BB14-D7ECE82F9098}"/>
               </a:ext>
             </a:extLst>
           </p:cNvPr>
@@ -5422,7 +5422,7 @@
           <p:cNvPr id="6" name="">
             <a:extLst xmlns:a="http://schemas.openxmlformats.org/drawingml/2006/main">
               <a:ext uri="{FF2B5EF4-FFF2-40B4-BE49-F238E27FC236}">
-                <a16:creationId xmlns:a16="http://schemas.microsoft.com/office/drawing/2014/main" id="{E79F3A61-3CC4-4D9E-AA0D-3C07B6D1D63E}"/>
+                <a16:creationId xmlns:a16="http://schemas.microsoft.com/office/drawing/2014/main" id="{2CAF8602-00E7-4F96-BE53-946150DF42D3}"/>
               </a:ext>
             </a:extLst>
           </p:cNvPr>
@@ -5491,7 +5491,7 @@
           <p:cNvPr id="7" name="">
             <a:extLst xmlns:a="http://schemas.openxmlformats.org/drawingml/2006/main">
               <a:ext uri="{FF2B5EF4-FFF2-40B4-BE49-F238E27FC236}">
-                <a16:creationId xmlns:a16="http://schemas.microsoft.com/office/drawing/2014/main" id="{805EAA48-8FDF-4E9F-BFDB-9DFE59C038AC}"/>
+                <a16:creationId xmlns:a16="http://schemas.microsoft.com/office/drawing/2014/main" id="{FF2E9903-1807-4903-83DE-5117AF4FB1CC}"/>
               </a:ext>
             </a:extLst>
           </p:cNvPr>
@@ -5526,7 +5526,7 @@
           <p:cNvPr id="8" name="">
             <a:extLst xmlns:a="http://schemas.openxmlformats.org/drawingml/2006/main">
               <a:ext uri="{FF2B5EF4-FFF2-40B4-BE49-F238E27FC236}">
-                <a16:creationId xmlns:a16="http://schemas.microsoft.com/office/drawing/2014/main" id="{4A3F235F-DE5F-4857-9977-FB87862466AB}"/>
+                <a16:creationId xmlns:a16="http://schemas.microsoft.com/office/drawing/2014/main" id="{0071E482-9771-4E31-AA7E-2638FB8AA8A3}"/>
               </a:ext>
             </a:extLst>
           </p:cNvPr>
@@ -5618,7 +5618,7 @@
           <p:cNvPr id="9" name="">
             <a:extLst xmlns:a="http://schemas.openxmlformats.org/drawingml/2006/main">
               <a:ext uri="{FF2B5EF4-FFF2-40B4-BE49-F238E27FC236}">
-                <a16:creationId xmlns:a16="http://schemas.microsoft.com/office/drawing/2014/main" id="{34DB58C1-CC47-4907-B774-FF6A55423371}"/>
+                <a16:creationId xmlns:a16="http://schemas.microsoft.com/office/drawing/2014/main" id="{17B6356A-91E4-4232-994E-867196D0DD01}"/>
               </a:ext>
             </a:extLst>
           </p:cNvPr>
@@ -5653,7 +5653,7 @@
           <p:cNvPr id="10" name="">
             <a:extLst xmlns:a="http://schemas.openxmlformats.org/drawingml/2006/main">
               <a:ext uri="{FF2B5EF4-FFF2-40B4-BE49-F238E27FC236}">
-                <a16:creationId xmlns:a16="http://schemas.microsoft.com/office/drawing/2014/main" id="{84E41B4D-B248-49FD-99E9-95D2D01D553A}"/>
+                <a16:creationId xmlns:a16="http://schemas.microsoft.com/office/drawing/2014/main" id="{5CF265A4-E34A-4C71-843E-9CB453540F24}"/>
               </a:ext>
             </a:extLst>
           </p:cNvPr>
@@ -5722,7 +5722,7 @@
           <p:cNvPr id="11" name="">
             <a:extLst xmlns:a="http://schemas.openxmlformats.org/drawingml/2006/main">
               <a:ext uri="{FF2B5EF4-FFF2-40B4-BE49-F238E27FC236}">
-                <a16:creationId xmlns:a16="http://schemas.microsoft.com/office/drawing/2014/main" id="{42DFCD71-9393-42AB-82DE-78CCA1A89970}"/>
+                <a16:creationId xmlns:a16="http://schemas.microsoft.com/office/drawing/2014/main" id="{D9BC06B6-1DFD-4F56-A9E4-F74BEB2EE07F}"/>
               </a:ext>
             </a:extLst>
           </p:cNvPr>
@@ -5755,7 +5755,7 @@
           <p:cNvPr id="12" name="">
             <a:extLst xmlns:a="http://schemas.openxmlformats.org/drawingml/2006/main">
               <a:ext uri="{FF2B5EF4-FFF2-40B4-BE49-F238E27FC236}">
-                <a16:creationId xmlns:a16="http://schemas.microsoft.com/office/drawing/2014/main" id="{1A72E8AC-D5B7-4B51-BBE6-770DBB01E519}"/>
+                <a16:creationId xmlns:a16="http://schemas.microsoft.com/office/drawing/2014/main" id="{E924004B-DDA9-4B16-B99B-E2A686AFCD64}"/>
               </a:ext>
             </a:extLst>
           </p:cNvPr>
@@ -5788,7 +5788,7 @@
           <p:cNvPr id="13" name="">
             <a:extLst xmlns:a="http://schemas.openxmlformats.org/drawingml/2006/main">
               <a:ext uri="{FF2B5EF4-FFF2-40B4-BE49-F238E27FC236}">
-                <a16:creationId xmlns:a16="http://schemas.microsoft.com/office/drawing/2014/main" id="{225FD5F3-2867-42D6-9679-6F037D7FEFAC}"/>
+                <a16:creationId xmlns:a16="http://schemas.microsoft.com/office/drawing/2014/main" id="{DB65EF9B-E080-47AC-833A-9ED5E4E55C3C}"/>
               </a:ext>
             </a:extLst>
           </p:cNvPr>
@@ -5857,7 +5857,7 @@
           <p:cNvPr id="14" name="">
             <a:extLst xmlns:a="http://schemas.openxmlformats.org/drawingml/2006/main">
               <a:ext uri="{FF2B5EF4-FFF2-40B4-BE49-F238E27FC236}">
-                <a16:creationId xmlns:a16="http://schemas.microsoft.com/office/drawing/2014/main" id="{65DF35D7-C47C-4DD4-A3BF-F2423F746223}"/>
+                <a16:creationId xmlns:a16="http://schemas.microsoft.com/office/drawing/2014/main" id="{28998CE5-AB87-42D4-B8A0-6EDE76E9D499}"/>
               </a:ext>
             </a:extLst>
           </p:cNvPr>
@@ -5926,7 +5926,7 @@
           <p:cNvPr id="15" name="">
             <a:extLst xmlns:a="http://schemas.openxmlformats.org/drawingml/2006/main">
               <a:ext uri="{FF2B5EF4-FFF2-40B4-BE49-F238E27FC236}">
-                <a16:creationId xmlns:a16="http://schemas.microsoft.com/office/drawing/2014/main" id="{CCC16628-36FD-40CE-B34D-D26AD415F359}"/>
+                <a16:creationId xmlns:a16="http://schemas.microsoft.com/office/drawing/2014/main" id="{C818F983-D367-4832-952D-07BBF83AE27C}"/>
               </a:ext>
             </a:extLst>
           </p:cNvPr>
@@ -5995,7 +5995,7 @@
           <p:cNvPr id="16" name="">
             <a:extLst xmlns:a="http://schemas.openxmlformats.org/drawingml/2006/main">
               <a:ext uri="{FF2B5EF4-FFF2-40B4-BE49-F238E27FC236}">
-                <a16:creationId xmlns:a16="http://schemas.microsoft.com/office/drawing/2014/main" id="{BC8B8285-59B3-45BE-A19B-0274235640B3}"/>
+                <a16:creationId xmlns:a16="http://schemas.microsoft.com/office/drawing/2014/main" id="{83D823A2-AFE8-499C-93A0-14B11ADEB457}"/>
               </a:ext>
             </a:extLst>
           </p:cNvPr>
@@ -6064,7 +6064,7 @@
           <p:cNvPr id="17" name="">
             <a:extLst xmlns:a="http://schemas.openxmlformats.org/drawingml/2006/main">
               <a:ext uri="{FF2B5EF4-FFF2-40B4-BE49-F238E27FC236}">
-                <a16:creationId xmlns:a16="http://schemas.microsoft.com/office/drawing/2014/main" id="{E6E0961D-89E8-456F-B368-79606A325982}"/>
+                <a16:creationId xmlns:a16="http://schemas.microsoft.com/office/drawing/2014/main" id="{E8783407-A01F-45C2-AA8F-2CD51AFE347D}"/>
               </a:ext>
             </a:extLst>
           </p:cNvPr>
@@ -6133,7 +6133,7 @@
           <p:cNvPr id="18" name="">
             <a:extLst xmlns:a="http://schemas.openxmlformats.org/drawingml/2006/main">
               <a:ext uri="{FF2B5EF4-FFF2-40B4-BE49-F238E27FC236}">
-                <a16:creationId xmlns:a16="http://schemas.microsoft.com/office/drawing/2014/main" id="{576FD081-59E0-4A70-BEEA-F6188D1CAAD3}"/>
+                <a16:creationId xmlns:a16="http://schemas.microsoft.com/office/drawing/2014/main" id="{70224601-18F2-44D8-8BE4-4284A87656BB}"/>
               </a:ext>
             </a:extLst>
           </p:cNvPr>
@@ -6202,7 +6202,7 @@
           <p:cNvPr id="19" name="">
             <a:extLst xmlns:a="http://schemas.openxmlformats.org/drawingml/2006/main">
               <a:ext uri="{FF2B5EF4-FFF2-40B4-BE49-F238E27FC236}">
-                <a16:creationId xmlns:a16="http://schemas.microsoft.com/office/drawing/2014/main" id="{B0A37AE0-A973-4E34-9DAE-F153CD22332E}"/>
+                <a16:creationId xmlns:a16="http://schemas.microsoft.com/office/drawing/2014/main" id="{B4D674D9-6AC5-49CD-9A2F-237614B0DC4E}"/>
               </a:ext>
             </a:extLst>
           </p:cNvPr>
@@ -6271,7 +6271,7 @@
           <p:cNvPr id="20" name="">
             <a:extLst xmlns:a="http://schemas.openxmlformats.org/drawingml/2006/main">
               <a:ext uri="{FF2B5EF4-FFF2-40B4-BE49-F238E27FC236}">
-                <a16:creationId xmlns:a16="http://schemas.microsoft.com/office/drawing/2014/main" id="{5929ACBF-ACC0-4985-98BB-3561C9EBA72D}"/>
+                <a16:creationId xmlns:a16="http://schemas.microsoft.com/office/drawing/2014/main" id="{860EB0F5-3313-4A4C-9B1D-AEFCB1C43D83}"/>
               </a:ext>
             </a:extLst>
           </p:cNvPr>
@@ -6340,7 +6340,7 @@
           <p:cNvPr id="21" name="">
             <a:extLst xmlns:a="http://schemas.openxmlformats.org/drawingml/2006/main">
               <a:ext uri="{FF2B5EF4-FFF2-40B4-BE49-F238E27FC236}">
-                <a16:creationId xmlns:a16="http://schemas.microsoft.com/office/drawing/2014/main" id="{902CB1D8-D3A9-4E1E-9A00-D7C331463BDF}"/>
+                <a16:creationId xmlns:a16="http://schemas.microsoft.com/office/drawing/2014/main" id="{79DEB90D-A7DF-4715-A804-D3019DDC3A13}"/>
               </a:ext>
             </a:extLst>
           </p:cNvPr>
@@ -6409,7 +6409,7 @@
           <p:cNvPr id="22" name="">
             <a:extLst xmlns:a="http://schemas.openxmlformats.org/drawingml/2006/main">
               <a:ext uri="{FF2B5EF4-FFF2-40B4-BE49-F238E27FC236}">
-                <a16:creationId xmlns:a16="http://schemas.microsoft.com/office/drawing/2014/main" id="{2A913DCC-FC0E-45C3-8AF6-3474F7C73A63}"/>
+                <a16:creationId xmlns:a16="http://schemas.microsoft.com/office/drawing/2014/main" id="{0A42EEF6-3267-4134-B853-064200AC4FC2}"/>
               </a:ext>
             </a:extLst>
           </p:cNvPr>
@@ -6478,7 +6478,7 @@
           <p:cNvPr id="23" name="">
             <a:extLst xmlns:a="http://schemas.openxmlformats.org/drawingml/2006/main">
               <a:ext uri="{FF2B5EF4-FFF2-40B4-BE49-F238E27FC236}">
-                <a16:creationId xmlns:a16="http://schemas.microsoft.com/office/drawing/2014/main" id="{7C151B96-A389-4A49-94DB-DFEDACD77054}"/>
+                <a16:creationId xmlns:a16="http://schemas.microsoft.com/office/drawing/2014/main" id="{E2E03EB4-F84A-4FE5-BB89-8F153A8850DC}"/>
               </a:ext>
             </a:extLst>
           </p:cNvPr>
@@ -6545,7 +6545,7 @@
     </p:spTree>
     <p:extLst>
       <p:ext uri="{BB962C8B-B14F-4D97-AF65-F5344CB8AC3E}">
-        <p14:creationId xmlns:p14="http://schemas.microsoft.com/office/powerpoint/2010/main" val="420003595"/>
+        <p14:creationId xmlns:p14="http://schemas.microsoft.com/office/powerpoint/2010/main" val="1874238899"/>
       </p:ext>
     </p:extLst>
   </p:cSld>
@@ -6576,7 +6576,7 @@
           <p:cNvPr id="28" name="">
             <a:extLst xmlns:a="http://schemas.openxmlformats.org/drawingml/2006/main">
               <a:ext uri="{FF2B5EF4-FFF2-40B4-BE49-F238E27FC236}">
-                <a16:creationId xmlns:a16="http://schemas.microsoft.com/office/drawing/2014/main" id="{42079361-7FCF-40A4-8368-87BCD7DE2D12}"/>
+                <a16:creationId xmlns:a16="http://schemas.microsoft.com/office/drawing/2014/main" id="{A337A4DC-A21B-4BE0-A12E-D8A396535B0A}"/>
               </a:ext>
             </a:extLst>
           </p:cNvPr>
@@ -6645,7 +6645,7 @@
           <p:cNvPr id="2" name="">
             <a:extLst xmlns:a="http://schemas.openxmlformats.org/drawingml/2006/main">
               <a:ext uri="{FF2B5EF4-FFF2-40B4-BE49-F238E27FC236}">
-                <a16:creationId xmlns:a16="http://schemas.microsoft.com/office/drawing/2014/main" id="{9A39FD1A-7A8F-4222-8B4A-34FC18E2757C}"/>
+                <a16:creationId xmlns:a16="http://schemas.microsoft.com/office/drawing/2014/main" id="{512A3656-6496-4170-B13C-18D0D6172CF8}"/>
               </a:ext>
             </a:extLst>
           </p:cNvPr>
@@ -6714,7 +6714,7 @@
           <p:cNvPr id="3" name="">
             <a:extLst xmlns:a="http://schemas.openxmlformats.org/drawingml/2006/main">
               <a:ext uri="{FF2B5EF4-FFF2-40B4-BE49-F238E27FC236}">
-                <a16:creationId xmlns:a16="http://schemas.microsoft.com/office/drawing/2014/main" id="{7BADACAF-231A-4DCF-BAD2-454B63FF3F9F}"/>
+                <a16:creationId xmlns:a16="http://schemas.microsoft.com/office/drawing/2014/main" id="{D4B10D3E-CC24-45FD-B5EA-58C1766D38DF}"/>
               </a:ext>
             </a:extLst>
           </p:cNvPr>
@@ -6783,7 +6783,7 @@
           <p:cNvPr id="4" name="">
             <a:extLst xmlns:a="http://schemas.openxmlformats.org/drawingml/2006/main">
               <a:ext uri="{FF2B5EF4-FFF2-40B4-BE49-F238E27FC236}">
-                <a16:creationId xmlns:a16="http://schemas.microsoft.com/office/drawing/2014/main" id="{E387A3C5-5D51-43F9-B9C3-E70E0B1C47FC}"/>
+                <a16:creationId xmlns:a16="http://schemas.microsoft.com/office/drawing/2014/main" id="{3102079D-AB58-4038-ABDA-0A36BB089D18}"/>
               </a:ext>
             </a:extLst>
           </p:cNvPr>
@@ -6816,7 +6816,7 @@
           <p:cNvPr id="5" name="">
             <a:extLst xmlns:a="http://schemas.openxmlformats.org/drawingml/2006/main">
               <a:ext uri="{FF2B5EF4-FFF2-40B4-BE49-F238E27FC236}">
-                <a16:creationId xmlns:a16="http://schemas.microsoft.com/office/drawing/2014/main" id="{FFF67704-DB31-4A17-B0CF-79ABD8090EB9}"/>
+                <a16:creationId xmlns:a16="http://schemas.microsoft.com/office/drawing/2014/main" id="{4116CCB0-1C96-437C-872B-E6BF1C7D173D}"/>
               </a:ext>
             </a:extLst>
           </p:cNvPr>
@@ -6885,7 +6885,7 @@
           <p:cNvPr id="6" name="">
             <a:extLst xmlns:a="http://schemas.openxmlformats.org/drawingml/2006/main">
               <a:ext uri="{FF2B5EF4-FFF2-40B4-BE49-F238E27FC236}">
-                <a16:creationId xmlns:a16="http://schemas.microsoft.com/office/drawing/2014/main" id="{36062E0E-F996-405C-A9A7-C699090FA191}"/>
+                <a16:creationId xmlns:a16="http://schemas.microsoft.com/office/drawing/2014/main" id="{FEFE2664-CCBA-4DF7-95E0-58F674315848}"/>
               </a:ext>
             </a:extLst>
           </p:cNvPr>
@@ -6954,7 +6954,7 @@
           <p:cNvPr id="7" name="">
             <a:extLst xmlns:a="http://schemas.openxmlformats.org/drawingml/2006/main">
               <a:ext uri="{FF2B5EF4-FFF2-40B4-BE49-F238E27FC236}">
-                <a16:creationId xmlns:a16="http://schemas.microsoft.com/office/drawing/2014/main" id="{6939A3E9-F61F-486C-9449-944054C57ACD}"/>
+                <a16:creationId xmlns:a16="http://schemas.microsoft.com/office/drawing/2014/main" id="{158A1663-DF8E-41CB-A93D-84AF5BBB18A2}"/>
               </a:ext>
             </a:extLst>
           </p:cNvPr>
@@ -7023,7 +7023,7 @@
           <p:cNvPr id="8" name="">
             <a:extLst xmlns:a="http://schemas.openxmlformats.org/drawingml/2006/main">
               <a:ext uri="{FF2B5EF4-FFF2-40B4-BE49-F238E27FC236}">
-                <a16:creationId xmlns:a16="http://schemas.microsoft.com/office/drawing/2014/main" id="{095B3C1C-254D-439F-9B49-BD737B61CAA5}"/>
+                <a16:creationId xmlns:a16="http://schemas.microsoft.com/office/drawing/2014/main" id="{83B2BB52-63D8-4C94-8708-0EC2CD4D7331}"/>
               </a:ext>
             </a:extLst>
           </p:cNvPr>
@@ -7092,7 +7092,7 @@
           <p:cNvPr id="9" name="">
             <a:extLst xmlns:a="http://schemas.openxmlformats.org/drawingml/2006/main">
               <a:ext uri="{FF2B5EF4-FFF2-40B4-BE49-F238E27FC236}">
-                <a16:creationId xmlns:a16="http://schemas.microsoft.com/office/drawing/2014/main" id="{F39E6527-F596-4173-9501-CF7F0B1DFB00}"/>
+                <a16:creationId xmlns:a16="http://schemas.microsoft.com/office/drawing/2014/main" id="{A17BF295-636F-480F-843B-6DE7C21B52F3}"/>
               </a:ext>
             </a:extLst>
           </p:cNvPr>
@@ -7127,7 +7127,7 @@
           <p:cNvPr id="10" name="">
             <a:extLst xmlns:a="http://schemas.openxmlformats.org/drawingml/2006/main">
               <a:ext uri="{FF2B5EF4-FFF2-40B4-BE49-F238E27FC236}">
-                <a16:creationId xmlns:a16="http://schemas.microsoft.com/office/drawing/2014/main" id="{594194F9-0E24-4CE2-A39C-3934D6DE794E}"/>
+                <a16:creationId xmlns:a16="http://schemas.microsoft.com/office/drawing/2014/main" id="{62F31252-4BF9-4B86-9790-2C147DBDB7F0}"/>
               </a:ext>
             </a:extLst>
           </p:cNvPr>
@@ -7196,7 +7196,7 @@
           <p:cNvPr id="11" name="">
             <a:extLst xmlns:a="http://schemas.openxmlformats.org/drawingml/2006/main">
               <a:ext uri="{FF2B5EF4-FFF2-40B4-BE49-F238E27FC236}">
-                <a16:creationId xmlns:a16="http://schemas.microsoft.com/office/drawing/2014/main" id="{E436E267-5958-43C4-B328-578790FF80AD}"/>
+                <a16:creationId xmlns:a16="http://schemas.microsoft.com/office/drawing/2014/main" id="{A1C23574-4C71-475A-833E-48FA078B8470}"/>
               </a:ext>
             </a:extLst>
           </p:cNvPr>
@@ -7265,7 +7265,7 @@
           <p:cNvPr id="12" name="">
             <a:extLst xmlns:a="http://schemas.openxmlformats.org/drawingml/2006/main">
               <a:ext uri="{FF2B5EF4-FFF2-40B4-BE49-F238E27FC236}">
-                <a16:creationId xmlns:a16="http://schemas.microsoft.com/office/drawing/2014/main" id="{C488678A-9040-42AA-8E64-D371C780CB8C}"/>
+                <a16:creationId xmlns:a16="http://schemas.microsoft.com/office/drawing/2014/main" id="{97DCF85F-FAF5-4E1C-B39E-AF58B7E671C0}"/>
               </a:ext>
             </a:extLst>
           </p:cNvPr>
@@ -7380,7 +7380,7 @@
           <p:cNvPr id="13" name="">
             <a:extLst xmlns:a="http://schemas.openxmlformats.org/drawingml/2006/main">
               <a:ext uri="{FF2B5EF4-FFF2-40B4-BE49-F238E27FC236}">
-                <a16:creationId xmlns:a16="http://schemas.microsoft.com/office/drawing/2014/main" id="{D3C88D33-7CAC-4BB8-9713-4CA0AAB67B62}"/>
+                <a16:creationId xmlns:a16="http://schemas.microsoft.com/office/drawing/2014/main" id="{11B03A0B-090F-42A7-BB61-2AA8E4545463}"/>
               </a:ext>
             </a:extLst>
           </p:cNvPr>
@@ -7415,7 +7415,7 @@
           <p:cNvPr id="14" name="">
             <a:extLst xmlns:a="http://schemas.openxmlformats.org/drawingml/2006/main">
               <a:ext uri="{FF2B5EF4-FFF2-40B4-BE49-F238E27FC236}">
-                <a16:creationId xmlns:a16="http://schemas.microsoft.com/office/drawing/2014/main" id="{148217A0-491E-4BB8-9E39-4E788BAEDC2A}"/>
+                <a16:creationId xmlns:a16="http://schemas.microsoft.com/office/drawing/2014/main" id="{C9AFACA9-C494-4B82-9006-F0607C6369E0}"/>
               </a:ext>
             </a:extLst>
           </p:cNvPr>
@@ -7484,7 +7484,7 @@
           <p:cNvPr id="15" name="">
             <a:extLst xmlns:a="http://schemas.openxmlformats.org/drawingml/2006/main">
               <a:ext uri="{FF2B5EF4-FFF2-40B4-BE49-F238E27FC236}">
-                <a16:creationId xmlns:a16="http://schemas.microsoft.com/office/drawing/2014/main" id="{1C44208B-FFDE-4AB0-BEED-1118E0BDFB7F}"/>
+                <a16:creationId xmlns:a16="http://schemas.microsoft.com/office/drawing/2014/main" id="{F4B5188B-F75A-41CD-947B-238D9EA7C36B}"/>
               </a:ext>
             </a:extLst>
           </p:cNvPr>
@@ -7553,7 +7553,7 @@
           <p:cNvPr id="16" name="">
             <a:extLst xmlns:a="http://schemas.openxmlformats.org/drawingml/2006/main">
               <a:ext uri="{FF2B5EF4-FFF2-40B4-BE49-F238E27FC236}">
-                <a16:creationId xmlns:a16="http://schemas.microsoft.com/office/drawing/2014/main" id="{19893D05-68FF-448F-BB53-A797E9F1F505}"/>
+                <a16:creationId xmlns:a16="http://schemas.microsoft.com/office/drawing/2014/main" id="{36674040-550A-4B0D-8F79-388E4E38C12A}"/>
               </a:ext>
             </a:extLst>
           </p:cNvPr>
@@ -7668,7 +7668,7 @@
           <p:cNvPr id="17" name="">
             <a:extLst xmlns:a="http://schemas.openxmlformats.org/drawingml/2006/main">
               <a:ext uri="{FF2B5EF4-FFF2-40B4-BE49-F238E27FC236}">
-                <a16:creationId xmlns:a16="http://schemas.microsoft.com/office/drawing/2014/main" id="{649C3D8A-D395-4833-ABC1-C32F26CF449B}"/>
+                <a16:creationId xmlns:a16="http://schemas.microsoft.com/office/drawing/2014/main" id="{2FD59CE9-4528-44D9-8A96-D374F42BB3F5}"/>
               </a:ext>
             </a:extLst>
           </p:cNvPr>
@@ -7703,7 +7703,7 @@
           <p:cNvPr id="18" name="">
             <a:extLst xmlns:a="http://schemas.openxmlformats.org/drawingml/2006/main">
               <a:ext uri="{FF2B5EF4-FFF2-40B4-BE49-F238E27FC236}">
-                <a16:creationId xmlns:a16="http://schemas.microsoft.com/office/drawing/2014/main" id="{F1B339BB-78D0-486E-B76F-4DE990704B00}"/>
+                <a16:creationId xmlns:a16="http://schemas.microsoft.com/office/drawing/2014/main" id="{42A2301B-1B65-4D8E-A597-7A226F053485}"/>
               </a:ext>
             </a:extLst>
           </p:cNvPr>
@@ -7772,7 +7772,7 @@
           <p:cNvPr id="19" name="">
             <a:extLst xmlns:a="http://schemas.openxmlformats.org/drawingml/2006/main">
               <a:ext uri="{FF2B5EF4-FFF2-40B4-BE49-F238E27FC236}">
-                <a16:creationId xmlns:a16="http://schemas.microsoft.com/office/drawing/2014/main" id="{E7C9B783-48DF-426A-A829-25CCFA7CFF23}"/>
+                <a16:creationId xmlns:a16="http://schemas.microsoft.com/office/drawing/2014/main" id="{3B7621AB-B08F-4E77-9D60-26FA39FF95A2}"/>
               </a:ext>
             </a:extLst>
           </p:cNvPr>
@@ -7841,7 +7841,7 @@
           <p:cNvPr id="20" name="">
             <a:extLst xmlns:a="http://schemas.openxmlformats.org/drawingml/2006/main">
               <a:ext uri="{FF2B5EF4-FFF2-40B4-BE49-F238E27FC236}">
-                <a16:creationId xmlns:a16="http://schemas.microsoft.com/office/drawing/2014/main" id="{CFA7C935-7924-4F06-ABC4-54E1F2686237}"/>
+                <a16:creationId xmlns:a16="http://schemas.microsoft.com/office/drawing/2014/main" id="{73C08E30-F4F3-4E7E-8D5C-7D58940C8938}"/>
               </a:ext>
             </a:extLst>
           </p:cNvPr>
@@ -7956,7 +7956,7 @@
           <p:cNvPr id="21" name="">
             <a:extLst xmlns:a="http://schemas.openxmlformats.org/drawingml/2006/main">
               <a:ext uri="{FF2B5EF4-FFF2-40B4-BE49-F238E27FC236}">
-                <a16:creationId xmlns:a16="http://schemas.microsoft.com/office/drawing/2014/main" id="{AD7936C6-53E8-4A63-80EF-B04E7B9A280A}"/>
+                <a16:creationId xmlns:a16="http://schemas.microsoft.com/office/drawing/2014/main" id="{ACCFE58B-0B79-4C1E-967A-6F5D1D4643E8}"/>
               </a:ext>
             </a:extLst>
           </p:cNvPr>
@@ -7991,7 +7991,7 @@
           <p:cNvPr id="22" name="">
             <a:extLst xmlns:a="http://schemas.openxmlformats.org/drawingml/2006/main">
               <a:ext uri="{FF2B5EF4-FFF2-40B4-BE49-F238E27FC236}">
-                <a16:creationId xmlns:a16="http://schemas.microsoft.com/office/drawing/2014/main" id="{76AF0C66-0C01-4E06-A6D1-B3BC0C048F1D}"/>
+                <a16:creationId xmlns:a16="http://schemas.microsoft.com/office/drawing/2014/main" id="{8D763971-E8C9-4D05-A56F-34FF12519DFC}"/>
               </a:ext>
             </a:extLst>
           </p:cNvPr>
@@ -8060,7 +8060,7 @@
           <p:cNvPr id="23" name="">
             <a:extLst xmlns:a="http://schemas.openxmlformats.org/drawingml/2006/main">
               <a:ext uri="{FF2B5EF4-FFF2-40B4-BE49-F238E27FC236}">
-                <a16:creationId xmlns:a16="http://schemas.microsoft.com/office/drawing/2014/main" id="{3CA72CB5-4CFF-4282-8F99-4EF8A4FAA827}"/>
+                <a16:creationId xmlns:a16="http://schemas.microsoft.com/office/drawing/2014/main" id="{4EEB8D6D-4B9A-4699-AD1A-A28F308C72ED}"/>
               </a:ext>
             </a:extLst>
           </p:cNvPr>
@@ -8129,7 +8129,7 @@
           <p:cNvPr id="24" name="">
             <a:extLst xmlns:a="http://schemas.openxmlformats.org/drawingml/2006/main">
               <a:ext uri="{FF2B5EF4-FFF2-40B4-BE49-F238E27FC236}">
-                <a16:creationId xmlns:a16="http://schemas.microsoft.com/office/drawing/2014/main" id="{C0A8B2AB-1C02-4B9E-B4BF-54BCB4F44AC0}"/>
+                <a16:creationId xmlns:a16="http://schemas.microsoft.com/office/drawing/2014/main" id="{B5F866FE-7D30-41B3-8481-A9A0E36677D0}"/>
               </a:ext>
             </a:extLst>
           </p:cNvPr>
@@ -8244,7 +8244,7 @@
           <p:cNvPr id="25" name="">
             <a:extLst xmlns:a="http://schemas.openxmlformats.org/drawingml/2006/main">
               <a:ext uri="{FF2B5EF4-FFF2-40B4-BE49-F238E27FC236}">
-                <a16:creationId xmlns:a16="http://schemas.microsoft.com/office/drawing/2014/main" id="{C0AD863E-0F6D-4EFC-BCA3-E23EFB38EFA2}"/>
+                <a16:creationId xmlns:a16="http://schemas.microsoft.com/office/drawing/2014/main" id="{DC2A7081-BAE1-4D24-B2D7-2296CD69171F}"/>
               </a:ext>
             </a:extLst>
           </p:cNvPr>
@@ -8313,7 +8313,7 @@
           <p:cNvPr id="26" name="">
             <a:extLst xmlns:a="http://schemas.openxmlformats.org/drawingml/2006/main">
               <a:ext uri="{FF2B5EF4-FFF2-40B4-BE49-F238E27FC236}">
-                <a16:creationId xmlns:a16="http://schemas.microsoft.com/office/drawing/2014/main" id="{B5053FBC-22E5-4B04-AD77-C6F5FC1B5B40}"/>
+                <a16:creationId xmlns:a16="http://schemas.microsoft.com/office/drawing/2014/main" id="{CF801149-9323-4E1C-82A7-45218971F14E}"/>
               </a:ext>
             </a:extLst>
           </p:cNvPr>
@@ -8382,7 +8382,7 @@
           <p:cNvPr id="27" name="">
             <a:extLst xmlns:a="http://schemas.openxmlformats.org/drawingml/2006/main">
               <a:ext uri="{FF2B5EF4-FFF2-40B4-BE49-F238E27FC236}">
-                <a16:creationId xmlns:a16="http://schemas.microsoft.com/office/drawing/2014/main" id="{CE7C48CC-9B8A-48E7-B220-69AF28BED0A7}"/>
+                <a16:creationId xmlns:a16="http://schemas.microsoft.com/office/drawing/2014/main" id="{9D9BA055-DDA1-4196-A3A7-43CD1FD0EEC1}"/>
               </a:ext>
             </a:extLst>
           </p:cNvPr>
@@ -8449,7 +8449,7 @@
     </p:spTree>
     <p:extLst>
       <p:ext uri="{BB962C8B-B14F-4D97-AF65-F5344CB8AC3E}">
-        <p14:creationId xmlns:p14="http://schemas.microsoft.com/office/powerpoint/2010/main" val="620312846"/>
+        <p14:creationId xmlns:p14="http://schemas.microsoft.com/office/powerpoint/2010/main" val="1687691269"/>
       </p:ext>
     </p:extLst>
   </p:cSld>
@@ -8480,7 +8480,7 @@
           <p:cNvPr id="12" name="">
             <a:extLst xmlns:a="http://schemas.openxmlformats.org/drawingml/2006/main">
               <a:ext uri="{FF2B5EF4-FFF2-40B4-BE49-F238E27FC236}">
-                <a16:creationId xmlns:a16="http://schemas.microsoft.com/office/drawing/2014/main" id="{72125D3A-B345-4A70-9695-722E32271FD6}"/>
+                <a16:creationId xmlns:a16="http://schemas.microsoft.com/office/drawing/2014/main" id="{F54A0062-C47A-48AA-8B93-A0772E3942D6}"/>
               </a:ext>
             </a:extLst>
           </p:cNvPr>
@@ -8549,7 +8549,7 @@
           <p:cNvPr id="2" name="">
             <a:extLst xmlns:a="http://schemas.openxmlformats.org/drawingml/2006/main">
               <a:ext uri="{FF2B5EF4-FFF2-40B4-BE49-F238E27FC236}">
-                <a16:creationId xmlns:a16="http://schemas.microsoft.com/office/drawing/2014/main" id="{33E35854-35E9-4733-86BD-4AF9D72CC9A2}"/>
+                <a16:creationId xmlns:a16="http://schemas.microsoft.com/office/drawing/2014/main" id="{9F2D4B59-DBBB-42C7-9DEC-D348443B9AEB}"/>
               </a:ext>
             </a:extLst>
           </p:cNvPr>
@@ -8618,7 +8618,7 @@
           <p:cNvPr id="3" name="">
             <a:extLst xmlns:a="http://schemas.openxmlformats.org/drawingml/2006/main">
               <a:ext uri="{FF2B5EF4-FFF2-40B4-BE49-F238E27FC236}">
-                <a16:creationId xmlns:a16="http://schemas.microsoft.com/office/drawing/2014/main" id="{7BE94EDB-2E36-4B59-9999-3674B72DD93E}"/>
+                <a16:creationId xmlns:a16="http://schemas.microsoft.com/office/drawing/2014/main" id="{C694E9FC-02C2-48C1-A702-AE89CE66C48B}"/>
               </a:ext>
             </a:extLst>
           </p:cNvPr>
@@ -8687,7 +8687,7 @@
           <p:cNvPr id="4" name="">
             <a:extLst xmlns:a="http://schemas.openxmlformats.org/drawingml/2006/main">
               <a:ext uri="{FF2B5EF4-FFF2-40B4-BE49-F238E27FC236}">
-                <a16:creationId xmlns:a16="http://schemas.microsoft.com/office/drawing/2014/main" id="{2B0293A4-B72A-4930-9D56-DEC2570822F2}"/>
+                <a16:creationId xmlns:a16="http://schemas.microsoft.com/office/drawing/2014/main" id="{4D94C9B6-4727-47F2-9942-2487526822B3}"/>
               </a:ext>
             </a:extLst>
           </p:cNvPr>
@@ -8720,7 +8720,7 @@
           <p:cNvPr id="5" name="">
             <a:extLst xmlns:a="http://schemas.openxmlformats.org/drawingml/2006/main">
               <a:ext uri="{FF2B5EF4-FFF2-40B4-BE49-F238E27FC236}">
-                <a16:creationId xmlns:a16="http://schemas.microsoft.com/office/drawing/2014/main" id="{AC6A6ADD-721F-4EE8-AA94-41F02BC79C0C}"/>
+                <a16:creationId xmlns:a16="http://schemas.microsoft.com/office/drawing/2014/main" id="{3035EB5B-6CB6-4DD5-8940-E5D6962E3476}"/>
               </a:ext>
             </a:extLst>
           </p:cNvPr>
@@ -8789,7 +8789,7 @@
           <p:cNvPr id="6" name="">
             <a:extLst xmlns:a="http://schemas.openxmlformats.org/drawingml/2006/main">
               <a:ext uri="{FF2B5EF4-FFF2-40B4-BE49-F238E27FC236}">
-                <a16:creationId xmlns:a16="http://schemas.microsoft.com/office/drawing/2014/main" id="{E09D242C-6921-493D-B557-E952CC93A978}"/>
+                <a16:creationId xmlns:a16="http://schemas.microsoft.com/office/drawing/2014/main" id="{4ECAE1D7-A399-46AF-A46F-E1BF36D89841}"/>
               </a:ext>
             </a:extLst>
           </p:cNvPr>
@@ -9034,7 +9034,7 @@
           <p:cNvPr id="7" name="">
             <a:extLst xmlns:a="http://schemas.openxmlformats.org/drawingml/2006/main">
               <a:ext uri="{FF2B5EF4-FFF2-40B4-BE49-F238E27FC236}">
-                <a16:creationId xmlns:a16="http://schemas.microsoft.com/office/drawing/2014/main" id="{9C76814E-5ED1-4474-A218-5D8512BEBCED}"/>
+                <a16:creationId xmlns:a16="http://schemas.microsoft.com/office/drawing/2014/main" id="{8C40576E-8758-407D-84ED-21FFDE1932D7}"/>
               </a:ext>
             </a:extLst>
           </p:cNvPr>
@@ -9103,7 +9103,7 @@
           <p:cNvPr id="8" name="">
             <a:extLst xmlns:a="http://schemas.openxmlformats.org/drawingml/2006/main">
               <a:ext uri="{FF2B5EF4-FFF2-40B4-BE49-F238E27FC236}">
-                <a16:creationId xmlns:a16="http://schemas.microsoft.com/office/drawing/2014/main" id="{2F78E983-C227-48E6-B174-C93EE75F0493}"/>
+                <a16:creationId xmlns:a16="http://schemas.microsoft.com/office/drawing/2014/main" id="{9E4745A3-5A4B-4F20-BD35-05499BAD9E01}"/>
               </a:ext>
             </a:extLst>
           </p:cNvPr>
@@ -9113,7 +9113,7 @@
           <p:nvPr/>
         </p:nvPicPr>
         <p:blipFill>
-          <a:blip xmlns:r="http://schemas.openxmlformats.org/officeDocument/2006/relationships" xmlns:a="http://schemas.openxmlformats.org/drawingml/2006/main" r:embed="R44140b4472dc41a5"/>
+          <a:blip xmlns:r="http://schemas.openxmlformats.org/officeDocument/2006/relationships" xmlns:a="http://schemas.openxmlformats.org/drawingml/2006/main" r:embed="Rbccd1841250844dc"/>
           <a:stretch xmlns:a="http://schemas.openxmlformats.org/drawingml/2006/main"/>
         </p:blipFill>
         <p:spPr>
@@ -9133,7 +9133,7 @@
           <p:cNvPr id="9" name="">
             <a:extLst xmlns:a="http://schemas.openxmlformats.org/drawingml/2006/main">
               <a:ext uri="{FF2B5EF4-FFF2-40B4-BE49-F238E27FC236}">
-                <a16:creationId xmlns:a16="http://schemas.microsoft.com/office/drawing/2014/main" id="{9205DCB3-CF70-4DEE-B26F-9C1950C83E86}"/>
+                <a16:creationId xmlns:a16="http://schemas.microsoft.com/office/drawing/2014/main" id="{290A4015-9E18-4705-91F5-1EB538915367}"/>
               </a:ext>
             </a:extLst>
           </p:cNvPr>
@@ -9202,7 +9202,7 @@
           <p:cNvPr id="10" name="">
             <a:extLst xmlns:a="http://schemas.openxmlformats.org/drawingml/2006/main">
               <a:ext uri="{FF2B5EF4-FFF2-40B4-BE49-F238E27FC236}">
-                <a16:creationId xmlns:a16="http://schemas.microsoft.com/office/drawing/2014/main" id="{258CC001-B2F5-4119-814E-9955772CBC89}"/>
+                <a16:creationId xmlns:a16="http://schemas.microsoft.com/office/drawing/2014/main" id="{FAC114E1-EA5B-4274-BE7C-291D51A0AB40}"/>
               </a:ext>
             </a:extLst>
           </p:cNvPr>
@@ -9271,7 +9271,7 @@
           <p:cNvPr id="11" name="">
             <a:extLst xmlns:a="http://schemas.openxmlformats.org/drawingml/2006/main">
               <a:ext uri="{FF2B5EF4-FFF2-40B4-BE49-F238E27FC236}">
-                <a16:creationId xmlns:a16="http://schemas.microsoft.com/office/drawing/2014/main" id="{6AA64011-92C3-4EBC-834A-B87299CF1486}"/>
+                <a16:creationId xmlns:a16="http://schemas.microsoft.com/office/drawing/2014/main" id="{643899D2-D254-4F43-BA46-59029DC5AA34}"/>
               </a:ext>
             </a:extLst>
           </p:cNvPr>
@@ -9338,7 +9338,7 @@
     </p:spTree>
     <p:extLst>
       <p:ext uri="{BB962C8B-B14F-4D97-AF65-F5344CB8AC3E}">
-        <p14:creationId xmlns:p14="http://schemas.microsoft.com/office/powerpoint/2010/main" val="815940890"/>
+        <p14:creationId xmlns:p14="http://schemas.microsoft.com/office/powerpoint/2010/main" val="593936720"/>
       </p:ext>
     </p:extLst>
   </p:cSld>
@@ -9366,10 +9366,10 @@
       </p:grpSpPr>
       <p:sp>
         <p:nvSpPr>
-          <p:cNvPr id="7" name="">
-            <a:extLst xmlns:a="http://schemas.openxmlformats.org/drawingml/2006/main">
-              <a:ext uri="{FF2B5EF4-FFF2-40B4-BE49-F238E27FC236}">
-                <a16:creationId xmlns:a16="http://schemas.microsoft.com/office/drawing/2014/main" id="{071BBAA8-4E1F-4915-B410-F53921886183}"/>
+          <p:cNvPr id="9" name="">
+            <a:extLst xmlns:a="http://schemas.openxmlformats.org/drawingml/2006/main">
+              <a:ext uri="{FF2B5EF4-FFF2-40B4-BE49-F238E27FC236}">
+                <a16:creationId xmlns:a16="http://schemas.microsoft.com/office/drawing/2014/main" id="{1EC35063-416D-480B-9DC5-AE32757AEC4A}"/>
               </a:ext>
             </a:extLst>
           </p:cNvPr>
@@ -9438,7 +9438,7 @@
           <p:cNvPr id="2" name="">
             <a:extLst xmlns:a="http://schemas.openxmlformats.org/drawingml/2006/main">
               <a:ext uri="{FF2B5EF4-FFF2-40B4-BE49-F238E27FC236}">
-                <a16:creationId xmlns:a16="http://schemas.microsoft.com/office/drawing/2014/main" id="{039FA893-6901-4DD5-9FD6-5D2AB6AAE7CA}"/>
+                <a16:creationId xmlns:a16="http://schemas.microsoft.com/office/drawing/2014/main" id="{1E56EF0D-DF48-4466-BCC1-68876053F82F}"/>
               </a:ext>
             </a:extLst>
           </p:cNvPr>
@@ -9497,7 +9497,7 @@
                 <a:ea typeface="Arial"/>
                 <a:cs typeface="Arial"/>
               </a:rPr>
-              <a:t>Build e testes automatizados</a:t>
+              <a:t>Execução real do pipeline</a:t>
             </a:r>
           </a:p>
         </p:txBody>
@@ -9507,7 +9507,7 @@
           <p:cNvPr id="3" name="">
             <a:extLst xmlns:a="http://schemas.openxmlformats.org/drawingml/2006/main">
               <a:ext uri="{FF2B5EF4-FFF2-40B4-BE49-F238E27FC236}">
-                <a16:creationId xmlns:a16="http://schemas.microsoft.com/office/drawing/2014/main" id="{6D910343-6B55-441A-8723-81A18CDD13F7}"/>
+                <a16:creationId xmlns:a16="http://schemas.microsoft.com/office/drawing/2014/main" id="{61AA809D-ECA0-466A-B887-C8B41AEA71E6}"/>
               </a:ext>
             </a:extLst>
           </p:cNvPr>
@@ -9566,7 +9566,7 @@
                 <a:ea typeface="Arial"/>
                 <a:cs typeface="Arial"/>
               </a:rPr>
-              <a:t>Maven Verify compilou 38 arquivos principais e executou 9 testes</a:t>
+              <a:t>GitHub Actions concluiu build, testes, imagem Docker e os dois deploys</a:t>
             </a:r>
           </a:p>
         </p:txBody>
@@ -9576,7 +9576,7 @@
           <p:cNvPr id="4" name="">
             <a:extLst xmlns:a="http://schemas.openxmlformats.org/drawingml/2006/main">
               <a:ext uri="{FF2B5EF4-FFF2-40B4-BE49-F238E27FC236}">
-                <a16:creationId xmlns:a16="http://schemas.microsoft.com/office/drawing/2014/main" id="{2B6D2A1C-9583-4E3C-8512-8995C2135000}"/>
+                <a16:creationId xmlns:a16="http://schemas.microsoft.com/office/drawing/2014/main" id="{8F651CBA-40A8-422A-A130-8BAF8155709E}"/>
               </a:ext>
             </a:extLst>
           </p:cNvPr>
@@ -9586,17 +9586,17 @@
           <p:nvPr/>
         </p:nvPicPr>
         <p:blipFill>
-          <a:blip xmlns:r="http://schemas.openxmlformats.org/officeDocument/2006/relationships" xmlns:a="http://schemas.openxmlformats.org/drawingml/2006/main" r:embed="Rb80b43cea1444df5"/>
+          <a:blip xmlns:r="http://schemas.openxmlformats.org/officeDocument/2006/relationships" xmlns:a="http://schemas.openxmlformats.org/drawingml/2006/main" r:embed="R3131cd1c0415404c"/>
           <a:stretch xmlns:a="http://schemas.openxmlformats.org/drawingml/2006/main"/>
         </p:blipFill>
         <p:spPr>
           <a:xfrm xmlns:a="http://schemas.openxmlformats.org/drawingml/2006/main">
-            <a:off x="1811867" y="1381125"/>
-            <a:ext cx="8568267" cy="4819650"/>
+            <a:off x="594675" y="1409700"/>
+            <a:ext cx="11002651" cy="3286125"/>
           </a:xfrm>
           <a:prstGeom xmlns:a="http://schemas.openxmlformats.org/drawingml/2006/main" prst="roundRect">
             <a:avLst>
-              <a:gd name="adj" fmla="val 2372"/>
+              <a:gd name="adj" fmla="val 3478"/>
             </a:avLst>
           </a:prstGeom>
         </p:spPr>
@@ -9606,19 +9606,157 @@
           <p:cNvPr id="5" name="">
             <a:extLst xmlns:a="http://schemas.openxmlformats.org/drawingml/2006/main">
               <a:ext uri="{FF2B5EF4-FFF2-40B4-BE49-F238E27FC236}">
-                <a16:creationId xmlns:a16="http://schemas.microsoft.com/office/drawing/2014/main" id="{E0529849-16E8-44BA-A5E1-8005120A19FF}"/>
-              </a:ext>
-            </a:extLst>
-          </p:cNvPr>
-          <p:cNvSpPr>
-            <a:spLocks xmlns:a="http://schemas.openxmlformats.org/drawingml/2006/main" noGrp="1"/>
-          </p:cNvSpPr>
-          <p:nvPr/>
-        </p:nvSpPr>
-        <p:spPr>
-          <a:xfrm xmlns:a="http://schemas.openxmlformats.org/drawingml/2006/main">
-            <a:off x="742950" y="6286500"/>
-            <a:ext cx="5905500" cy="228600"/>
+                <a16:creationId xmlns:a16="http://schemas.microsoft.com/office/drawing/2014/main" id="{60DAFD29-7746-414A-86E3-31B3353267F1}"/>
+              </a:ext>
+            </a:extLst>
+          </p:cNvPr>
+          <p:cNvSpPr>
+            <a:spLocks xmlns:a="http://schemas.openxmlformats.org/drawingml/2006/main" noGrp="1"/>
+          </p:cNvSpPr>
+          <p:nvPr/>
+        </p:nvSpPr>
+        <p:spPr>
+          <a:xfrm xmlns:a="http://schemas.openxmlformats.org/drawingml/2006/main">
+            <a:off x="1047750" y="4953000"/>
+            <a:ext cx="10096500" cy="342900"/>
+          </a:xfrm>
+          <a:prstGeom xmlns:a="http://schemas.openxmlformats.org/drawingml/2006/main" prst="rect">
+            <a:avLst/>
+          </a:prstGeom>
+          <a:noFill xmlns:a="http://schemas.openxmlformats.org/drawingml/2006/main"/>
+          <a:ln xmlns:a="http://schemas.openxmlformats.org/drawingml/2006/main" w="0">
+            <a:noFill/>
+            <a:prstDash val="solid"/>
+          </a:ln>
+        </p:spPr>
+        <p:txBody>
+          <a:bodyPr xmlns:a="http://schemas.openxmlformats.org/drawingml/2006/main" wrap="square" lIns="0" tIns="0" rIns="0" bIns="0" anchor="t">
+            <a:normAutofit fontScale="100000"/>
+          </a:bodyPr>
+          <a:lstStyle xmlns:a="http://schemas.openxmlformats.org/drawingml/2006/main">
+            <a:defPPr algn="ctr">
+              <a:defRPr sz="1575" b="1">
+                <a:solidFill>
+                  <a:srgbClr val="42D392"/>
+                </a:solidFill>
+                <a:latin typeface="Arial"/>
+                <a:ea typeface="Arial"/>
+                <a:cs typeface="Arial"/>
+              </a:defRPr>
+            </a:defPPr>
+          </a:lstStyle>
+          <a:p xmlns:a="http://schemas.openxmlformats.org/drawingml/2006/main">
+            <a:pPr algn="ctr">
+              <a:defRPr sz="1575" b="1">
+                <a:solidFill>
+                  <a:srgbClr val="42D392"/>
+                </a:solidFill>
+                <a:latin typeface="Arial"/>
+                <a:ea typeface="Arial"/>
+                <a:cs typeface="Arial"/>
+              </a:defRPr>
+            </a:pPr>
+            <a:r>
+              <a:rPr sz="1575" b="1">
+                <a:solidFill>
+                  <a:srgbClr val="42D392"/>
+                </a:solidFill>
+                <a:latin typeface="Arial"/>
+                <a:ea typeface="Arial"/>
+                <a:cs typeface="Arial"/>
+              </a:rPr>
+              <a:t>Build e testes: 34s. Imagem Docker: 50s. Staging: 31s. Produção: 32s.</a:t>
+            </a:r>
+          </a:p>
+        </p:txBody>
+      </p:sp>
+      <p:sp>
+        <p:nvSpPr>
+          <p:cNvPr id="6" name="">
+            <a:extLst xmlns:a="http://schemas.openxmlformats.org/drawingml/2006/main">
+              <a:ext uri="{FF2B5EF4-FFF2-40B4-BE49-F238E27FC236}">
+                <a16:creationId xmlns:a16="http://schemas.microsoft.com/office/drawing/2014/main" id="{8EA6BBE8-9C01-4CBA-9732-1C747671605C}"/>
+              </a:ext>
+            </a:extLst>
+          </p:cNvPr>
+          <p:cNvSpPr>
+            <a:spLocks xmlns:a="http://schemas.openxmlformats.org/drawingml/2006/main" noGrp="1"/>
+          </p:cNvSpPr>
+          <p:nvPr/>
+        </p:nvSpPr>
+        <p:spPr>
+          <a:xfrm xmlns:a="http://schemas.openxmlformats.org/drawingml/2006/main">
+            <a:off x="1047750" y="5429250"/>
+            <a:ext cx="10096500" cy="304800"/>
+          </a:xfrm>
+          <a:prstGeom xmlns:a="http://schemas.openxmlformats.org/drawingml/2006/main" prst="rect">
+            <a:avLst/>
+          </a:prstGeom>
+          <a:noFill xmlns:a="http://schemas.openxmlformats.org/drawingml/2006/main"/>
+          <a:ln xmlns:a="http://schemas.openxmlformats.org/drawingml/2006/main" w="0">
+            <a:noFill/>
+            <a:prstDash val="solid"/>
+          </a:ln>
+        </p:spPr>
+        <p:txBody>
+          <a:bodyPr xmlns:a="http://schemas.openxmlformats.org/drawingml/2006/main" wrap="square" lIns="0" tIns="0" rIns="0" bIns="0" anchor="t">
+            <a:normAutofit fontScale="100000"/>
+          </a:bodyPr>
+          <a:lstStyle xmlns:a="http://schemas.openxmlformats.org/drawingml/2006/main">
+            <a:defPPr algn="ctr">
+              <a:defRPr sz="1350" b="0">
+                <a:solidFill>
+                  <a:srgbClr val="D8E2EE"/>
+                </a:solidFill>
+                <a:latin typeface="Arial"/>
+                <a:ea typeface="Arial"/>
+                <a:cs typeface="Arial"/>
+              </a:defRPr>
+            </a:defPPr>
+          </a:lstStyle>
+          <a:p xmlns:a="http://schemas.openxmlformats.org/drawingml/2006/main">
+            <a:pPr algn="ctr">
+              <a:defRPr sz="1350" b="0">
+                <a:solidFill>
+                  <a:srgbClr val="D8E2EE"/>
+                </a:solidFill>
+                <a:latin typeface="Arial"/>
+                <a:ea typeface="Arial"/>
+                <a:cs typeface="Arial"/>
+              </a:defRPr>
+            </a:pPr>
+            <a:r>
+              <a:rPr sz="1350" b="0">
+                <a:solidFill>
+                  <a:srgbClr val="D8E2EE"/>
+                </a:solidFill>
+                <a:latin typeface="Arial"/>
+                <a:ea typeface="Arial"/>
+                <a:cs typeface="Arial"/>
+              </a:rPr>
+              <a:t>Status final: Success. Duração total: 2m40s. Execução #1 na branch main.</a:t>
+            </a:r>
+          </a:p>
+        </p:txBody>
+      </p:sp>
+      <p:sp>
+        <p:nvSpPr>
+          <p:cNvPr id="7" name="">
+            <a:extLst xmlns:a="http://schemas.openxmlformats.org/drawingml/2006/main">
+              <a:ext uri="{FF2B5EF4-FFF2-40B4-BE49-F238E27FC236}">
+                <a16:creationId xmlns:a16="http://schemas.microsoft.com/office/drawing/2014/main" id="{089C8CF9-9435-421E-B68E-588D4A3D3B2A}"/>
+              </a:ext>
+            </a:extLst>
+          </p:cNvPr>
+          <p:cNvSpPr>
+            <a:spLocks xmlns:a="http://schemas.openxmlformats.org/drawingml/2006/main" noGrp="1"/>
+          </p:cNvSpPr>
+          <p:nvPr/>
+        </p:nvSpPr>
+        <p:spPr>
+          <a:xfrm xmlns:a="http://schemas.openxmlformats.org/drawingml/2006/main">
+            <a:off x="742950" y="6153150"/>
+            <a:ext cx="9144000" cy="228600"/>
           </a:xfrm>
           <a:prstGeom xmlns:a="http://schemas.openxmlformats.org/drawingml/2006/main" prst="rect">
             <a:avLst/>
@@ -9665,17 +9803,17 @@
                 <a:ea typeface="Arial"/>
                 <a:cs typeface="Arial"/>
               </a:rPr>
-              <a:t>Fonte: saída real de ./mvnw clean verify</a:t>
+              <a:t>Fonte: github.com/Gabriel-Morais102/ecoactions-api/actions/runs/38076926404</a:t>
             </a:r>
           </a:p>
         </p:txBody>
       </p:sp>
       <p:sp>
         <p:nvSpPr>
-          <p:cNvPr id="6" name="">
-            <a:extLst xmlns:a="http://schemas.openxmlformats.org/drawingml/2006/main">
-              <a:ext uri="{FF2B5EF4-FFF2-40B4-BE49-F238E27FC236}">
-                <a16:creationId xmlns:a16="http://schemas.microsoft.com/office/drawing/2014/main" id="{9BA6387D-8578-45AB-A164-29FF1105050D}"/>
+          <p:cNvPr id="8" name="">
+            <a:extLst xmlns:a="http://schemas.openxmlformats.org/drawingml/2006/main">
+              <a:ext uri="{FF2B5EF4-FFF2-40B4-BE49-F238E27FC236}">
+                <a16:creationId xmlns:a16="http://schemas.microsoft.com/office/drawing/2014/main" id="{38CFB80C-5D2A-4EBC-A86B-E8DBE4DF0496}"/>
               </a:ext>
             </a:extLst>
           </p:cNvPr>
@@ -9742,7 +9880,7 @@
     </p:spTree>
     <p:extLst>
       <p:ext uri="{BB962C8B-B14F-4D97-AF65-F5344CB8AC3E}">
-        <p14:creationId xmlns:p14="http://schemas.microsoft.com/office/powerpoint/2010/main" val="1789578237"/>
+        <p14:creationId xmlns:p14="http://schemas.microsoft.com/office/powerpoint/2010/main" val="522166961"/>
       </p:ext>
     </p:extLst>
   </p:cSld>
@@ -9773,7 +9911,7 @@
           <p:cNvPr id="13" name="">
             <a:extLst xmlns:a="http://schemas.openxmlformats.org/drawingml/2006/main">
               <a:ext uri="{FF2B5EF4-FFF2-40B4-BE49-F238E27FC236}">
-                <a16:creationId xmlns:a16="http://schemas.microsoft.com/office/drawing/2014/main" id="{D8A608CA-7154-4F9C-8A07-8466048C1D42}"/>
+                <a16:creationId xmlns:a16="http://schemas.microsoft.com/office/drawing/2014/main" id="{F8801596-4061-4591-B183-7A19A7FC7F32}"/>
               </a:ext>
             </a:extLst>
           </p:cNvPr>
@@ -9842,7 +9980,7 @@
           <p:cNvPr id="2" name="">
             <a:extLst xmlns:a="http://schemas.openxmlformats.org/drawingml/2006/main">
               <a:ext uri="{FF2B5EF4-FFF2-40B4-BE49-F238E27FC236}">
-                <a16:creationId xmlns:a16="http://schemas.microsoft.com/office/drawing/2014/main" id="{BFA41CF5-774C-4259-867C-1338AA5330F0}"/>
+                <a16:creationId xmlns:a16="http://schemas.microsoft.com/office/drawing/2014/main" id="{0D1B679D-8586-4760-9483-85608D09A29F}"/>
               </a:ext>
             </a:extLst>
           </p:cNvPr>
@@ -9911,7 +10049,7 @@
           <p:cNvPr id="3" name="">
             <a:extLst xmlns:a="http://schemas.openxmlformats.org/drawingml/2006/main">
               <a:ext uri="{FF2B5EF4-FFF2-40B4-BE49-F238E27FC236}">
-                <a16:creationId xmlns:a16="http://schemas.microsoft.com/office/drawing/2014/main" id="{DEA7458B-AE1E-4C97-8C41-509D6BFA6822}"/>
+                <a16:creationId xmlns:a16="http://schemas.microsoft.com/office/drawing/2014/main" id="{5751C8F1-CBEE-4E00-A6AE-403EB900116F}"/>
               </a:ext>
             </a:extLst>
           </p:cNvPr>
@@ -9970,7 +10108,7 @@
                 <a:ea typeface="Arial"/>
                 <a:cs typeface="Arial"/>
               </a:rPr>
-              <a:t>Redes, volumes, bancos e portas independentes</a:t>
+              <a:t>Jobs reais executados em sequência pelo GitHub Actions</a:t>
             </a:r>
           </a:p>
         </p:txBody>
@@ -9980,7 +10118,7 @@
           <p:cNvPr id="4" name="">
             <a:extLst xmlns:a="http://schemas.openxmlformats.org/drawingml/2006/main">
               <a:ext uri="{FF2B5EF4-FFF2-40B4-BE49-F238E27FC236}">
-                <a16:creationId xmlns:a16="http://schemas.microsoft.com/office/drawing/2014/main" id="{3E401736-F776-4A67-A028-B96C623C6197}"/>
+                <a16:creationId xmlns:a16="http://schemas.microsoft.com/office/drawing/2014/main" id="{C9C25209-3849-481F-A001-65E53DCA4F84}"/>
               </a:ext>
             </a:extLst>
           </p:cNvPr>
@@ -10013,7 +10151,7 @@
           <p:cNvPr id="5" name="">
             <a:extLst xmlns:a="http://schemas.openxmlformats.org/drawingml/2006/main">
               <a:ext uri="{FF2B5EF4-FFF2-40B4-BE49-F238E27FC236}">
-                <a16:creationId xmlns:a16="http://schemas.microsoft.com/office/drawing/2014/main" id="{2F410B79-C9DB-40BA-A755-42365F56DE60}"/>
+                <a16:creationId xmlns:a16="http://schemas.microsoft.com/office/drawing/2014/main" id="{9A7047E8-CEBF-40BB-8CF3-DC79F3392266}"/>
               </a:ext>
             </a:extLst>
           </p:cNvPr>
@@ -10023,17 +10161,17 @@
           <p:nvPr/>
         </p:nvPicPr>
         <p:blipFill>
-          <a:blip xmlns:r="http://schemas.openxmlformats.org/officeDocument/2006/relationships" xmlns:a="http://schemas.openxmlformats.org/drawingml/2006/main" r:embed="Rac971e1a423445f3"/>
+          <a:blip xmlns:r="http://schemas.openxmlformats.org/officeDocument/2006/relationships" xmlns:a="http://schemas.openxmlformats.org/drawingml/2006/main" r:embed="R0fe99951fb6546ef"/>
           <a:stretch xmlns:a="http://schemas.openxmlformats.org/drawingml/2006/main"/>
         </p:blipFill>
         <p:spPr>
           <a:xfrm xmlns:a="http://schemas.openxmlformats.org/drawingml/2006/main">
-            <a:off x="619125" y="1582043"/>
-            <a:ext cx="5381625" cy="3027164"/>
+            <a:off x="495300" y="1478836"/>
+            <a:ext cx="5476875" cy="3881279"/>
           </a:xfrm>
           <a:prstGeom xmlns:a="http://schemas.openxmlformats.org/drawingml/2006/main" prst="roundRect">
             <a:avLst>
-              <a:gd name="adj" fmla="val 3774"/>
+              <a:gd name="adj" fmla="val 2927"/>
             </a:avLst>
           </a:prstGeom>
         </p:spPr>
@@ -10043,7 +10181,7 @@
           <p:cNvPr id="6" name="">
             <a:extLst xmlns:a="http://schemas.openxmlformats.org/drawingml/2006/main">
               <a:ext uri="{FF2B5EF4-FFF2-40B4-BE49-F238E27FC236}">
-                <a16:creationId xmlns:a16="http://schemas.microsoft.com/office/drawing/2014/main" id="{78288339-2DAD-47C1-8F44-C9735081A31E}"/>
+                <a16:creationId xmlns:a16="http://schemas.microsoft.com/office/drawing/2014/main" id="{307376B3-31AF-4270-9BB1-51014A729A5A}"/>
               </a:ext>
             </a:extLst>
           </p:cNvPr>
@@ -10053,17 +10191,17 @@
           <p:nvPr/>
         </p:nvPicPr>
         <p:blipFill>
-          <a:blip xmlns:r="http://schemas.openxmlformats.org/officeDocument/2006/relationships" xmlns:a="http://schemas.openxmlformats.org/drawingml/2006/main" r:embed="R600b35ab4cfb4e9a"/>
+          <a:blip xmlns:r="http://schemas.openxmlformats.org/officeDocument/2006/relationships" xmlns:a="http://schemas.openxmlformats.org/drawingml/2006/main" r:embed="Re9bc7792299b4217"/>
           <a:stretch xmlns:a="http://schemas.openxmlformats.org/drawingml/2006/main"/>
         </p:blipFill>
         <p:spPr>
           <a:xfrm xmlns:a="http://schemas.openxmlformats.org/drawingml/2006/main">
-            <a:off x="6191250" y="1582043"/>
-            <a:ext cx="5381625" cy="3027164"/>
+            <a:off x="6219825" y="1478836"/>
+            <a:ext cx="5476875" cy="3881279"/>
           </a:xfrm>
           <a:prstGeom xmlns:a="http://schemas.openxmlformats.org/drawingml/2006/main" prst="roundRect">
             <a:avLst>
-              <a:gd name="adj" fmla="val 3774"/>
+              <a:gd name="adj" fmla="val 2927"/>
             </a:avLst>
           </a:prstGeom>
         </p:spPr>
@@ -10073,19 +10211,19 @@
           <p:cNvPr id="7" name="">
             <a:extLst xmlns:a="http://schemas.openxmlformats.org/drawingml/2006/main">
               <a:ext uri="{FF2B5EF4-FFF2-40B4-BE49-F238E27FC236}">
-                <a16:creationId xmlns:a16="http://schemas.microsoft.com/office/drawing/2014/main" id="{B11DAE5E-25AF-40E7-99C9-CFEBE358F25A}"/>
-              </a:ext>
-            </a:extLst>
-          </p:cNvPr>
-          <p:cNvSpPr>
-            <a:spLocks xmlns:a="http://schemas.openxmlformats.org/drawingml/2006/main" noGrp="1"/>
-          </p:cNvSpPr>
-          <p:nvPr/>
-        </p:nvSpPr>
-        <p:spPr>
-          <a:xfrm xmlns:a="http://schemas.openxmlformats.org/drawingml/2006/main">
-            <a:off x="704850" y="4876800"/>
-            <a:ext cx="1714500" cy="285750"/>
+                <a16:creationId xmlns:a16="http://schemas.microsoft.com/office/drawing/2014/main" id="{78F9A79F-D293-45C3-A6F4-7C1919E09A0F}"/>
+              </a:ext>
+            </a:extLst>
+          </p:cNvPr>
+          <p:cNvSpPr>
+            <a:spLocks xmlns:a="http://schemas.openxmlformats.org/drawingml/2006/main" noGrp="1"/>
+          </p:cNvSpPr>
+          <p:nvPr/>
+        </p:nvSpPr>
+        <p:spPr>
+          <a:xfrm xmlns:a="http://schemas.openxmlformats.org/drawingml/2006/main">
+            <a:off x="685800" y="5467350"/>
+            <a:ext cx="5048250" cy="285750"/>
           </a:xfrm>
           <a:prstGeom xmlns:a="http://schemas.openxmlformats.org/drawingml/2006/main" prst="rect">
             <a:avLst/>
@@ -10101,8 +10239,8 @@
             <a:normAutofit fontScale="100000"/>
           </a:bodyPr>
           <a:lstStyle xmlns:a="http://schemas.openxmlformats.org/drawingml/2006/main">
-            <a:defPPr algn="l">
-              <a:defRPr sz="1350" b="1">
+            <a:defPPr algn="ctr">
+              <a:defRPr sz="1425" b="1">
                 <a:solidFill>
                   <a:srgbClr val="187A5A"/>
                 </a:solidFill>
@@ -10113,8 +10251,8 @@
             </a:defPPr>
           </a:lstStyle>
           <a:p xmlns:a="http://schemas.openxmlformats.org/drawingml/2006/main">
-            <a:pPr algn="l">
-              <a:defRPr sz="1350" b="1">
+            <a:pPr algn="ctr">
+              <a:defRPr sz="1425" b="1">
                 <a:solidFill>
                   <a:srgbClr val="187A5A"/>
                 </a:solidFill>
@@ -10124,7 +10262,7 @@
               </a:defRPr>
             </a:pPr>
             <a:r>
-              <a:rPr sz="1350" b="1">
+              <a:rPr sz="1425" b="1">
                 <a:solidFill>
                   <a:srgbClr val="187A5A"/>
                 </a:solidFill>
@@ -10132,7 +10270,7 @@
                 <a:ea typeface="Arial"/>
                 <a:cs typeface="Arial"/>
               </a:rPr>
-              <a:t>STAGING</a:t>
+              <a:t>STAGING · 31s</a:t>
             </a:r>
           </a:p>
         </p:txBody>
@@ -10142,19 +10280,19 @@
           <p:cNvPr id="8" name="">
             <a:extLst xmlns:a="http://schemas.openxmlformats.org/drawingml/2006/main">
               <a:ext uri="{FF2B5EF4-FFF2-40B4-BE49-F238E27FC236}">
-                <a16:creationId xmlns:a16="http://schemas.microsoft.com/office/drawing/2014/main" id="{64CAA401-17E1-4E3D-AE42-C37DB06B616A}"/>
-              </a:ext>
-            </a:extLst>
-          </p:cNvPr>
-          <p:cNvSpPr>
-            <a:spLocks xmlns:a="http://schemas.openxmlformats.org/drawingml/2006/main" noGrp="1"/>
-          </p:cNvSpPr>
-          <p:nvPr/>
-        </p:nvSpPr>
-        <p:spPr>
-          <a:xfrm xmlns:a="http://schemas.openxmlformats.org/drawingml/2006/main">
-            <a:off x="704850" y="5219700"/>
-            <a:ext cx="3333750" cy="781050"/>
+                <a16:creationId xmlns:a16="http://schemas.microsoft.com/office/drawing/2014/main" id="{7ADA4443-4EA6-4359-B0BF-0BEB747AE4BD}"/>
+              </a:ext>
+            </a:extLst>
+          </p:cNvPr>
+          <p:cNvSpPr>
+            <a:spLocks xmlns:a="http://schemas.openxmlformats.org/drawingml/2006/main" noGrp="1"/>
+          </p:cNvSpPr>
+          <p:nvPr/>
+        </p:nvSpPr>
+        <p:spPr>
+          <a:xfrm xmlns:a="http://schemas.openxmlformats.org/drawingml/2006/main">
+            <a:off x="685800" y="5791200"/>
+            <a:ext cx="5048250" cy="285750"/>
           </a:xfrm>
           <a:prstGeom xmlns:a="http://schemas.openxmlformats.org/drawingml/2006/main" prst="rect">
             <a:avLst/>
@@ -10170,8 +10308,8 @@
             <a:normAutofit fontScale="100000"/>
           </a:bodyPr>
           <a:lstStyle xmlns:a="http://schemas.openxmlformats.org/drawingml/2006/main">
-            <a:defPPr algn="l">
-              <a:defRPr sz="1425" b="0">
+            <a:defPPr algn="ctr">
+              <a:defRPr sz="1275" b="0">
                 <a:solidFill>
                   <a:srgbClr val="102235"/>
                 </a:solidFill>
@@ -10182,8 +10320,8 @@
             </a:defPPr>
           </a:lstStyle>
           <a:p xmlns:a="http://schemas.openxmlformats.org/drawingml/2006/main">
-            <a:pPr algn="l">
-              <a:defRPr sz="1425" b="0">
+            <a:pPr algn="ctr">
+              <a:defRPr sz="1275" b="0">
                 <a:solidFill>
                   <a:srgbClr val="102235"/>
                 </a:solidFill>
@@ -10193,7 +10331,7 @@
               </a:defRPr>
             </a:pPr>
             <a:r>
-              <a:rPr sz="1425" b="0">
+              <a:rPr sz="1275" b="0">
                 <a:solidFill>
                   <a:srgbClr val="102235"/>
                 </a:solidFill>
@@ -10201,55 +10339,9 @@
                 <a:ea typeface="Arial"/>
                 <a:cs typeface="Arial"/>
               </a:rPr>
-              <a:t>API 8081</a:t>
+              <a:t>Health check aprovado antes da promoção</a:t>
             </a:r>
           </a:p>
-          <a:p xmlns:a="http://schemas.openxmlformats.org/drawingml/2006/main">
-            <a:pPr algn="l">
-              <a:defRPr sz="1425" b="0">
-                <a:solidFill>
-                  <a:srgbClr val="102235"/>
-                </a:solidFill>
-                <a:latin typeface="Arial"/>
-                <a:ea typeface="Arial"/>
-                <a:cs typeface="Arial"/>
-              </a:defRPr>
-            </a:pPr>
-            <a:r>
-              <a:rPr sz="1425" b="0">
-                <a:solidFill>
-                  <a:srgbClr val="102235"/>
-                </a:solidFill>
-                <a:latin typeface="Arial"/>
-                <a:ea typeface="Arial"/>
-                <a:cs typeface="Arial"/>
-              </a:rPr>
-              <a:t>MongoDB 27018</a:t>
-            </a:r>
-          </a:p>
-          <a:p xmlns:a="http://schemas.openxmlformats.org/drawingml/2006/main">
-            <a:pPr algn="l">
-              <a:defRPr sz="1425" b="0">
-                <a:solidFill>
-                  <a:srgbClr val="102235"/>
-                </a:solidFill>
-                <a:latin typeface="Arial"/>
-                <a:ea typeface="Arial"/>
-                <a:cs typeface="Arial"/>
-              </a:defRPr>
-            </a:pPr>
-            <a:r>
-              <a:rPr sz="1425" b="0">
-                <a:solidFill>
-                  <a:srgbClr val="102235"/>
-                </a:solidFill>
-                <a:latin typeface="Arial"/>
-                <a:ea typeface="Arial"/>
-                <a:cs typeface="Arial"/>
-              </a:rPr>
-              <a:t>ecoactions_staging</a:t>
-            </a:r>
-          </a:p>
         </p:txBody>
       </p:sp>
       <p:sp>
@@ -10257,19 +10349,19 @@
           <p:cNvPr id="9" name="">
             <a:extLst xmlns:a="http://schemas.openxmlformats.org/drawingml/2006/main">
               <a:ext uri="{FF2B5EF4-FFF2-40B4-BE49-F238E27FC236}">
-                <a16:creationId xmlns:a16="http://schemas.microsoft.com/office/drawing/2014/main" id="{5B698B44-8667-4297-A192-9A5DF50E71BD}"/>
-              </a:ext>
-            </a:extLst>
-          </p:cNvPr>
-          <p:cNvSpPr>
-            <a:spLocks xmlns:a="http://schemas.openxmlformats.org/drawingml/2006/main" noGrp="1"/>
-          </p:cNvSpPr>
-          <p:nvPr/>
-        </p:nvSpPr>
-        <p:spPr>
-          <a:xfrm xmlns:a="http://schemas.openxmlformats.org/drawingml/2006/main">
-            <a:off x="6267450" y="4876800"/>
-            <a:ext cx="1714500" cy="285750"/>
+                <a16:creationId xmlns:a16="http://schemas.microsoft.com/office/drawing/2014/main" id="{2F6D112D-ED22-4FAB-964B-F35BA05D1F08}"/>
+              </a:ext>
+            </a:extLst>
+          </p:cNvPr>
+          <p:cNvSpPr>
+            <a:spLocks xmlns:a="http://schemas.openxmlformats.org/drawingml/2006/main" noGrp="1"/>
+          </p:cNvSpPr>
+          <p:nvPr/>
+        </p:nvSpPr>
+        <p:spPr>
+          <a:xfrm xmlns:a="http://schemas.openxmlformats.org/drawingml/2006/main">
+            <a:off x="6448425" y="5467350"/>
+            <a:ext cx="5048250" cy="285750"/>
           </a:xfrm>
           <a:prstGeom xmlns:a="http://schemas.openxmlformats.org/drawingml/2006/main" prst="rect">
             <a:avLst/>
@@ -10285,8 +10377,8 @@
             <a:normAutofit fontScale="100000"/>
           </a:bodyPr>
           <a:lstStyle xmlns:a="http://schemas.openxmlformats.org/drawingml/2006/main">
-            <a:defPPr algn="l">
-              <a:defRPr sz="1350" b="1">
+            <a:defPPr algn="ctr">
+              <a:defRPr sz="1425" b="1">
                 <a:solidFill>
                   <a:srgbClr val="187A5A"/>
                 </a:solidFill>
@@ -10297,8 +10389,8 @@
             </a:defPPr>
           </a:lstStyle>
           <a:p xmlns:a="http://schemas.openxmlformats.org/drawingml/2006/main">
-            <a:pPr algn="l">
-              <a:defRPr sz="1350" b="1">
+            <a:pPr algn="ctr">
+              <a:defRPr sz="1425" b="1">
                 <a:solidFill>
                   <a:srgbClr val="187A5A"/>
                 </a:solidFill>
@@ -10308,7 +10400,7 @@
               </a:defRPr>
             </a:pPr>
             <a:r>
-              <a:rPr sz="1350" b="1">
+              <a:rPr sz="1425" b="1">
                 <a:solidFill>
                   <a:srgbClr val="187A5A"/>
                 </a:solidFill>
@@ -10316,7 +10408,7 @@
                 <a:ea typeface="Arial"/>
                 <a:cs typeface="Arial"/>
               </a:rPr>
-              <a:t>PRODUÇÃO</a:t>
+              <a:t>PRODUÇÃO · 32s</a:t>
             </a:r>
           </a:p>
         </p:txBody>
@@ -10326,19 +10418,19 @@
           <p:cNvPr id="10" name="">
             <a:extLst xmlns:a="http://schemas.openxmlformats.org/drawingml/2006/main">
               <a:ext uri="{FF2B5EF4-FFF2-40B4-BE49-F238E27FC236}">
-                <a16:creationId xmlns:a16="http://schemas.microsoft.com/office/drawing/2014/main" id="{271788BF-8591-410C-8684-251B5F0CC730}"/>
-              </a:ext>
-            </a:extLst>
-          </p:cNvPr>
-          <p:cNvSpPr>
-            <a:spLocks xmlns:a="http://schemas.openxmlformats.org/drawingml/2006/main" noGrp="1"/>
-          </p:cNvSpPr>
-          <p:nvPr/>
-        </p:nvSpPr>
-        <p:spPr>
-          <a:xfrm xmlns:a="http://schemas.openxmlformats.org/drawingml/2006/main">
-            <a:off x="6267450" y="5219700"/>
-            <a:ext cx="3429000" cy="781050"/>
+                <a16:creationId xmlns:a16="http://schemas.microsoft.com/office/drawing/2014/main" id="{1E335879-91D1-481F-AECE-F5D0AB43E92B}"/>
+              </a:ext>
+            </a:extLst>
+          </p:cNvPr>
+          <p:cNvSpPr>
+            <a:spLocks xmlns:a="http://schemas.openxmlformats.org/drawingml/2006/main" noGrp="1"/>
+          </p:cNvSpPr>
+          <p:nvPr/>
+        </p:nvSpPr>
+        <p:spPr>
+          <a:xfrm xmlns:a="http://schemas.openxmlformats.org/drawingml/2006/main">
+            <a:off x="6448425" y="5791200"/>
+            <a:ext cx="5048250" cy="285750"/>
           </a:xfrm>
           <a:prstGeom xmlns:a="http://schemas.openxmlformats.org/drawingml/2006/main" prst="rect">
             <a:avLst/>
@@ -10354,8 +10446,8 @@
             <a:normAutofit fontScale="100000"/>
           </a:bodyPr>
           <a:lstStyle xmlns:a="http://schemas.openxmlformats.org/drawingml/2006/main">
-            <a:defPPr algn="l">
-              <a:defRPr sz="1425" b="0">
+            <a:defPPr algn="ctr">
+              <a:defRPr sz="1275" b="0">
                 <a:solidFill>
                   <a:srgbClr val="102235"/>
                 </a:solidFill>
@@ -10366,8 +10458,8 @@
             </a:defPPr>
           </a:lstStyle>
           <a:p xmlns:a="http://schemas.openxmlformats.org/drawingml/2006/main">
-            <a:pPr algn="l">
-              <a:defRPr sz="1425" b="0">
+            <a:pPr algn="ctr">
+              <a:defRPr sz="1275" b="0">
                 <a:solidFill>
                   <a:srgbClr val="102235"/>
                 </a:solidFill>
@@ -10377,7 +10469,7 @@
               </a:defRPr>
             </a:pPr>
             <a:r>
-              <a:rPr sz="1425" b="0">
+              <a:rPr sz="1275" b="0">
                 <a:solidFill>
                   <a:srgbClr val="102235"/>
                 </a:solidFill>
@@ -10385,55 +10477,9 @@
                 <a:ea typeface="Arial"/>
                 <a:cs typeface="Arial"/>
               </a:rPr>
-              <a:t>API 8082</a:t>
+              <a:t>Executado somente após staging</a:t>
             </a:r>
           </a:p>
-          <a:p xmlns:a="http://schemas.openxmlformats.org/drawingml/2006/main">
-            <a:pPr algn="l">
-              <a:defRPr sz="1425" b="0">
-                <a:solidFill>
-                  <a:srgbClr val="102235"/>
-                </a:solidFill>
-                <a:latin typeface="Arial"/>
-                <a:ea typeface="Arial"/>
-                <a:cs typeface="Arial"/>
-              </a:defRPr>
-            </a:pPr>
-            <a:r>
-              <a:rPr sz="1425" b="0">
-                <a:solidFill>
-                  <a:srgbClr val="102235"/>
-                </a:solidFill>
-                <a:latin typeface="Arial"/>
-                <a:ea typeface="Arial"/>
-                <a:cs typeface="Arial"/>
-              </a:rPr>
-              <a:t>MongoDB 27019</a:t>
-            </a:r>
-          </a:p>
-          <a:p xmlns:a="http://schemas.openxmlformats.org/drawingml/2006/main">
-            <a:pPr algn="l">
-              <a:defRPr sz="1425" b="0">
-                <a:solidFill>
-                  <a:srgbClr val="102235"/>
-                </a:solidFill>
-                <a:latin typeface="Arial"/>
-                <a:ea typeface="Arial"/>
-                <a:cs typeface="Arial"/>
-              </a:defRPr>
-            </a:pPr>
-            <a:r>
-              <a:rPr sz="1425" b="0">
-                <a:solidFill>
-                  <a:srgbClr val="102235"/>
-                </a:solidFill>
-                <a:latin typeface="Arial"/>
-                <a:ea typeface="Arial"/>
-                <a:cs typeface="Arial"/>
-              </a:rPr>
-              <a:t>ecoactions_production</a:t>
-            </a:r>
-          </a:p>
         </p:txBody>
       </p:sp>
       <p:sp>
@@ -10441,7 +10487,7 @@
           <p:cNvPr id="11" name="">
             <a:extLst xmlns:a="http://schemas.openxmlformats.org/drawingml/2006/main">
               <a:ext uri="{FF2B5EF4-FFF2-40B4-BE49-F238E27FC236}">
-                <a16:creationId xmlns:a16="http://schemas.microsoft.com/office/drawing/2014/main" id="{6EAF6150-00BE-4A22-AC77-E2BA96CC6AA6}"/>
+                <a16:creationId xmlns:a16="http://schemas.microsoft.com/office/drawing/2014/main" id="{A8C745D7-06DC-4838-B874-BA36AF17BE0B}"/>
               </a:ext>
             </a:extLst>
           </p:cNvPr>
@@ -10510,7 +10556,7 @@
           <p:cNvPr id="12" name="">
             <a:extLst xmlns:a="http://schemas.openxmlformats.org/drawingml/2006/main">
               <a:ext uri="{FF2B5EF4-FFF2-40B4-BE49-F238E27FC236}">
-                <a16:creationId xmlns:a16="http://schemas.microsoft.com/office/drawing/2014/main" id="{B693D9FF-7A28-4A4C-ACA6-A8635242FB6B}"/>
+                <a16:creationId xmlns:a16="http://schemas.microsoft.com/office/drawing/2014/main" id="{70BC1970-1C6A-4C59-9DE9-91F25F005C0C}"/>
               </a:ext>
             </a:extLst>
           </p:cNvPr>
@@ -10577,7 +10623,7 @@
     </p:spTree>
     <p:extLst>
       <p:ext uri="{BB962C8B-B14F-4D97-AF65-F5344CB8AC3E}">
-        <p14:creationId xmlns:p14="http://schemas.microsoft.com/office/powerpoint/2010/main" val="1043940551"/>
+        <p14:creationId xmlns:p14="http://schemas.microsoft.com/office/powerpoint/2010/main" val="18744954"/>
       </p:ext>
     </p:extLst>
   </p:cSld>
@@ -10608,7 +10654,7 @@
           <p:cNvPr id="20" name="">
             <a:extLst xmlns:a="http://schemas.openxmlformats.org/drawingml/2006/main">
               <a:ext uri="{FF2B5EF4-FFF2-40B4-BE49-F238E27FC236}">
-                <a16:creationId xmlns:a16="http://schemas.microsoft.com/office/drawing/2014/main" id="{F074BD02-4757-4567-BCAD-C2793C1366CB}"/>
+                <a16:creationId xmlns:a16="http://schemas.microsoft.com/office/drawing/2014/main" id="{52F66435-3C99-409F-97C0-0BFE9731C5F3}"/>
               </a:ext>
             </a:extLst>
           </p:cNvPr>
@@ -10677,7 +10723,7 @@
           <p:cNvPr id="2" name="">
             <a:extLst xmlns:a="http://schemas.openxmlformats.org/drawingml/2006/main">
               <a:ext uri="{FF2B5EF4-FFF2-40B4-BE49-F238E27FC236}">
-                <a16:creationId xmlns:a16="http://schemas.microsoft.com/office/drawing/2014/main" id="{945B66A9-40DF-48D3-9210-E2177EC4E79B}"/>
+                <a16:creationId xmlns:a16="http://schemas.microsoft.com/office/drawing/2014/main" id="{86A8DAC2-49BF-4528-9E3F-16D2F6AE2D70}"/>
               </a:ext>
             </a:extLst>
           </p:cNvPr>
@@ -10746,7 +10792,7 @@
           <p:cNvPr id="3" name="">
             <a:extLst xmlns:a="http://schemas.openxmlformats.org/drawingml/2006/main">
               <a:ext uri="{FF2B5EF4-FFF2-40B4-BE49-F238E27FC236}">
-                <a16:creationId xmlns:a16="http://schemas.microsoft.com/office/drawing/2014/main" id="{6079055C-63E6-45D8-AD8D-77D1CB8EDD90}"/>
+                <a16:creationId xmlns:a16="http://schemas.microsoft.com/office/drawing/2014/main" id="{C76D82DA-6BD5-46E5-8047-7D4690943DD0}"/>
               </a:ext>
             </a:extLst>
           </p:cNvPr>
@@ -10815,7 +10861,7 @@
           <p:cNvPr id="4" name="">
             <a:extLst xmlns:a="http://schemas.openxmlformats.org/drawingml/2006/main">
               <a:ext uri="{FF2B5EF4-FFF2-40B4-BE49-F238E27FC236}">
-                <a16:creationId xmlns:a16="http://schemas.microsoft.com/office/drawing/2014/main" id="{CC588E87-6C12-44C5-8FDD-56958C354F03}"/>
+                <a16:creationId xmlns:a16="http://schemas.microsoft.com/office/drawing/2014/main" id="{AD4C068D-1CE1-4A2F-ABA3-C182610704FA}"/>
               </a:ext>
             </a:extLst>
           </p:cNvPr>
@@ -10848,7 +10894,7 @@
           <p:cNvPr id="5" name="">
             <a:extLst xmlns:a="http://schemas.openxmlformats.org/drawingml/2006/main">
               <a:ext uri="{FF2B5EF4-FFF2-40B4-BE49-F238E27FC236}">
-                <a16:creationId xmlns:a16="http://schemas.microsoft.com/office/drawing/2014/main" id="{1F593A2B-C119-43A5-9077-0F659995768C}"/>
+                <a16:creationId xmlns:a16="http://schemas.microsoft.com/office/drawing/2014/main" id="{B10F6A49-C397-4C69-AFE9-484EA56301EE}"/>
               </a:ext>
             </a:extLst>
           </p:cNvPr>
@@ -10917,7 +10963,7 @@
           <p:cNvPr id="6" name="">
             <a:extLst xmlns:a="http://schemas.openxmlformats.org/drawingml/2006/main">
               <a:ext uri="{FF2B5EF4-FFF2-40B4-BE49-F238E27FC236}">
-                <a16:creationId xmlns:a16="http://schemas.microsoft.com/office/drawing/2014/main" id="{B78F3675-90FE-4AA6-A3E3-8312027DC2E0}"/>
+                <a16:creationId xmlns:a16="http://schemas.microsoft.com/office/drawing/2014/main" id="{5D91322C-6BD5-4B18-AACB-6B1FB28CA45A}"/>
               </a:ext>
             </a:extLst>
           </p:cNvPr>
@@ -10986,7 +11032,7 @@
           <p:cNvPr id="7" name="">
             <a:extLst xmlns:a="http://schemas.openxmlformats.org/drawingml/2006/main">
               <a:ext uri="{FF2B5EF4-FFF2-40B4-BE49-F238E27FC236}">
-                <a16:creationId xmlns:a16="http://schemas.microsoft.com/office/drawing/2014/main" id="{7CC1E1CB-0E0C-422D-BE61-C07CBFACB2CA}"/>
+                <a16:creationId xmlns:a16="http://schemas.microsoft.com/office/drawing/2014/main" id="{69B787B6-ADF4-4546-93FB-946EA69009C4}"/>
               </a:ext>
             </a:extLst>
           </p:cNvPr>
@@ -11055,7 +11101,7 @@
           <p:cNvPr id="8" name="">
             <a:extLst xmlns:a="http://schemas.openxmlformats.org/drawingml/2006/main">
               <a:ext uri="{FF2B5EF4-FFF2-40B4-BE49-F238E27FC236}">
-                <a16:creationId xmlns:a16="http://schemas.microsoft.com/office/drawing/2014/main" id="{221C3A3E-F9CB-4574-9F8B-80ACAB573EAE}"/>
+                <a16:creationId xmlns:a16="http://schemas.microsoft.com/office/drawing/2014/main" id="{F70526EE-2BF1-4D9B-8B5A-C7D7D1C25924}"/>
               </a:ext>
             </a:extLst>
           </p:cNvPr>
@@ -11124,7 +11170,7 @@
           <p:cNvPr id="9" name="">
             <a:extLst xmlns:a="http://schemas.openxmlformats.org/drawingml/2006/main">
               <a:ext uri="{FF2B5EF4-FFF2-40B4-BE49-F238E27FC236}">
-                <a16:creationId xmlns:a16="http://schemas.microsoft.com/office/drawing/2014/main" id="{4B9669E9-6322-4ABF-A3BA-B67C911EB37F}"/>
+                <a16:creationId xmlns:a16="http://schemas.microsoft.com/office/drawing/2014/main" id="{F2D7551A-1EF7-4C8E-9A17-4596166ACB2D}"/>
               </a:ext>
             </a:extLst>
           </p:cNvPr>
@@ -11157,7 +11203,7 @@
           <p:cNvPr id="10" name="">
             <a:extLst xmlns:a="http://schemas.openxmlformats.org/drawingml/2006/main">
               <a:ext uri="{FF2B5EF4-FFF2-40B4-BE49-F238E27FC236}">
-                <a16:creationId xmlns:a16="http://schemas.microsoft.com/office/drawing/2014/main" id="{B50D0782-76A7-499F-B58F-51588FE8DCCE}"/>
+                <a16:creationId xmlns:a16="http://schemas.microsoft.com/office/drawing/2014/main" id="{BCF647E3-D125-491A-A220-DB9E504382F0}"/>
               </a:ext>
             </a:extLst>
           </p:cNvPr>
@@ -11226,7 +11272,7 @@
           <p:cNvPr id="11" name="">
             <a:extLst xmlns:a="http://schemas.openxmlformats.org/drawingml/2006/main">
               <a:ext uri="{FF2B5EF4-FFF2-40B4-BE49-F238E27FC236}">
-                <a16:creationId xmlns:a16="http://schemas.microsoft.com/office/drawing/2014/main" id="{2D5985DB-B4CC-494E-BF39-9A05AC96D273}"/>
+                <a16:creationId xmlns:a16="http://schemas.microsoft.com/office/drawing/2014/main" id="{DF622202-996B-4114-974F-70F04559C89B}"/>
               </a:ext>
             </a:extLst>
           </p:cNvPr>
@@ -11295,7 +11341,7 @@
           <p:cNvPr id="12" name="">
             <a:extLst xmlns:a="http://schemas.openxmlformats.org/drawingml/2006/main">
               <a:ext uri="{FF2B5EF4-FFF2-40B4-BE49-F238E27FC236}">
-                <a16:creationId xmlns:a16="http://schemas.microsoft.com/office/drawing/2014/main" id="{4388A410-B368-45D3-8092-3853760CA0CC}"/>
+                <a16:creationId xmlns:a16="http://schemas.microsoft.com/office/drawing/2014/main" id="{20BAAAAE-5E8D-49AB-A488-6C09D1094F99}"/>
               </a:ext>
             </a:extLst>
           </p:cNvPr>
@@ -11328,7 +11374,7 @@
           <p:cNvPr id="13" name="">
             <a:extLst xmlns:a="http://schemas.openxmlformats.org/drawingml/2006/main">
               <a:ext uri="{FF2B5EF4-FFF2-40B4-BE49-F238E27FC236}">
-                <a16:creationId xmlns:a16="http://schemas.microsoft.com/office/drawing/2014/main" id="{CE925A10-9E00-4D85-969E-230DA3D11ED0}"/>
+                <a16:creationId xmlns:a16="http://schemas.microsoft.com/office/drawing/2014/main" id="{F90CFA46-F884-45D1-9118-3B408286AFBF}"/>
               </a:ext>
             </a:extLst>
           </p:cNvPr>
@@ -11397,7 +11443,7 @@
           <p:cNvPr id="14" name="">
             <a:extLst xmlns:a="http://schemas.openxmlformats.org/drawingml/2006/main">
               <a:ext uri="{FF2B5EF4-FFF2-40B4-BE49-F238E27FC236}">
-                <a16:creationId xmlns:a16="http://schemas.microsoft.com/office/drawing/2014/main" id="{05B4C86E-E834-4092-8126-7945912E8223}"/>
+                <a16:creationId xmlns:a16="http://schemas.microsoft.com/office/drawing/2014/main" id="{C8DD52EC-3C36-4F70-BCA0-B53B04FFC8DD}"/>
               </a:ext>
             </a:extLst>
           </p:cNvPr>
@@ -11466,7 +11512,7 @@
           <p:cNvPr id="15" name="">
             <a:extLst xmlns:a="http://schemas.openxmlformats.org/drawingml/2006/main">
               <a:ext uri="{FF2B5EF4-FFF2-40B4-BE49-F238E27FC236}">
-                <a16:creationId xmlns:a16="http://schemas.microsoft.com/office/drawing/2014/main" id="{B1AB6F6E-829E-482C-BF54-66534A77761B}"/>
+                <a16:creationId xmlns:a16="http://schemas.microsoft.com/office/drawing/2014/main" id="{FCB3FC61-9B84-42DA-90DA-D072ACD8BC91}"/>
               </a:ext>
             </a:extLst>
           </p:cNvPr>
@@ -11499,7 +11545,7 @@
           <p:cNvPr id="16" name="">
             <a:extLst xmlns:a="http://schemas.openxmlformats.org/drawingml/2006/main">
               <a:ext uri="{FF2B5EF4-FFF2-40B4-BE49-F238E27FC236}">
-                <a16:creationId xmlns:a16="http://schemas.microsoft.com/office/drawing/2014/main" id="{88A114C2-373B-41EE-ADA7-0C756D3865AE}"/>
+                <a16:creationId xmlns:a16="http://schemas.microsoft.com/office/drawing/2014/main" id="{7238A0F4-AFCB-4F63-BF9D-295B7954695B}"/>
               </a:ext>
             </a:extLst>
           </p:cNvPr>
@@ -11568,7 +11614,7 @@
           <p:cNvPr id="17" name="">
             <a:extLst xmlns:a="http://schemas.openxmlformats.org/drawingml/2006/main">
               <a:ext uri="{FF2B5EF4-FFF2-40B4-BE49-F238E27FC236}">
-                <a16:creationId xmlns:a16="http://schemas.microsoft.com/office/drawing/2014/main" id="{E14DCCEA-3FC1-4FCC-B027-B7B9D0BA8399}"/>
+                <a16:creationId xmlns:a16="http://schemas.microsoft.com/office/drawing/2014/main" id="{8DDA1F36-96AB-463D-90E9-2E2CF0614D15}"/>
               </a:ext>
             </a:extLst>
           </p:cNvPr>
@@ -11637,7 +11683,7 @@
           <p:cNvPr id="18" name="">
             <a:extLst xmlns:a="http://schemas.openxmlformats.org/drawingml/2006/main">
               <a:ext uri="{FF2B5EF4-FFF2-40B4-BE49-F238E27FC236}">
-                <a16:creationId xmlns:a16="http://schemas.microsoft.com/office/drawing/2014/main" id="{457DF9E8-D203-4A36-9648-BDEA02DB5552}"/>
+                <a16:creationId xmlns:a16="http://schemas.microsoft.com/office/drawing/2014/main" id="{299760C6-37B1-443F-B0DB-E6F52B0A300F}"/>
               </a:ext>
             </a:extLst>
           </p:cNvPr>
@@ -11706,7 +11752,7 @@
           <p:cNvPr id="19" name="">
             <a:extLst xmlns:a="http://schemas.openxmlformats.org/drawingml/2006/main">
               <a:ext uri="{FF2B5EF4-FFF2-40B4-BE49-F238E27FC236}">
-                <a16:creationId xmlns:a16="http://schemas.microsoft.com/office/drawing/2014/main" id="{04EFEE10-D075-4201-8BF5-794EC33EC554}"/>
+                <a16:creationId xmlns:a16="http://schemas.microsoft.com/office/drawing/2014/main" id="{94992FE2-8887-49B5-B298-6358009192D6}"/>
               </a:ext>
             </a:extLst>
           </p:cNvPr>
@@ -11773,7 +11819,7 @@
     </p:spTree>
     <p:extLst>
       <p:ext uri="{BB962C8B-B14F-4D97-AF65-F5344CB8AC3E}">
-        <p14:creationId xmlns:p14="http://schemas.microsoft.com/office/powerpoint/2010/main" val="651201508"/>
+        <p14:creationId xmlns:p14="http://schemas.microsoft.com/office/powerpoint/2010/main" val="932078162"/>
       </p:ext>
     </p:extLst>
   </p:cSld>
@@ -11804,7 +11850,7 @@
           <p:cNvPr id="9" name="">
             <a:extLst xmlns:a="http://schemas.openxmlformats.org/drawingml/2006/main">
               <a:ext uri="{FF2B5EF4-FFF2-40B4-BE49-F238E27FC236}">
-                <a16:creationId xmlns:a16="http://schemas.microsoft.com/office/drawing/2014/main" id="{03DF9010-6048-4DDD-9310-DABABB68F8D9}"/>
+                <a16:creationId xmlns:a16="http://schemas.microsoft.com/office/drawing/2014/main" id="{3BC24E86-C06B-4FEA-B02A-BD32B1FC8613}"/>
               </a:ext>
             </a:extLst>
           </p:cNvPr>
@@ -11873,7 +11919,7 @@
           <p:cNvPr id="2" name="">
             <a:extLst xmlns:a="http://schemas.openxmlformats.org/drawingml/2006/main">
               <a:ext uri="{FF2B5EF4-FFF2-40B4-BE49-F238E27FC236}">
-                <a16:creationId xmlns:a16="http://schemas.microsoft.com/office/drawing/2014/main" id="{B34A59BF-0C92-480A-9823-67F7E921490A}"/>
+                <a16:creationId xmlns:a16="http://schemas.microsoft.com/office/drawing/2014/main" id="{EDD46234-9531-4FB0-A505-FBB6392EDE95}"/>
               </a:ext>
             </a:extLst>
           </p:cNvPr>
@@ -11942,7 +11988,7 @@
           <p:cNvPr id="3" name="">
             <a:extLst xmlns:a="http://schemas.openxmlformats.org/drawingml/2006/main">
               <a:ext uri="{FF2B5EF4-FFF2-40B4-BE49-F238E27FC236}">
-                <a16:creationId xmlns:a16="http://schemas.microsoft.com/office/drawing/2014/main" id="{A6850821-6D84-44E5-A436-1A2A0F7FE6B6}"/>
+                <a16:creationId xmlns:a16="http://schemas.microsoft.com/office/drawing/2014/main" id="{B0D11A32-062E-46F7-BFD6-BE10EC54B409}"/>
               </a:ext>
             </a:extLst>
           </p:cNvPr>
@@ -12001,7 +12047,7 @@
                 <a:ea typeface="Arial"/>
                 <a:cs typeface="Arial"/>
               </a:rPr>
-              <a:t>Situação registrada antes da publicação no GitHub e da geração do ZIP final</a:t>
+              <a:t>Situação após publicação, execução do pipeline e atualização das evidências</a:t>
             </a:r>
           </a:p>
         </p:txBody>
@@ -12011,7 +12057,7 @@
           <p:cNvPr id="4" name="">
             <a:extLst xmlns:a="http://schemas.openxmlformats.org/drawingml/2006/main">
               <a:ext uri="{FF2B5EF4-FFF2-40B4-BE49-F238E27FC236}">
-                <a16:creationId xmlns:a16="http://schemas.microsoft.com/office/drawing/2014/main" id="{0C45E96B-729F-4930-AD7D-C1DB851E077C}"/>
+                <a16:creationId xmlns:a16="http://schemas.microsoft.com/office/drawing/2014/main" id="{B6932C68-3569-4015-BEC1-A3606647B98D}"/>
               </a:ext>
             </a:extLst>
           </p:cNvPr>
@@ -12044,7 +12090,7 @@
           <p:cNvPr id="5" name="">
             <a:extLst xmlns:a="http://schemas.openxmlformats.org/drawingml/2006/main">
               <a:ext uri="{FF2B5EF4-FFF2-40B4-BE49-F238E27FC236}">
-                <a16:creationId xmlns:a16="http://schemas.microsoft.com/office/drawing/2014/main" id="{FEB99940-7E45-4346-895C-865596592244}"/>
+                <a16:creationId xmlns:a16="http://schemas.microsoft.com/office/drawing/2014/main" id="{82C60DEB-E5A4-42A5-8E14-1AE7F5D38970}"/>
               </a:ext>
             </a:extLst>
           </p:cNvPr>
@@ -12158,13 +12204,13 @@
                       <a:r>
                         <a:rPr sz="1350" b="1">
                           <a:solidFill>
-                            <a:srgbClr val="102235"/>
+                            <a:srgbClr val="187A5A"/>
                           </a:solidFill>
                           <a:latin typeface="Arial"/>
                           <a:ea typeface="Arial"/>
                           <a:cs typeface="Arial"/>
                         </a:rPr>
-                        <a:t>☐</a:t>
+                        <a:t>☑</a:t>
                       </a:r>
                     </a:p>
                   </a:txBody>
@@ -12382,13 +12428,13 @@
                       <a:r>
                         <a:rPr sz="1350" b="1">
                           <a:solidFill>
-                            <a:srgbClr val="102235"/>
+                            <a:srgbClr val="187A5A"/>
                           </a:solidFill>
                           <a:latin typeface="Arial"/>
                           <a:ea typeface="Arial"/>
                           <a:cs typeface="Arial"/>
                         </a:rPr>
-                        <a:t>☐</a:t>
+                        <a:t>☑</a:t>
                       </a:r>
                     </a:p>
                   </a:txBody>
@@ -12438,13 +12484,13 @@
                       <a:r>
                         <a:rPr sz="1350" b="1">
                           <a:solidFill>
-                            <a:srgbClr val="102235"/>
+                            <a:srgbClr val="187A5A"/>
                           </a:solidFill>
                           <a:latin typeface="Arial"/>
                           <a:ea typeface="Arial"/>
                           <a:cs typeface="Arial"/>
                         </a:rPr>
-                        <a:t>☐</a:t>
+                        <a:t>☑</a:t>
                       </a:r>
                     </a:p>
                   </a:txBody>
@@ -12520,7 +12566,7 @@
           <p:cNvPr id="6" name="">
             <a:extLst xmlns:a="http://schemas.openxmlformats.org/drawingml/2006/main">
               <a:ext uri="{FF2B5EF4-FFF2-40B4-BE49-F238E27FC236}">
-                <a16:creationId xmlns:a16="http://schemas.microsoft.com/office/drawing/2014/main" id="{85FF9807-DCB1-4AD3-9D9B-0BA8521A0060}"/>
+                <a16:creationId xmlns:a16="http://schemas.microsoft.com/office/drawing/2014/main" id="{C8F457B8-2BCB-4DBF-8A34-B454ADBB61B9}"/>
               </a:ext>
             </a:extLst>
           </p:cNvPr>
@@ -12551,7 +12597,7 @@
             <a:defPPr algn="ctr">
               <a:defRPr sz="1425" b="1">
                 <a:solidFill>
-                  <a:srgbClr val="EF6A6A"/>
+                  <a:srgbClr val="F4C95D"/>
                 </a:solidFill>
                 <a:latin typeface="Arial"/>
                 <a:ea typeface="Arial"/>
@@ -12563,7 +12609,7 @@
             <a:pPr algn="ctr">
               <a:defRPr sz="1425" b="1">
                 <a:solidFill>
-                  <a:srgbClr val="EF6A6A"/>
+                  <a:srgbClr val="F4C95D"/>
                 </a:solidFill>
                 <a:latin typeface="Arial"/>
                 <a:ea typeface="Arial"/>
@@ -12573,13 +12619,13 @@
             <a:r>
               <a:rPr sz="1425" b="1">
                 <a:solidFill>
-                  <a:srgbClr val="EF6A6A"/>
+                  <a:srgbClr val="F4C95D"/>
                 </a:solidFill>
                 <a:latin typeface="Arial"/>
                 <a:ea typeface="Arial"/>
                 <a:cs typeface="Arial"/>
               </a:rPr>
-              <a:t>Pendências reais: nomes e turma, prints do GitHub Actions e pacote ZIP definitivo.</a:t>
+              <a:t>Antes do envio: preencher os nomes e a turma na capa e no README.</a:t>
             </a:r>
           </a:p>
         </p:txBody>
@@ -12589,7 +12635,7 @@
           <p:cNvPr id="7" name="">
             <a:extLst xmlns:a="http://schemas.openxmlformats.org/drawingml/2006/main">
               <a:ext uri="{FF2B5EF4-FFF2-40B4-BE49-F238E27FC236}">
-                <a16:creationId xmlns:a16="http://schemas.microsoft.com/office/drawing/2014/main" id="{21345155-84EC-45DA-9AE8-318394757AA4}"/>
+                <a16:creationId xmlns:a16="http://schemas.microsoft.com/office/drawing/2014/main" id="{5EC9E890-9461-4B8E-B7D5-8336A7998BA0}"/>
               </a:ext>
             </a:extLst>
           </p:cNvPr>
@@ -12658,7 +12704,7 @@
           <p:cNvPr id="8" name="">
             <a:extLst xmlns:a="http://schemas.openxmlformats.org/drawingml/2006/main">
               <a:ext uri="{FF2B5EF4-FFF2-40B4-BE49-F238E27FC236}">
-                <a16:creationId xmlns:a16="http://schemas.microsoft.com/office/drawing/2014/main" id="{FE5E7E42-E15F-4148-A158-7CAA211D3C03}"/>
+                <a16:creationId xmlns:a16="http://schemas.microsoft.com/office/drawing/2014/main" id="{95824EC5-8390-4FDF-8E9E-39268B1B63B9}"/>
               </a:ext>
             </a:extLst>
           </p:cNvPr>
@@ -12725,7 +12771,7 @@
     </p:spTree>
     <p:extLst>
       <p:ext uri="{BB962C8B-B14F-4D97-AF65-F5344CB8AC3E}">
-        <p14:creationId xmlns:p14="http://schemas.microsoft.com/office/powerpoint/2010/main" val="1798942694"/>
+        <p14:creationId xmlns:p14="http://schemas.microsoft.com/office/powerpoint/2010/main" val="943487516"/>
       </p:ext>
     </p:extLst>
   </p:cSld>

</xml_diff>

<commit_message>
Finaliza dados do integrante e documentação
</commit_message>
<xml_diff>
--- a/documentacao/EcoActions-Documentacao-Tecnica.pptx
+++ b/documentacao/EcoActions-Documentacao-Tecnica.pptx
@@ -2,21 +2,21 @@
 <file path=ppt/presentation.xml><?xml version="1.0" encoding="utf-8"?>
 <p:presentation xmlns:p="http://schemas.openxmlformats.org/presentationml/2006/main">
   <p:sldMasterIdLst>
-    <p:sldMasterId xmlns:r="http://schemas.openxmlformats.org/officeDocument/2006/relationships" id="2147483648" r:id="R66f2ceb4fba9437d"/>
+    <p:sldMasterId xmlns:r="http://schemas.openxmlformats.org/officeDocument/2006/relationships" id="2147483648" r:id="R31d267bb79ba4574"/>
   </p:sldMasterIdLst>
   <p:notesMasterIdLst>
-    <p:notesMasterId xmlns:r="http://schemas.openxmlformats.org/officeDocument/2006/relationships" r:id="R0916ffa5b3cc48b7"/>
+    <p:notesMasterId xmlns:r="http://schemas.openxmlformats.org/officeDocument/2006/relationships" r:id="Rb78743bbef3d4f05"/>
   </p:notesMasterIdLst>
   <p:sldIdLst>
-    <p:sldId xmlns:r="http://schemas.openxmlformats.org/officeDocument/2006/relationships" id="256" r:id="R68d4d6813a134145"/>
-    <p:sldId xmlns:r="http://schemas.openxmlformats.org/officeDocument/2006/relationships" id="257" r:id="R62e64b542cf949ed"/>
-    <p:sldId xmlns:r="http://schemas.openxmlformats.org/officeDocument/2006/relationships" id="258" r:id="Ree87451b27d841d4"/>
-    <p:sldId xmlns:r="http://schemas.openxmlformats.org/officeDocument/2006/relationships" id="259" r:id="R7948cb8ccb844723"/>
-    <p:sldId xmlns:r="http://schemas.openxmlformats.org/officeDocument/2006/relationships" id="260" r:id="Rfc5f04e6ca2f4be0"/>
-    <p:sldId xmlns:r="http://schemas.openxmlformats.org/officeDocument/2006/relationships" id="261" r:id="Rd4a8dcda44e24e89"/>
-    <p:sldId xmlns:r="http://schemas.openxmlformats.org/officeDocument/2006/relationships" id="262" r:id="Rbd006a3c7dfa40e4"/>
-    <p:sldId xmlns:r="http://schemas.openxmlformats.org/officeDocument/2006/relationships" id="263" r:id="Ref04adb46c0f4b2a"/>
-    <p:sldId xmlns:r="http://schemas.openxmlformats.org/officeDocument/2006/relationships" id="264" r:id="Rff2aed8942204374"/>
+    <p:sldId xmlns:r="http://schemas.openxmlformats.org/officeDocument/2006/relationships" id="256" r:id="Rb37563728c1d43db"/>
+    <p:sldId xmlns:r="http://schemas.openxmlformats.org/officeDocument/2006/relationships" id="257" r:id="Rc462099a3ef6471f"/>
+    <p:sldId xmlns:r="http://schemas.openxmlformats.org/officeDocument/2006/relationships" id="258" r:id="R5dc4d2d580564b3e"/>
+    <p:sldId xmlns:r="http://schemas.openxmlformats.org/officeDocument/2006/relationships" id="259" r:id="R1e634df4389048bc"/>
+    <p:sldId xmlns:r="http://schemas.openxmlformats.org/officeDocument/2006/relationships" id="260" r:id="R13fa8bbd81c94366"/>
+    <p:sldId xmlns:r="http://schemas.openxmlformats.org/officeDocument/2006/relationships" id="261" r:id="R22a61129a3c44a29"/>
+    <p:sldId xmlns:r="http://schemas.openxmlformats.org/officeDocument/2006/relationships" id="262" r:id="Rad7a4b7051e04c8c"/>
+    <p:sldId xmlns:r="http://schemas.openxmlformats.org/officeDocument/2006/relationships" id="263" r:id="R04c6bb434dc644e8"/>
+    <p:sldId xmlns:r="http://schemas.openxmlformats.org/officeDocument/2006/relationships" id="264" r:id="R00cb43eeef684744"/>
   </p:sldIdLst>
   <p:sldSz cx="12192000" cy="6858000"/>
   <p:notesSz cx="6858000" cy="9144000"/>
@@ -1021,7 +1021,7 @@
           <p:cNvPr id="3" name="Title">
             <a:extLst xmlns:a="http://schemas.openxmlformats.org/drawingml/2006/main">
               <a:ext uri="{FF2B5EF4-FFF2-40B4-BE49-F238E27FC236}">
-                <a16:creationId xmlns:a16="http://schemas.microsoft.com/office/drawing/2014/main" id="{33C62055-0114-4E63-A698-0A20BB1663EC}"/>
+                <a16:creationId xmlns:a16="http://schemas.microsoft.com/office/drawing/2014/main" id="{133AB64E-2C66-490A-9578-2DFE1E0ACEFA}"/>
               </a:ext>
             </a:extLst>
           </p:cNvPr>
@@ -1178,7 +1178,7 @@
           <p:cNvPr id="2" name="Subtitle">
             <a:extLst xmlns:a="http://schemas.openxmlformats.org/drawingml/2006/main">
               <a:ext uri="{FF2B5EF4-FFF2-40B4-BE49-F238E27FC236}">
-                <a16:creationId xmlns:a16="http://schemas.microsoft.com/office/drawing/2014/main" id="{53B23E61-B672-4FBE-B90A-A7A0BFC080A2}"/>
+                <a16:creationId xmlns:a16="http://schemas.microsoft.com/office/drawing/2014/main" id="{0E22D0E2-9C09-459C-B003-4E75EE8CF7E3}"/>
               </a:ext>
             </a:extLst>
           </p:cNvPr>
@@ -1352,7 +1352,7 @@
           <p:cNvPr id="2" name="Section title">
             <a:extLst xmlns:a="http://schemas.openxmlformats.org/drawingml/2006/main">
               <a:ext uri="{FF2B5EF4-FFF2-40B4-BE49-F238E27FC236}">
-                <a16:creationId xmlns:a16="http://schemas.microsoft.com/office/drawing/2014/main" id="{44531D24-DA29-44A3-B5E8-67874755B8E7}"/>
+                <a16:creationId xmlns:a16="http://schemas.microsoft.com/office/drawing/2014/main" id="{499CB5AE-A589-4B89-B079-854D53F3156F}"/>
               </a:ext>
             </a:extLst>
           </p:cNvPr>
@@ -1526,7 +1526,7 @@
           <p:cNvPr id="3" name="Title">
             <a:extLst xmlns:a="http://schemas.openxmlformats.org/drawingml/2006/main">
               <a:ext uri="{FF2B5EF4-FFF2-40B4-BE49-F238E27FC236}">
-                <a16:creationId xmlns:a16="http://schemas.microsoft.com/office/drawing/2014/main" id="{76E3ACBC-B2F8-4BA8-87F1-514C88B39595}"/>
+                <a16:creationId xmlns:a16="http://schemas.microsoft.com/office/drawing/2014/main" id="{B490ACC4-14E2-4C9F-8928-E8F5B17F0E75}"/>
               </a:ext>
             </a:extLst>
           </p:cNvPr>
@@ -1683,7 +1683,7 @@
           <p:cNvPr id="2" name="Body">
             <a:extLst xmlns:a="http://schemas.openxmlformats.org/drawingml/2006/main">
               <a:ext uri="{FF2B5EF4-FFF2-40B4-BE49-F238E27FC236}">
-                <a16:creationId xmlns:a16="http://schemas.microsoft.com/office/drawing/2014/main" id="{991D9D06-D4B8-4F7F-ACA6-F18D76658AAF}"/>
+                <a16:creationId xmlns:a16="http://schemas.microsoft.com/office/drawing/2014/main" id="{D11EEA15-857B-4B2F-9728-13C683219903}"/>
               </a:ext>
             </a:extLst>
           </p:cNvPr>
@@ -1857,7 +1857,7 @@
           <p:cNvPr id="4" name="Title">
             <a:extLst xmlns:a="http://schemas.openxmlformats.org/drawingml/2006/main">
               <a:ext uri="{FF2B5EF4-FFF2-40B4-BE49-F238E27FC236}">
-                <a16:creationId xmlns:a16="http://schemas.microsoft.com/office/drawing/2014/main" id="{F0BAF612-8163-4D12-9B4B-3A460A9B0644}"/>
+                <a16:creationId xmlns:a16="http://schemas.microsoft.com/office/drawing/2014/main" id="{4EE4D24F-8C1D-4D3C-B981-022CE95B5995}"/>
               </a:ext>
             </a:extLst>
           </p:cNvPr>
@@ -2014,7 +2014,7 @@
           <p:cNvPr id="2" name="Left column">
             <a:extLst xmlns:a="http://schemas.openxmlformats.org/drawingml/2006/main">
               <a:ext uri="{FF2B5EF4-FFF2-40B4-BE49-F238E27FC236}">
-                <a16:creationId xmlns:a16="http://schemas.microsoft.com/office/drawing/2014/main" id="{E245B38E-74B3-4175-8A81-F9971F5002B7}"/>
+                <a16:creationId xmlns:a16="http://schemas.microsoft.com/office/drawing/2014/main" id="{909C5C1C-BE6C-4BF2-A91C-F407BE313A4D}"/>
               </a:ext>
             </a:extLst>
           </p:cNvPr>
@@ -2171,7 +2171,7 @@
           <p:cNvPr id="3" name="Right column">
             <a:extLst xmlns:a="http://schemas.openxmlformats.org/drawingml/2006/main">
               <a:ext uri="{FF2B5EF4-FFF2-40B4-BE49-F238E27FC236}">
-                <a16:creationId xmlns:a16="http://schemas.microsoft.com/office/drawing/2014/main" id="{0FB6ECBA-624A-49B7-8457-E43EEBB4885A}"/>
+                <a16:creationId xmlns:a16="http://schemas.microsoft.com/office/drawing/2014/main" id="{82AC10A6-C3CD-4662-9B51-C31D8AC50AD3}"/>
               </a:ext>
             </a:extLst>
           </p:cNvPr>
@@ -2345,7 +2345,7 @@
           <p:cNvPr id="3" name="Title">
             <a:extLst xmlns:a="http://schemas.openxmlformats.org/drawingml/2006/main">
               <a:ext uri="{FF2B5EF4-FFF2-40B4-BE49-F238E27FC236}">
-                <a16:creationId xmlns:a16="http://schemas.microsoft.com/office/drawing/2014/main" id="{6FF57BE7-92E2-46F4-9676-793C36A2FB08}"/>
+                <a16:creationId xmlns:a16="http://schemas.microsoft.com/office/drawing/2014/main" id="{2F8DB231-4DFC-40F0-AA63-55D3F1F798EB}"/>
               </a:ext>
             </a:extLst>
           </p:cNvPr>
@@ -2502,7 +2502,7 @@
           <p:cNvPr id="2" name="Left column">
             <a:extLst xmlns:a="http://schemas.openxmlformats.org/drawingml/2006/main">
               <a:ext uri="{FF2B5EF4-FFF2-40B4-BE49-F238E27FC236}">
-                <a16:creationId xmlns:a16="http://schemas.microsoft.com/office/drawing/2014/main" id="{DB8042FF-ABD7-4B15-8F52-6A1C8E7C7769}"/>
+                <a16:creationId xmlns:a16="http://schemas.microsoft.com/office/drawing/2014/main" id="{5DC429B8-DAC6-486C-9D0C-76A811D95283}"/>
               </a:ext>
             </a:extLst>
           </p:cNvPr>
@@ -2697,12 +2697,12 @@
   </p:cSld>
   <p:clrMap bg1="lt1" tx1="dk1" bg2="lt2" tx2="dk2" accent1="accent1" accent2="accent2" accent3="accent3" accent4="accent4" accent5="accent5" accent6="accent6" hlink="hlink" folHlink="folHlink"/>
   <p:sldLayoutIdLst>
-    <p:sldLayoutId xmlns:r="http://schemas.openxmlformats.org/officeDocument/2006/relationships" id="2147483649" r:id="Rab7196e254404550"/>
-    <p:sldLayoutId xmlns:r="http://schemas.openxmlformats.org/officeDocument/2006/relationships" id="2147483650" r:id="Rfac16ee7d6814a43"/>
-    <p:sldLayoutId xmlns:r="http://schemas.openxmlformats.org/officeDocument/2006/relationships" id="2147483651" r:id="Rd3cc563ee5db4da0"/>
-    <p:sldLayoutId xmlns:r="http://schemas.openxmlformats.org/officeDocument/2006/relationships" id="2147483652" r:id="R22c562db4b5548b3"/>
-    <p:sldLayoutId xmlns:r="http://schemas.openxmlformats.org/officeDocument/2006/relationships" id="2147483653" r:id="R5f4681634dda4c7a"/>
-    <p:sldLayoutId xmlns:r="http://schemas.openxmlformats.org/officeDocument/2006/relationships" id="2147483654" r:id="Rd02a164f28454679"/>
+    <p:sldLayoutId xmlns:r="http://schemas.openxmlformats.org/officeDocument/2006/relationships" id="2147483649" r:id="R9cb3dd1905cc45ae"/>
+    <p:sldLayoutId xmlns:r="http://schemas.openxmlformats.org/officeDocument/2006/relationships" id="2147483650" r:id="R8bc706b590d24d6e"/>
+    <p:sldLayoutId xmlns:r="http://schemas.openxmlformats.org/officeDocument/2006/relationships" id="2147483651" r:id="R87b09fd1e2614631"/>
+    <p:sldLayoutId xmlns:r="http://schemas.openxmlformats.org/officeDocument/2006/relationships" id="2147483652" r:id="R4c6c9d57e8774440"/>
+    <p:sldLayoutId xmlns:r="http://schemas.openxmlformats.org/officeDocument/2006/relationships" id="2147483653" r:id="R2c599f7665414914"/>
+    <p:sldLayoutId xmlns:r="http://schemas.openxmlformats.org/officeDocument/2006/relationships" id="2147483654" r:id="R75aa453512ec461e"/>
   </p:sldLayoutIdLst>
   <p:txStyles>
     <p:titleStyle>
@@ -3253,7 +3253,7 @@
           <p:cNvPr id="8" name="">
             <a:extLst xmlns:a="http://schemas.openxmlformats.org/drawingml/2006/main">
               <a:ext uri="{FF2B5EF4-FFF2-40B4-BE49-F238E27FC236}">
-                <a16:creationId xmlns:a16="http://schemas.microsoft.com/office/drawing/2014/main" id="{DE6D3457-6EDB-41C8-80E7-6C10C2665817}"/>
+                <a16:creationId xmlns:a16="http://schemas.microsoft.com/office/drawing/2014/main" id="{250CBB65-9CD2-4719-909C-6F590A776AE3}"/>
               </a:ext>
             </a:extLst>
           </p:cNvPr>
@@ -3263,7 +3263,7 @@
           <p:nvPr/>
         </p:nvPicPr>
         <p:blipFill>
-          <a:blip xmlns:r="http://schemas.openxmlformats.org/officeDocument/2006/relationships" xmlns:a="http://schemas.openxmlformats.org/drawingml/2006/main" r:embed="Rad7bcaf693c34a62"/>
+          <a:blip xmlns:r="http://schemas.openxmlformats.org/officeDocument/2006/relationships" xmlns:a="http://schemas.openxmlformats.org/drawingml/2006/main" r:embed="Re4aa7233faef4f21"/>
           <a:srcRect xmlns:a="http://schemas.openxmlformats.org/drawingml/2006/main" l="0" t="27" r="0" b="27"/>
           <a:stretch xmlns:a="http://schemas.openxmlformats.org/drawingml/2006/main">
             <a:fillRect l="0" t="0" r="0" b="0"/>
@@ -3284,7 +3284,7 @@
           <p:cNvPr id="2" name="">
             <a:extLst xmlns:a="http://schemas.openxmlformats.org/drawingml/2006/main">
               <a:ext uri="{FF2B5EF4-FFF2-40B4-BE49-F238E27FC236}">
-                <a16:creationId xmlns:a16="http://schemas.microsoft.com/office/drawing/2014/main" id="{83B0372D-E224-46EC-BA55-83DC0595815C}"/>
+                <a16:creationId xmlns:a16="http://schemas.microsoft.com/office/drawing/2014/main" id="{B2EF3CBA-4224-494C-A30D-203B34EF26A3}"/>
               </a:ext>
             </a:extLst>
           </p:cNvPr>
@@ -3353,7 +3353,7 @@
           <p:cNvPr id="3" name="">
             <a:extLst xmlns:a="http://schemas.openxmlformats.org/drawingml/2006/main">
               <a:ext uri="{FF2B5EF4-FFF2-40B4-BE49-F238E27FC236}">
-                <a16:creationId xmlns:a16="http://schemas.microsoft.com/office/drawing/2014/main" id="{0FE1125B-0886-40D7-BC40-E86E032A6937}"/>
+                <a16:creationId xmlns:a16="http://schemas.microsoft.com/office/drawing/2014/main" id="{97EDA885-E6CD-4994-82A2-590E8EA31764}"/>
               </a:ext>
             </a:extLst>
           </p:cNvPr>
@@ -3422,7 +3422,7 @@
           <p:cNvPr id="4" name="">
             <a:extLst xmlns:a="http://schemas.openxmlformats.org/drawingml/2006/main">
               <a:ext uri="{FF2B5EF4-FFF2-40B4-BE49-F238E27FC236}">
-                <a16:creationId xmlns:a16="http://schemas.microsoft.com/office/drawing/2014/main" id="{F57FB64C-B41E-4372-B5D4-DF17A8C207D3}"/>
+                <a16:creationId xmlns:a16="http://schemas.microsoft.com/office/drawing/2014/main" id="{7F4B85DB-1F5A-4B33-AD17-FD929458725E}"/>
               </a:ext>
             </a:extLst>
           </p:cNvPr>
@@ -3491,7 +3491,7 @@
           <p:cNvPr id="5" name="">
             <a:extLst xmlns:a="http://schemas.openxmlformats.org/drawingml/2006/main">
               <a:ext uri="{FF2B5EF4-FFF2-40B4-BE49-F238E27FC236}">
-                <a16:creationId xmlns:a16="http://schemas.microsoft.com/office/drawing/2014/main" id="{42C078E0-F4D4-4391-936A-CE9FBC8928ED}"/>
+                <a16:creationId xmlns:a16="http://schemas.microsoft.com/office/drawing/2014/main" id="{F561470F-2604-40FD-AF46-1F81780036D4}"/>
               </a:ext>
             </a:extLst>
           </p:cNvPr>
@@ -3524,7 +3524,7 @@
           <p:cNvPr id="6" name="">
             <a:extLst xmlns:a="http://schemas.openxmlformats.org/drawingml/2006/main">
               <a:ext uri="{FF2B5EF4-FFF2-40B4-BE49-F238E27FC236}">
-                <a16:creationId xmlns:a16="http://schemas.microsoft.com/office/drawing/2014/main" id="{DC457E2D-70A7-4199-82C7-A2FBCCCE22FD}"/>
+                <a16:creationId xmlns:a16="http://schemas.microsoft.com/office/drawing/2014/main" id="{9AF1ED30-BD22-4822-96D1-59B685F5DDCD}"/>
               </a:ext>
             </a:extLst>
           </p:cNvPr>
@@ -3536,7 +3536,7 @@
         <p:spPr>
           <a:xfrm xmlns:a="http://schemas.openxmlformats.org/drawingml/2006/main">
             <a:off x="685800" y="4953000"/>
-            <a:ext cx="4953000" cy="685800"/>
+            <a:ext cx="5715000" cy="685800"/>
           </a:xfrm>
           <a:prstGeom xmlns:a="http://schemas.openxmlformats.org/drawingml/2006/main" prst="rect">
             <a:avLst/>
@@ -3555,7 +3555,7 @@
             <a:defPPr algn="l">
               <a:defRPr sz="1275" b="1">
                 <a:solidFill>
-                  <a:srgbClr val="F4C95D"/>
+                  <a:srgbClr val="FFFFFF"/>
                 </a:solidFill>
                 <a:latin typeface="Arial"/>
                 <a:ea typeface="Arial"/>
@@ -3567,7 +3567,7 @@
             <a:pPr algn="l">
               <a:defRPr sz="1275" b="1">
                 <a:solidFill>
-                  <a:srgbClr val="F4C95D"/>
+                  <a:srgbClr val="FFFFFF"/>
                 </a:solidFill>
                 <a:latin typeface="Arial"/>
                 <a:ea typeface="Arial"/>
@@ -3577,20 +3577,20 @@
             <a:r>
               <a:rPr sz="1275" b="1">
                 <a:solidFill>
-                  <a:srgbClr val="F4C95D"/>
+                  <a:srgbClr val="FFFFFF"/>
                 </a:solidFill>
                 <a:latin typeface="Arial"/>
                 <a:ea typeface="Arial"/>
                 <a:cs typeface="Arial"/>
               </a:rPr>
-              <a:t>Integrante(s): NOME(S) E RM(S)</a:t>
+              <a:t>Integrante: Gabriel Elias Lopes de Morais</a:t>
             </a:r>
           </a:p>
           <a:p xmlns:a="http://schemas.openxmlformats.org/drawingml/2006/main">
             <a:pPr algn="l">
               <a:defRPr sz="1275" b="1">
                 <a:solidFill>
-                  <a:srgbClr val="F4C95D"/>
+                  <a:srgbClr val="FFFFFF"/>
                 </a:solidFill>
                 <a:latin typeface="Arial"/>
                 <a:ea typeface="Arial"/>
@@ -3600,13 +3600,13 @@
             <a:r>
               <a:rPr sz="1275" b="1">
                 <a:solidFill>
-                  <a:srgbClr val="F4C95D"/>
+                  <a:srgbClr val="FFFFFF"/>
                 </a:solidFill>
                 <a:latin typeface="Arial"/>
                 <a:ea typeface="Arial"/>
                 <a:cs typeface="Arial"/>
               </a:rPr>
-              <a:t>Turma: PREENCHER ANTES DA ENTREGA</a:t>
+              <a:t>RM 566281 | Turma 2TDSOD</a:t>
             </a:r>
           </a:p>
         </p:txBody>
@@ -3616,7 +3616,7 @@
           <p:cNvPr id="7" name="">
             <a:extLst xmlns:a="http://schemas.openxmlformats.org/drawingml/2006/main">
               <a:ext uri="{FF2B5EF4-FFF2-40B4-BE49-F238E27FC236}">
-                <a16:creationId xmlns:a16="http://schemas.microsoft.com/office/drawing/2014/main" id="{AC60831A-DDC2-4AC7-A829-CEBCD09DD127}"/>
+                <a16:creationId xmlns:a16="http://schemas.microsoft.com/office/drawing/2014/main" id="{89ECA4AA-8312-4EC7-9973-BDE8745776CB}"/>
               </a:ext>
             </a:extLst>
           </p:cNvPr>
@@ -3683,7 +3683,7 @@
     </p:spTree>
     <p:extLst>
       <p:ext uri="{BB962C8B-B14F-4D97-AF65-F5344CB8AC3E}">
-        <p14:creationId xmlns:p14="http://schemas.microsoft.com/office/powerpoint/2010/main" val="1035066233"/>
+        <p14:creationId xmlns:p14="http://schemas.microsoft.com/office/powerpoint/2010/main" val="628431905"/>
       </p:ext>
     </p:extLst>
   </p:cSld>
@@ -3714,7 +3714,7 @@
           <p:cNvPr id="24" name="">
             <a:extLst xmlns:a="http://schemas.openxmlformats.org/drawingml/2006/main">
               <a:ext uri="{FF2B5EF4-FFF2-40B4-BE49-F238E27FC236}">
-                <a16:creationId xmlns:a16="http://schemas.microsoft.com/office/drawing/2014/main" id="{70D0751E-7583-4780-A9DA-1464DA1B9009}"/>
+                <a16:creationId xmlns:a16="http://schemas.microsoft.com/office/drawing/2014/main" id="{1A227291-13A3-45A6-A9D6-430CA25B71E4}"/>
               </a:ext>
             </a:extLst>
           </p:cNvPr>
@@ -3783,7 +3783,7 @@
           <p:cNvPr id="2" name="">
             <a:extLst xmlns:a="http://schemas.openxmlformats.org/drawingml/2006/main">
               <a:ext uri="{FF2B5EF4-FFF2-40B4-BE49-F238E27FC236}">
-                <a16:creationId xmlns:a16="http://schemas.microsoft.com/office/drawing/2014/main" id="{BB76DB73-A989-49BA-821A-4F0AF2E6FFCE}"/>
+                <a16:creationId xmlns:a16="http://schemas.microsoft.com/office/drawing/2014/main" id="{1DD648A8-3576-4A24-8777-873FE6F069A4}"/>
               </a:ext>
             </a:extLst>
           </p:cNvPr>
@@ -3852,7 +3852,7 @@
           <p:cNvPr id="3" name="">
             <a:extLst xmlns:a="http://schemas.openxmlformats.org/drawingml/2006/main">
               <a:ext uri="{FF2B5EF4-FFF2-40B4-BE49-F238E27FC236}">
-                <a16:creationId xmlns:a16="http://schemas.microsoft.com/office/drawing/2014/main" id="{5B1CE859-EE05-4D01-82F2-C7B9504E7628}"/>
+                <a16:creationId xmlns:a16="http://schemas.microsoft.com/office/drawing/2014/main" id="{BCC65C15-2E26-4F66-A835-C8CC0C93766B}"/>
               </a:ext>
             </a:extLst>
           </p:cNvPr>
@@ -3921,7 +3921,7 @@
           <p:cNvPr id="4" name="">
             <a:extLst xmlns:a="http://schemas.openxmlformats.org/drawingml/2006/main">
               <a:ext uri="{FF2B5EF4-FFF2-40B4-BE49-F238E27FC236}">
-                <a16:creationId xmlns:a16="http://schemas.microsoft.com/office/drawing/2014/main" id="{E1D0ABA5-4D88-423F-9409-7773E08BE1BE}"/>
+                <a16:creationId xmlns:a16="http://schemas.microsoft.com/office/drawing/2014/main" id="{08126E90-A2D0-4BD2-883A-5D6353ECC46C}"/>
               </a:ext>
             </a:extLst>
           </p:cNvPr>
@@ -3954,7 +3954,7 @@
           <p:cNvPr id="5" name="">
             <a:extLst xmlns:a="http://schemas.openxmlformats.org/drawingml/2006/main">
               <a:ext uri="{FF2B5EF4-FFF2-40B4-BE49-F238E27FC236}">
-                <a16:creationId xmlns:a16="http://schemas.microsoft.com/office/drawing/2014/main" id="{0BFBD9D8-9C86-4F80-9E04-8089A7B0E88B}"/>
+                <a16:creationId xmlns:a16="http://schemas.microsoft.com/office/drawing/2014/main" id="{1CB849D4-DE6B-44FB-891E-AF43CFF62572}"/>
               </a:ext>
             </a:extLst>
           </p:cNvPr>
@@ -4023,7 +4023,7 @@
           <p:cNvPr id="6" name="">
             <a:extLst xmlns:a="http://schemas.openxmlformats.org/drawingml/2006/main">
               <a:ext uri="{FF2B5EF4-FFF2-40B4-BE49-F238E27FC236}">
-                <a16:creationId xmlns:a16="http://schemas.microsoft.com/office/drawing/2014/main" id="{B25316CE-8275-4371-ABCE-89FB3A8D29D4}"/>
+                <a16:creationId xmlns:a16="http://schemas.microsoft.com/office/drawing/2014/main" id="{5ADF888C-34D8-4C01-AC99-B81832656367}"/>
               </a:ext>
             </a:extLst>
           </p:cNvPr>
@@ -4092,7 +4092,7 @@
           <p:cNvPr id="7" name="">
             <a:extLst xmlns:a="http://schemas.openxmlformats.org/drawingml/2006/main">
               <a:ext uri="{FF2B5EF4-FFF2-40B4-BE49-F238E27FC236}">
-                <a16:creationId xmlns:a16="http://schemas.microsoft.com/office/drawing/2014/main" id="{D464D553-1C44-440C-B202-421C3A191919}"/>
+                <a16:creationId xmlns:a16="http://schemas.microsoft.com/office/drawing/2014/main" id="{D0FDE869-2778-41BD-8456-E80A3022B790}"/>
               </a:ext>
             </a:extLst>
           </p:cNvPr>
@@ -4127,7 +4127,7 @@
           <p:cNvPr id="8" name="">
             <a:extLst xmlns:a="http://schemas.openxmlformats.org/drawingml/2006/main">
               <a:ext uri="{FF2B5EF4-FFF2-40B4-BE49-F238E27FC236}">
-                <a16:creationId xmlns:a16="http://schemas.microsoft.com/office/drawing/2014/main" id="{B6A7C350-F59E-401B-8E86-0AAE77DC7C5C}"/>
+                <a16:creationId xmlns:a16="http://schemas.microsoft.com/office/drawing/2014/main" id="{3D55E14F-BB34-4C64-A018-EC22827F6D2C}"/>
               </a:ext>
             </a:extLst>
           </p:cNvPr>
@@ -4196,7 +4196,7 @@
           <p:cNvPr id="9" name="">
             <a:extLst xmlns:a="http://schemas.openxmlformats.org/drawingml/2006/main">
               <a:ext uri="{FF2B5EF4-FFF2-40B4-BE49-F238E27FC236}">
-                <a16:creationId xmlns:a16="http://schemas.microsoft.com/office/drawing/2014/main" id="{26AD7EDD-927F-4B46-8DCE-1DF6240B0459}"/>
+                <a16:creationId xmlns:a16="http://schemas.microsoft.com/office/drawing/2014/main" id="{991AAAD7-4E3E-4BE9-B818-8353FD4BDA03}"/>
               </a:ext>
             </a:extLst>
           </p:cNvPr>
@@ -4265,7 +4265,7 @@
           <p:cNvPr id="10" name="">
             <a:extLst xmlns:a="http://schemas.openxmlformats.org/drawingml/2006/main">
               <a:ext uri="{FF2B5EF4-FFF2-40B4-BE49-F238E27FC236}">
-                <a16:creationId xmlns:a16="http://schemas.microsoft.com/office/drawing/2014/main" id="{924A4917-0CCB-41D0-A8F0-77E728FCBD29}"/>
+                <a16:creationId xmlns:a16="http://schemas.microsoft.com/office/drawing/2014/main" id="{7BBD86C3-840F-4435-870A-4E3DC120B4D6}"/>
               </a:ext>
             </a:extLst>
           </p:cNvPr>
@@ -4300,7 +4300,7 @@
           <p:cNvPr id="11" name="">
             <a:extLst xmlns:a="http://schemas.openxmlformats.org/drawingml/2006/main">
               <a:ext uri="{FF2B5EF4-FFF2-40B4-BE49-F238E27FC236}">
-                <a16:creationId xmlns:a16="http://schemas.microsoft.com/office/drawing/2014/main" id="{C9628461-05F1-4F81-A839-29DD3F501811}"/>
+                <a16:creationId xmlns:a16="http://schemas.microsoft.com/office/drawing/2014/main" id="{59951294-AA42-40A4-AF78-C93074E7F413}"/>
               </a:ext>
             </a:extLst>
           </p:cNvPr>
@@ -4369,7 +4369,7 @@
           <p:cNvPr id="12" name="">
             <a:extLst xmlns:a="http://schemas.openxmlformats.org/drawingml/2006/main">
               <a:ext uri="{FF2B5EF4-FFF2-40B4-BE49-F238E27FC236}">
-                <a16:creationId xmlns:a16="http://schemas.microsoft.com/office/drawing/2014/main" id="{58C21778-0E85-4220-8CAE-831B91895577}"/>
+                <a16:creationId xmlns:a16="http://schemas.microsoft.com/office/drawing/2014/main" id="{53AE4918-2B8E-45B2-84E8-665EAFB92C91}"/>
               </a:ext>
             </a:extLst>
           </p:cNvPr>
@@ -4461,7 +4461,7 @@
           <p:cNvPr id="13" name="">
             <a:extLst xmlns:a="http://schemas.openxmlformats.org/drawingml/2006/main">
               <a:ext uri="{FF2B5EF4-FFF2-40B4-BE49-F238E27FC236}">
-                <a16:creationId xmlns:a16="http://schemas.microsoft.com/office/drawing/2014/main" id="{0D6F1592-CC34-49BB-8D14-296E9B3EDA1B}"/>
+                <a16:creationId xmlns:a16="http://schemas.microsoft.com/office/drawing/2014/main" id="{9D0EC8B9-4D60-4DF5-B89E-A5366E7BCE46}"/>
               </a:ext>
             </a:extLst>
           </p:cNvPr>
@@ -4496,7 +4496,7 @@
           <p:cNvPr id="14" name="">
             <a:extLst xmlns:a="http://schemas.openxmlformats.org/drawingml/2006/main">
               <a:ext uri="{FF2B5EF4-FFF2-40B4-BE49-F238E27FC236}">
-                <a16:creationId xmlns:a16="http://schemas.microsoft.com/office/drawing/2014/main" id="{26642A2C-2DBC-454F-9D56-2E6F236673D6}"/>
+                <a16:creationId xmlns:a16="http://schemas.microsoft.com/office/drawing/2014/main" id="{17DF88E5-D019-4077-A2EB-158F09D0A3DC}"/>
               </a:ext>
             </a:extLst>
           </p:cNvPr>
@@ -4565,7 +4565,7 @@
           <p:cNvPr id="15" name="">
             <a:extLst xmlns:a="http://schemas.openxmlformats.org/drawingml/2006/main">
               <a:ext uri="{FF2B5EF4-FFF2-40B4-BE49-F238E27FC236}">
-                <a16:creationId xmlns:a16="http://schemas.microsoft.com/office/drawing/2014/main" id="{4DBA9669-3EF1-4077-A838-7E62CFE47809}"/>
+                <a16:creationId xmlns:a16="http://schemas.microsoft.com/office/drawing/2014/main" id="{9A9C05A0-3C8D-4A5D-8203-A064282F01EC}"/>
               </a:ext>
             </a:extLst>
           </p:cNvPr>
@@ -4634,7 +4634,7 @@
           <p:cNvPr id="16" name="">
             <a:extLst xmlns:a="http://schemas.openxmlformats.org/drawingml/2006/main">
               <a:ext uri="{FF2B5EF4-FFF2-40B4-BE49-F238E27FC236}">
-                <a16:creationId xmlns:a16="http://schemas.microsoft.com/office/drawing/2014/main" id="{5DB9EE99-A873-454F-B70E-14594D7511AC}"/>
+                <a16:creationId xmlns:a16="http://schemas.microsoft.com/office/drawing/2014/main" id="{76C82360-BFA8-4682-9816-85D4E5ED27EB}"/>
               </a:ext>
             </a:extLst>
           </p:cNvPr>
@@ -4669,7 +4669,7 @@
           <p:cNvPr id="17" name="">
             <a:extLst xmlns:a="http://schemas.openxmlformats.org/drawingml/2006/main">
               <a:ext uri="{FF2B5EF4-FFF2-40B4-BE49-F238E27FC236}">
-                <a16:creationId xmlns:a16="http://schemas.microsoft.com/office/drawing/2014/main" id="{C051D11B-42DD-420F-8E29-12D1160D3199}"/>
+                <a16:creationId xmlns:a16="http://schemas.microsoft.com/office/drawing/2014/main" id="{05EC2A85-18D7-44A1-8B39-93403A110CB6}"/>
               </a:ext>
             </a:extLst>
           </p:cNvPr>
@@ -4738,7 +4738,7 @@
           <p:cNvPr id="18" name="">
             <a:extLst xmlns:a="http://schemas.openxmlformats.org/drawingml/2006/main">
               <a:ext uri="{FF2B5EF4-FFF2-40B4-BE49-F238E27FC236}">
-                <a16:creationId xmlns:a16="http://schemas.microsoft.com/office/drawing/2014/main" id="{8FCF6776-81BF-4CFE-AE07-369B29E1B719}"/>
+                <a16:creationId xmlns:a16="http://schemas.microsoft.com/office/drawing/2014/main" id="{9C037E04-E1D7-4938-A056-3B08AFE70039}"/>
               </a:ext>
             </a:extLst>
           </p:cNvPr>
@@ -4807,7 +4807,7 @@
           <p:cNvPr id="19" name="">
             <a:extLst xmlns:a="http://schemas.openxmlformats.org/drawingml/2006/main">
               <a:ext uri="{FF2B5EF4-FFF2-40B4-BE49-F238E27FC236}">
-                <a16:creationId xmlns:a16="http://schemas.microsoft.com/office/drawing/2014/main" id="{8CAD27B8-6D4F-4619-8044-1413DF0AD556}"/>
+                <a16:creationId xmlns:a16="http://schemas.microsoft.com/office/drawing/2014/main" id="{931E6530-0AEA-4166-9B3C-82DB14B22732}"/>
               </a:ext>
             </a:extLst>
           </p:cNvPr>
@@ -4842,7 +4842,7 @@
           <p:cNvPr id="20" name="">
             <a:extLst xmlns:a="http://schemas.openxmlformats.org/drawingml/2006/main">
               <a:ext uri="{FF2B5EF4-FFF2-40B4-BE49-F238E27FC236}">
-                <a16:creationId xmlns:a16="http://schemas.microsoft.com/office/drawing/2014/main" id="{08F8F580-BC67-4588-9000-B74B700FF875}"/>
+                <a16:creationId xmlns:a16="http://schemas.microsoft.com/office/drawing/2014/main" id="{3464C111-88F2-41B0-A4DE-834C53C952F6}"/>
               </a:ext>
             </a:extLst>
           </p:cNvPr>
@@ -4911,7 +4911,7 @@
           <p:cNvPr id="21" name="">
             <a:extLst xmlns:a="http://schemas.openxmlformats.org/drawingml/2006/main">
               <a:ext uri="{FF2B5EF4-FFF2-40B4-BE49-F238E27FC236}">
-                <a16:creationId xmlns:a16="http://schemas.microsoft.com/office/drawing/2014/main" id="{CFBAC044-BAF6-4F1B-811A-E5B6758D046C}"/>
+                <a16:creationId xmlns:a16="http://schemas.microsoft.com/office/drawing/2014/main" id="{8BE82E9C-105B-428E-A56D-652AE7C5462C}"/>
               </a:ext>
             </a:extLst>
           </p:cNvPr>
@@ -4980,7 +4980,7 @@
           <p:cNvPr id="22" name="">
             <a:extLst xmlns:a="http://schemas.openxmlformats.org/drawingml/2006/main">
               <a:ext uri="{FF2B5EF4-FFF2-40B4-BE49-F238E27FC236}">
-                <a16:creationId xmlns:a16="http://schemas.microsoft.com/office/drawing/2014/main" id="{84B74DFF-FB5A-4887-8CCD-3CCDEE7D94B5}"/>
+                <a16:creationId xmlns:a16="http://schemas.microsoft.com/office/drawing/2014/main" id="{72FEB014-BDEB-4E61-9926-C9E98FE62257}"/>
               </a:ext>
             </a:extLst>
           </p:cNvPr>
@@ -5049,7 +5049,7 @@
           <p:cNvPr id="23" name="">
             <a:extLst xmlns:a="http://schemas.openxmlformats.org/drawingml/2006/main">
               <a:ext uri="{FF2B5EF4-FFF2-40B4-BE49-F238E27FC236}">
-                <a16:creationId xmlns:a16="http://schemas.microsoft.com/office/drawing/2014/main" id="{ED4B4BF6-6169-4D5A-B8FB-1DC234F487CC}"/>
+                <a16:creationId xmlns:a16="http://schemas.microsoft.com/office/drawing/2014/main" id="{EC3D9B0E-92E0-479A-A91C-627B2D8B2AD3}"/>
               </a:ext>
             </a:extLst>
           </p:cNvPr>
@@ -5116,7 +5116,7 @@
     </p:spTree>
     <p:extLst>
       <p:ext uri="{BB962C8B-B14F-4D97-AF65-F5344CB8AC3E}">
-        <p14:creationId xmlns:p14="http://schemas.microsoft.com/office/powerpoint/2010/main" val="135227257"/>
+        <p14:creationId xmlns:p14="http://schemas.microsoft.com/office/powerpoint/2010/main" val="508410476"/>
       </p:ext>
     </p:extLst>
   </p:cSld>
@@ -5147,7 +5147,7 @@
           <p:cNvPr id="24" name="">
             <a:extLst xmlns:a="http://schemas.openxmlformats.org/drawingml/2006/main">
               <a:ext uri="{FF2B5EF4-FFF2-40B4-BE49-F238E27FC236}">
-                <a16:creationId xmlns:a16="http://schemas.microsoft.com/office/drawing/2014/main" id="{B5709689-D7CE-4093-A72D-F0ECD9AB2AD7}"/>
+                <a16:creationId xmlns:a16="http://schemas.microsoft.com/office/drawing/2014/main" id="{AC5CFE7A-6999-408C-8F16-F947C38AFBC6}"/>
               </a:ext>
             </a:extLst>
           </p:cNvPr>
@@ -5216,7 +5216,7 @@
           <p:cNvPr id="2" name="">
             <a:extLst xmlns:a="http://schemas.openxmlformats.org/drawingml/2006/main">
               <a:ext uri="{FF2B5EF4-FFF2-40B4-BE49-F238E27FC236}">
-                <a16:creationId xmlns:a16="http://schemas.microsoft.com/office/drawing/2014/main" id="{128591DD-10B8-4394-91F0-E313392DD79B}"/>
+                <a16:creationId xmlns:a16="http://schemas.microsoft.com/office/drawing/2014/main" id="{F98B1B77-74B9-4A18-9FE1-7DB62A61A443}"/>
               </a:ext>
             </a:extLst>
           </p:cNvPr>
@@ -5285,7 +5285,7 @@
           <p:cNvPr id="3" name="">
             <a:extLst xmlns:a="http://schemas.openxmlformats.org/drawingml/2006/main">
               <a:ext uri="{FF2B5EF4-FFF2-40B4-BE49-F238E27FC236}">
-                <a16:creationId xmlns:a16="http://schemas.microsoft.com/office/drawing/2014/main" id="{98F520D6-D895-4CA3-8F8E-C6B3A4ECBFA6}"/>
+                <a16:creationId xmlns:a16="http://schemas.microsoft.com/office/drawing/2014/main" id="{DFE69BDE-186F-43E0-B748-DECCBF4ADC30}"/>
               </a:ext>
             </a:extLst>
           </p:cNvPr>
@@ -5354,7 +5354,7 @@
           <p:cNvPr id="4" name="">
             <a:extLst xmlns:a="http://schemas.openxmlformats.org/drawingml/2006/main">
               <a:ext uri="{FF2B5EF4-FFF2-40B4-BE49-F238E27FC236}">
-                <a16:creationId xmlns:a16="http://schemas.microsoft.com/office/drawing/2014/main" id="{B2749057-888C-4B67-BD50-F7EAAE39494E}"/>
+                <a16:creationId xmlns:a16="http://schemas.microsoft.com/office/drawing/2014/main" id="{C1117A5B-EE32-4F9B-8AF6-C855E2BE0FED}"/>
               </a:ext>
             </a:extLst>
           </p:cNvPr>
@@ -5387,7 +5387,7 @@
           <p:cNvPr id="5" name="">
             <a:extLst xmlns:a="http://schemas.openxmlformats.org/drawingml/2006/main">
               <a:ext uri="{FF2B5EF4-FFF2-40B4-BE49-F238E27FC236}">
-                <a16:creationId xmlns:a16="http://schemas.microsoft.com/office/drawing/2014/main" id="{C6332136-70DB-4E10-BB14-D7ECE82F9098}"/>
+                <a16:creationId xmlns:a16="http://schemas.microsoft.com/office/drawing/2014/main" id="{73A49E64-DA27-48F7-8357-D60164175453}"/>
               </a:ext>
             </a:extLst>
           </p:cNvPr>
@@ -5422,7 +5422,7 @@
           <p:cNvPr id="6" name="">
             <a:extLst xmlns:a="http://schemas.openxmlformats.org/drawingml/2006/main">
               <a:ext uri="{FF2B5EF4-FFF2-40B4-BE49-F238E27FC236}">
-                <a16:creationId xmlns:a16="http://schemas.microsoft.com/office/drawing/2014/main" id="{2CAF8602-00E7-4F96-BE53-946150DF42D3}"/>
+                <a16:creationId xmlns:a16="http://schemas.microsoft.com/office/drawing/2014/main" id="{C4686CF0-B9E4-4906-8B94-356AE9EC7B13}"/>
               </a:ext>
             </a:extLst>
           </p:cNvPr>
@@ -5491,7 +5491,7 @@
           <p:cNvPr id="7" name="">
             <a:extLst xmlns:a="http://schemas.openxmlformats.org/drawingml/2006/main">
               <a:ext uri="{FF2B5EF4-FFF2-40B4-BE49-F238E27FC236}">
-                <a16:creationId xmlns:a16="http://schemas.microsoft.com/office/drawing/2014/main" id="{FF2E9903-1807-4903-83DE-5117AF4FB1CC}"/>
+                <a16:creationId xmlns:a16="http://schemas.microsoft.com/office/drawing/2014/main" id="{3B48D59C-2B8C-4459-95EC-21248E15EF45}"/>
               </a:ext>
             </a:extLst>
           </p:cNvPr>
@@ -5526,7 +5526,7 @@
           <p:cNvPr id="8" name="">
             <a:extLst xmlns:a="http://schemas.openxmlformats.org/drawingml/2006/main">
               <a:ext uri="{FF2B5EF4-FFF2-40B4-BE49-F238E27FC236}">
-                <a16:creationId xmlns:a16="http://schemas.microsoft.com/office/drawing/2014/main" id="{0071E482-9771-4E31-AA7E-2638FB8AA8A3}"/>
+                <a16:creationId xmlns:a16="http://schemas.microsoft.com/office/drawing/2014/main" id="{B3A86A7B-11D4-4D7A-940E-4C0BF2AEA016}"/>
               </a:ext>
             </a:extLst>
           </p:cNvPr>
@@ -5618,7 +5618,7 @@
           <p:cNvPr id="9" name="">
             <a:extLst xmlns:a="http://schemas.openxmlformats.org/drawingml/2006/main">
               <a:ext uri="{FF2B5EF4-FFF2-40B4-BE49-F238E27FC236}">
-                <a16:creationId xmlns:a16="http://schemas.microsoft.com/office/drawing/2014/main" id="{17B6356A-91E4-4232-994E-867196D0DD01}"/>
+                <a16:creationId xmlns:a16="http://schemas.microsoft.com/office/drawing/2014/main" id="{EBDA415D-BB98-4605-8FB1-7EA0E4EB7BF6}"/>
               </a:ext>
             </a:extLst>
           </p:cNvPr>
@@ -5653,7 +5653,7 @@
           <p:cNvPr id="10" name="">
             <a:extLst xmlns:a="http://schemas.openxmlformats.org/drawingml/2006/main">
               <a:ext uri="{FF2B5EF4-FFF2-40B4-BE49-F238E27FC236}">
-                <a16:creationId xmlns:a16="http://schemas.microsoft.com/office/drawing/2014/main" id="{5CF265A4-E34A-4C71-843E-9CB453540F24}"/>
+                <a16:creationId xmlns:a16="http://schemas.microsoft.com/office/drawing/2014/main" id="{D8B24446-891F-4D97-B967-588ECE563132}"/>
               </a:ext>
             </a:extLst>
           </p:cNvPr>
@@ -5722,7 +5722,7 @@
           <p:cNvPr id="11" name="">
             <a:extLst xmlns:a="http://schemas.openxmlformats.org/drawingml/2006/main">
               <a:ext uri="{FF2B5EF4-FFF2-40B4-BE49-F238E27FC236}">
-                <a16:creationId xmlns:a16="http://schemas.microsoft.com/office/drawing/2014/main" id="{D9BC06B6-1DFD-4F56-A9E4-F74BEB2EE07F}"/>
+                <a16:creationId xmlns:a16="http://schemas.microsoft.com/office/drawing/2014/main" id="{A75D7D1B-46B6-4C45-93B4-6B9D6D4FC8AF}"/>
               </a:ext>
             </a:extLst>
           </p:cNvPr>
@@ -5755,7 +5755,7 @@
           <p:cNvPr id="12" name="">
             <a:extLst xmlns:a="http://schemas.openxmlformats.org/drawingml/2006/main">
               <a:ext uri="{FF2B5EF4-FFF2-40B4-BE49-F238E27FC236}">
-                <a16:creationId xmlns:a16="http://schemas.microsoft.com/office/drawing/2014/main" id="{E924004B-DDA9-4B16-B99B-E2A686AFCD64}"/>
+                <a16:creationId xmlns:a16="http://schemas.microsoft.com/office/drawing/2014/main" id="{97FE06AC-3546-4265-8BF7-5817C87AB309}"/>
               </a:ext>
             </a:extLst>
           </p:cNvPr>
@@ -5788,7 +5788,7 @@
           <p:cNvPr id="13" name="">
             <a:extLst xmlns:a="http://schemas.openxmlformats.org/drawingml/2006/main">
               <a:ext uri="{FF2B5EF4-FFF2-40B4-BE49-F238E27FC236}">
-                <a16:creationId xmlns:a16="http://schemas.microsoft.com/office/drawing/2014/main" id="{DB65EF9B-E080-47AC-833A-9ED5E4E55C3C}"/>
+                <a16:creationId xmlns:a16="http://schemas.microsoft.com/office/drawing/2014/main" id="{9FFF88E5-B92B-43E4-AB76-B4F5B45333B4}"/>
               </a:ext>
             </a:extLst>
           </p:cNvPr>
@@ -5857,7 +5857,7 @@
           <p:cNvPr id="14" name="">
             <a:extLst xmlns:a="http://schemas.openxmlformats.org/drawingml/2006/main">
               <a:ext uri="{FF2B5EF4-FFF2-40B4-BE49-F238E27FC236}">
-                <a16:creationId xmlns:a16="http://schemas.microsoft.com/office/drawing/2014/main" id="{28998CE5-AB87-42D4-B8A0-6EDE76E9D499}"/>
+                <a16:creationId xmlns:a16="http://schemas.microsoft.com/office/drawing/2014/main" id="{ABF1FF83-C0DA-4187-B690-E6856D0BB071}"/>
               </a:ext>
             </a:extLst>
           </p:cNvPr>
@@ -5926,7 +5926,7 @@
           <p:cNvPr id="15" name="">
             <a:extLst xmlns:a="http://schemas.openxmlformats.org/drawingml/2006/main">
               <a:ext uri="{FF2B5EF4-FFF2-40B4-BE49-F238E27FC236}">
-                <a16:creationId xmlns:a16="http://schemas.microsoft.com/office/drawing/2014/main" id="{C818F983-D367-4832-952D-07BBF83AE27C}"/>
+                <a16:creationId xmlns:a16="http://schemas.microsoft.com/office/drawing/2014/main" id="{9EC675AD-E6CB-447C-9C20-03EB9FBD393B}"/>
               </a:ext>
             </a:extLst>
           </p:cNvPr>
@@ -5995,7 +5995,7 @@
           <p:cNvPr id="16" name="">
             <a:extLst xmlns:a="http://schemas.openxmlformats.org/drawingml/2006/main">
               <a:ext uri="{FF2B5EF4-FFF2-40B4-BE49-F238E27FC236}">
-                <a16:creationId xmlns:a16="http://schemas.microsoft.com/office/drawing/2014/main" id="{83D823A2-AFE8-499C-93A0-14B11ADEB457}"/>
+                <a16:creationId xmlns:a16="http://schemas.microsoft.com/office/drawing/2014/main" id="{7583960A-41B5-4997-BACB-D6D556D52337}"/>
               </a:ext>
             </a:extLst>
           </p:cNvPr>
@@ -6064,7 +6064,7 @@
           <p:cNvPr id="17" name="">
             <a:extLst xmlns:a="http://schemas.openxmlformats.org/drawingml/2006/main">
               <a:ext uri="{FF2B5EF4-FFF2-40B4-BE49-F238E27FC236}">
-                <a16:creationId xmlns:a16="http://schemas.microsoft.com/office/drawing/2014/main" id="{E8783407-A01F-45C2-AA8F-2CD51AFE347D}"/>
+                <a16:creationId xmlns:a16="http://schemas.microsoft.com/office/drawing/2014/main" id="{5F2B224D-EBC1-449D-A410-5AB34E9CDEBE}"/>
               </a:ext>
             </a:extLst>
           </p:cNvPr>
@@ -6133,7 +6133,7 @@
           <p:cNvPr id="18" name="">
             <a:extLst xmlns:a="http://schemas.openxmlformats.org/drawingml/2006/main">
               <a:ext uri="{FF2B5EF4-FFF2-40B4-BE49-F238E27FC236}">
-                <a16:creationId xmlns:a16="http://schemas.microsoft.com/office/drawing/2014/main" id="{70224601-18F2-44D8-8BE4-4284A87656BB}"/>
+                <a16:creationId xmlns:a16="http://schemas.microsoft.com/office/drawing/2014/main" id="{2950CBD2-8A0D-491E-8530-C2C3A48259B2}"/>
               </a:ext>
             </a:extLst>
           </p:cNvPr>
@@ -6202,7 +6202,7 @@
           <p:cNvPr id="19" name="">
             <a:extLst xmlns:a="http://schemas.openxmlformats.org/drawingml/2006/main">
               <a:ext uri="{FF2B5EF4-FFF2-40B4-BE49-F238E27FC236}">
-                <a16:creationId xmlns:a16="http://schemas.microsoft.com/office/drawing/2014/main" id="{B4D674D9-6AC5-49CD-9A2F-237614B0DC4E}"/>
+                <a16:creationId xmlns:a16="http://schemas.microsoft.com/office/drawing/2014/main" id="{C3028147-8D27-41DF-A73A-102665F030B3}"/>
               </a:ext>
             </a:extLst>
           </p:cNvPr>
@@ -6271,7 +6271,7 @@
           <p:cNvPr id="20" name="">
             <a:extLst xmlns:a="http://schemas.openxmlformats.org/drawingml/2006/main">
               <a:ext uri="{FF2B5EF4-FFF2-40B4-BE49-F238E27FC236}">
-                <a16:creationId xmlns:a16="http://schemas.microsoft.com/office/drawing/2014/main" id="{860EB0F5-3313-4A4C-9B1D-AEFCB1C43D83}"/>
+                <a16:creationId xmlns:a16="http://schemas.microsoft.com/office/drawing/2014/main" id="{1E08E741-4941-4910-82F6-101397551D64}"/>
               </a:ext>
             </a:extLst>
           </p:cNvPr>
@@ -6340,7 +6340,7 @@
           <p:cNvPr id="21" name="">
             <a:extLst xmlns:a="http://schemas.openxmlformats.org/drawingml/2006/main">
               <a:ext uri="{FF2B5EF4-FFF2-40B4-BE49-F238E27FC236}">
-                <a16:creationId xmlns:a16="http://schemas.microsoft.com/office/drawing/2014/main" id="{79DEB90D-A7DF-4715-A804-D3019DDC3A13}"/>
+                <a16:creationId xmlns:a16="http://schemas.microsoft.com/office/drawing/2014/main" id="{5EFADF79-2D57-464B-95DB-ABDA5854B789}"/>
               </a:ext>
             </a:extLst>
           </p:cNvPr>
@@ -6409,7 +6409,7 @@
           <p:cNvPr id="22" name="">
             <a:extLst xmlns:a="http://schemas.openxmlformats.org/drawingml/2006/main">
               <a:ext uri="{FF2B5EF4-FFF2-40B4-BE49-F238E27FC236}">
-                <a16:creationId xmlns:a16="http://schemas.microsoft.com/office/drawing/2014/main" id="{0A42EEF6-3267-4134-B853-064200AC4FC2}"/>
+                <a16:creationId xmlns:a16="http://schemas.microsoft.com/office/drawing/2014/main" id="{7116C69F-776E-4C02-A942-68A1D65B8181}"/>
               </a:ext>
             </a:extLst>
           </p:cNvPr>
@@ -6478,7 +6478,7 @@
           <p:cNvPr id="23" name="">
             <a:extLst xmlns:a="http://schemas.openxmlformats.org/drawingml/2006/main">
               <a:ext uri="{FF2B5EF4-FFF2-40B4-BE49-F238E27FC236}">
-                <a16:creationId xmlns:a16="http://schemas.microsoft.com/office/drawing/2014/main" id="{E2E03EB4-F84A-4FE5-BB89-8F153A8850DC}"/>
+                <a16:creationId xmlns:a16="http://schemas.microsoft.com/office/drawing/2014/main" id="{DFFE03B9-306E-47FB-BCDB-5DC4325A994E}"/>
               </a:ext>
             </a:extLst>
           </p:cNvPr>
@@ -6545,7 +6545,7 @@
     </p:spTree>
     <p:extLst>
       <p:ext uri="{BB962C8B-B14F-4D97-AF65-F5344CB8AC3E}">
-        <p14:creationId xmlns:p14="http://schemas.microsoft.com/office/powerpoint/2010/main" val="1874238899"/>
+        <p14:creationId xmlns:p14="http://schemas.microsoft.com/office/powerpoint/2010/main" val="127167353"/>
       </p:ext>
     </p:extLst>
   </p:cSld>
@@ -6576,7 +6576,7 @@
           <p:cNvPr id="28" name="">
             <a:extLst xmlns:a="http://schemas.openxmlformats.org/drawingml/2006/main">
               <a:ext uri="{FF2B5EF4-FFF2-40B4-BE49-F238E27FC236}">
-                <a16:creationId xmlns:a16="http://schemas.microsoft.com/office/drawing/2014/main" id="{A337A4DC-A21B-4BE0-A12E-D8A396535B0A}"/>
+                <a16:creationId xmlns:a16="http://schemas.microsoft.com/office/drawing/2014/main" id="{C6D1AB7F-0C80-44CB-93B5-A3544968BAA8}"/>
               </a:ext>
             </a:extLst>
           </p:cNvPr>
@@ -6645,7 +6645,7 @@
           <p:cNvPr id="2" name="">
             <a:extLst xmlns:a="http://schemas.openxmlformats.org/drawingml/2006/main">
               <a:ext uri="{FF2B5EF4-FFF2-40B4-BE49-F238E27FC236}">
-                <a16:creationId xmlns:a16="http://schemas.microsoft.com/office/drawing/2014/main" id="{512A3656-6496-4170-B13C-18D0D6172CF8}"/>
+                <a16:creationId xmlns:a16="http://schemas.microsoft.com/office/drawing/2014/main" id="{36D9B34A-D40B-4EDB-8DD3-F0BAC1760B18}"/>
               </a:ext>
             </a:extLst>
           </p:cNvPr>
@@ -6714,7 +6714,7 @@
           <p:cNvPr id="3" name="">
             <a:extLst xmlns:a="http://schemas.openxmlformats.org/drawingml/2006/main">
               <a:ext uri="{FF2B5EF4-FFF2-40B4-BE49-F238E27FC236}">
-                <a16:creationId xmlns:a16="http://schemas.microsoft.com/office/drawing/2014/main" id="{D4B10D3E-CC24-45FD-B5EA-58C1766D38DF}"/>
+                <a16:creationId xmlns:a16="http://schemas.microsoft.com/office/drawing/2014/main" id="{91ED93B4-DFD2-4BE9-ABE2-FBB0EE171F8D}"/>
               </a:ext>
             </a:extLst>
           </p:cNvPr>
@@ -6783,7 +6783,7 @@
           <p:cNvPr id="4" name="">
             <a:extLst xmlns:a="http://schemas.openxmlformats.org/drawingml/2006/main">
               <a:ext uri="{FF2B5EF4-FFF2-40B4-BE49-F238E27FC236}">
-                <a16:creationId xmlns:a16="http://schemas.microsoft.com/office/drawing/2014/main" id="{3102079D-AB58-4038-ABDA-0A36BB089D18}"/>
+                <a16:creationId xmlns:a16="http://schemas.microsoft.com/office/drawing/2014/main" id="{D22BAC26-9F8B-48E5-8883-A9C6006C5028}"/>
               </a:ext>
             </a:extLst>
           </p:cNvPr>
@@ -6816,7 +6816,7 @@
           <p:cNvPr id="5" name="">
             <a:extLst xmlns:a="http://schemas.openxmlformats.org/drawingml/2006/main">
               <a:ext uri="{FF2B5EF4-FFF2-40B4-BE49-F238E27FC236}">
-                <a16:creationId xmlns:a16="http://schemas.microsoft.com/office/drawing/2014/main" id="{4116CCB0-1C96-437C-872B-E6BF1C7D173D}"/>
+                <a16:creationId xmlns:a16="http://schemas.microsoft.com/office/drawing/2014/main" id="{15B08FAF-FF4C-450C-AC73-C6545E9F8324}"/>
               </a:ext>
             </a:extLst>
           </p:cNvPr>
@@ -6885,7 +6885,7 @@
           <p:cNvPr id="6" name="">
             <a:extLst xmlns:a="http://schemas.openxmlformats.org/drawingml/2006/main">
               <a:ext uri="{FF2B5EF4-FFF2-40B4-BE49-F238E27FC236}">
-                <a16:creationId xmlns:a16="http://schemas.microsoft.com/office/drawing/2014/main" id="{FEFE2664-CCBA-4DF7-95E0-58F674315848}"/>
+                <a16:creationId xmlns:a16="http://schemas.microsoft.com/office/drawing/2014/main" id="{FD041950-34E7-4DC1-BCC5-35D9EE6E1C12}"/>
               </a:ext>
             </a:extLst>
           </p:cNvPr>
@@ -6954,7 +6954,7 @@
           <p:cNvPr id="7" name="">
             <a:extLst xmlns:a="http://schemas.openxmlformats.org/drawingml/2006/main">
               <a:ext uri="{FF2B5EF4-FFF2-40B4-BE49-F238E27FC236}">
-                <a16:creationId xmlns:a16="http://schemas.microsoft.com/office/drawing/2014/main" id="{158A1663-DF8E-41CB-A93D-84AF5BBB18A2}"/>
+                <a16:creationId xmlns:a16="http://schemas.microsoft.com/office/drawing/2014/main" id="{9B64E89F-CD66-44E9-94E7-7E118AEFAD08}"/>
               </a:ext>
             </a:extLst>
           </p:cNvPr>
@@ -7023,7 +7023,7 @@
           <p:cNvPr id="8" name="">
             <a:extLst xmlns:a="http://schemas.openxmlformats.org/drawingml/2006/main">
               <a:ext uri="{FF2B5EF4-FFF2-40B4-BE49-F238E27FC236}">
-                <a16:creationId xmlns:a16="http://schemas.microsoft.com/office/drawing/2014/main" id="{83B2BB52-63D8-4C94-8708-0EC2CD4D7331}"/>
+                <a16:creationId xmlns:a16="http://schemas.microsoft.com/office/drawing/2014/main" id="{F9FFF824-8749-48ED-B497-134FA5CFD091}"/>
               </a:ext>
             </a:extLst>
           </p:cNvPr>
@@ -7092,7 +7092,7 @@
           <p:cNvPr id="9" name="">
             <a:extLst xmlns:a="http://schemas.openxmlformats.org/drawingml/2006/main">
               <a:ext uri="{FF2B5EF4-FFF2-40B4-BE49-F238E27FC236}">
-                <a16:creationId xmlns:a16="http://schemas.microsoft.com/office/drawing/2014/main" id="{A17BF295-636F-480F-843B-6DE7C21B52F3}"/>
+                <a16:creationId xmlns:a16="http://schemas.microsoft.com/office/drawing/2014/main" id="{B29E3C7A-C847-4109-8756-E5590CE3D3E6}"/>
               </a:ext>
             </a:extLst>
           </p:cNvPr>
@@ -7127,7 +7127,7 @@
           <p:cNvPr id="10" name="">
             <a:extLst xmlns:a="http://schemas.openxmlformats.org/drawingml/2006/main">
               <a:ext uri="{FF2B5EF4-FFF2-40B4-BE49-F238E27FC236}">
-                <a16:creationId xmlns:a16="http://schemas.microsoft.com/office/drawing/2014/main" id="{62F31252-4BF9-4B86-9790-2C147DBDB7F0}"/>
+                <a16:creationId xmlns:a16="http://schemas.microsoft.com/office/drawing/2014/main" id="{739B97AA-F7F4-4375-8241-E60BE9DE2760}"/>
               </a:ext>
             </a:extLst>
           </p:cNvPr>
@@ -7196,7 +7196,7 @@
           <p:cNvPr id="11" name="">
             <a:extLst xmlns:a="http://schemas.openxmlformats.org/drawingml/2006/main">
               <a:ext uri="{FF2B5EF4-FFF2-40B4-BE49-F238E27FC236}">
-                <a16:creationId xmlns:a16="http://schemas.microsoft.com/office/drawing/2014/main" id="{A1C23574-4C71-475A-833E-48FA078B8470}"/>
+                <a16:creationId xmlns:a16="http://schemas.microsoft.com/office/drawing/2014/main" id="{BA56782F-CEF5-419A-95FF-271DCEE4DE6F}"/>
               </a:ext>
             </a:extLst>
           </p:cNvPr>
@@ -7265,7 +7265,7 @@
           <p:cNvPr id="12" name="">
             <a:extLst xmlns:a="http://schemas.openxmlformats.org/drawingml/2006/main">
               <a:ext uri="{FF2B5EF4-FFF2-40B4-BE49-F238E27FC236}">
-                <a16:creationId xmlns:a16="http://schemas.microsoft.com/office/drawing/2014/main" id="{97DCF85F-FAF5-4E1C-B39E-AF58B7E671C0}"/>
+                <a16:creationId xmlns:a16="http://schemas.microsoft.com/office/drawing/2014/main" id="{B938F792-06DF-47EB-9D25-30AD22BA2B75}"/>
               </a:ext>
             </a:extLst>
           </p:cNvPr>
@@ -7380,7 +7380,7 @@
           <p:cNvPr id="13" name="">
             <a:extLst xmlns:a="http://schemas.openxmlformats.org/drawingml/2006/main">
               <a:ext uri="{FF2B5EF4-FFF2-40B4-BE49-F238E27FC236}">
-                <a16:creationId xmlns:a16="http://schemas.microsoft.com/office/drawing/2014/main" id="{11B03A0B-090F-42A7-BB61-2AA8E4545463}"/>
+                <a16:creationId xmlns:a16="http://schemas.microsoft.com/office/drawing/2014/main" id="{B5C4D481-1631-4F76-8536-E7A0D1025B63}"/>
               </a:ext>
             </a:extLst>
           </p:cNvPr>
@@ -7415,7 +7415,7 @@
           <p:cNvPr id="14" name="">
             <a:extLst xmlns:a="http://schemas.openxmlformats.org/drawingml/2006/main">
               <a:ext uri="{FF2B5EF4-FFF2-40B4-BE49-F238E27FC236}">
-                <a16:creationId xmlns:a16="http://schemas.microsoft.com/office/drawing/2014/main" id="{C9AFACA9-C494-4B82-9006-F0607C6369E0}"/>
+                <a16:creationId xmlns:a16="http://schemas.microsoft.com/office/drawing/2014/main" id="{3BDBBEF9-000D-411F-9B7A-8BCC4E8CF462}"/>
               </a:ext>
             </a:extLst>
           </p:cNvPr>
@@ -7484,7 +7484,7 @@
           <p:cNvPr id="15" name="">
             <a:extLst xmlns:a="http://schemas.openxmlformats.org/drawingml/2006/main">
               <a:ext uri="{FF2B5EF4-FFF2-40B4-BE49-F238E27FC236}">
-                <a16:creationId xmlns:a16="http://schemas.microsoft.com/office/drawing/2014/main" id="{F4B5188B-F75A-41CD-947B-238D9EA7C36B}"/>
+                <a16:creationId xmlns:a16="http://schemas.microsoft.com/office/drawing/2014/main" id="{C532A861-B85A-4E93-A6C0-94AFCA466A49}"/>
               </a:ext>
             </a:extLst>
           </p:cNvPr>
@@ -7553,7 +7553,7 @@
           <p:cNvPr id="16" name="">
             <a:extLst xmlns:a="http://schemas.openxmlformats.org/drawingml/2006/main">
               <a:ext uri="{FF2B5EF4-FFF2-40B4-BE49-F238E27FC236}">
-                <a16:creationId xmlns:a16="http://schemas.microsoft.com/office/drawing/2014/main" id="{36674040-550A-4B0D-8F79-388E4E38C12A}"/>
+                <a16:creationId xmlns:a16="http://schemas.microsoft.com/office/drawing/2014/main" id="{162E0218-087D-4371-8488-A52B30FC5869}"/>
               </a:ext>
             </a:extLst>
           </p:cNvPr>
@@ -7668,7 +7668,7 @@
           <p:cNvPr id="17" name="">
             <a:extLst xmlns:a="http://schemas.openxmlformats.org/drawingml/2006/main">
               <a:ext uri="{FF2B5EF4-FFF2-40B4-BE49-F238E27FC236}">
-                <a16:creationId xmlns:a16="http://schemas.microsoft.com/office/drawing/2014/main" id="{2FD59CE9-4528-44D9-8A96-D374F42BB3F5}"/>
+                <a16:creationId xmlns:a16="http://schemas.microsoft.com/office/drawing/2014/main" id="{9A8CA594-1282-4D6C-982C-9F3476FC1EAC}"/>
               </a:ext>
             </a:extLst>
           </p:cNvPr>
@@ -7703,7 +7703,7 @@
           <p:cNvPr id="18" name="">
             <a:extLst xmlns:a="http://schemas.openxmlformats.org/drawingml/2006/main">
               <a:ext uri="{FF2B5EF4-FFF2-40B4-BE49-F238E27FC236}">
-                <a16:creationId xmlns:a16="http://schemas.microsoft.com/office/drawing/2014/main" id="{42A2301B-1B65-4D8E-A597-7A226F053485}"/>
+                <a16:creationId xmlns:a16="http://schemas.microsoft.com/office/drawing/2014/main" id="{9B36F94D-4A76-42FA-8189-1B6B40B69F7E}"/>
               </a:ext>
             </a:extLst>
           </p:cNvPr>
@@ -7772,7 +7772,7 @@
           <p:cNvPr id="19" name="">
             <a:extLst xmlns:a="http://schemas.openxmlformats.org/drawingml/2006/main">
               <a:ext uri="{FF2B5EF4-FFF2-40B4-BE49-F238E27FC236}">
-                <a16:creationId xmlns:a16="http://schemas.microsoft.com/office/drawing/2014/main" id="{3B7621AB-B08F-4E77-9D60-26FA39FF95A2}"/>
+                <a16:creationId xmlns:a16="http://schemas.microsoft.com/office/drawing/2014/main" id="{E4FC073D-3F37-40AD-AF9C-053953521562}"/>
               </a:ext>
             </a:extLst>
           </p:cNvPr>
@@ -7841,7 +7841,7 @@
           <p:cNvPr id="20" name="">
             <a:extLst xmlns:a="http://schemas.openxmlformats.org/drawingml/2006/main">
               <a:ext uri="{FF2B5EF4-FFF2-40B4-BE49-F238E27FC236}">
-                <a16:creationId xmlns:a16="http://schemas.microsoft.com/office/drawing/2014/main" id="{73C08E30-F4F3-4E7E-8D5C-7D58940C8938}"/>
+                <a16:creationId xmlns:a16="http://schemas.microsoft.com/office/drawing/2014/main" id="{B96F0D37-BE84-4C69-BD18-16E6216BEA85}"/>
               </a:ext>
             </a:extLst>
           </p:cNvPr>
@@ -7956,7 +7956,7 @@
           <p:cNvPr id="21" name="">
             <a:extLst xmlns:a="http://schemas.openxmlformats.org/drawingml/2006/main">
               <a:ext uri="{FF2B5EF4-FFF2-40B4-BE49-F238E27FC236}">
-                <a16:creationId xmlns:a16="http://schemas.microsoft.com/office/drawing/2014/main" id="{ACCFE58B-0B79-4C1E-967A-6F5D1D4643E8}"/>
+                <a16:creationId xmlns:a16="http://schemas.microsoft.com/office/drawing/2014/main" id="{D4BA35B5-90A9-4908-BC0D-6843DC1C46EB}"/>
               </a:ext>
             </a:extLst>
           </p:cNvPr>
@@ -7991,7 +7991,7 @@
           <p:cNvPr id="22" name="">
             <a:extLst xmlns:a="http://schemas.openxmlformats.org/drawingml/2006/main">
               <a:ext uri="{FF2B5EF4-FFF2-40B4-BE49-F238E27FC236}">
-                <a16:creationId xmlns:a16="http://schemas.microsoft.com/office/drawing/2014/main" id="{8D763971-E8C9-4D05-A56F-34FF12519DFC}"/>
+                <a16:creationId xmlns:a16="http://schemas.microsoft.com/office/drawing/2014/main" id="{B4C1B22F-9C29-4993-8CD5-9E2CA6270E8F}"/>
               </a:ext>
             </a:extLst>
           </p:cNvPr>
@@ -8060,7 +8060,7 @@
           <p:cNvPr id="23" name="">
             <a:extLst xmlns:a="http://schemas.openxmlformats.org/drawingml/2006/main">
               <a:ext uri="{FF2B5EF4-FFF2-40B4-BE49-F238E27FC236}">
-                <a16:creationId xmlns:a16="http://schemas.microsoft.com/office/drawing/2014/main" id="{4EEB8D6D-4B9A-4699-AD1A-A28F308C72ED}"/>
+                <a16:creationId xmlns:a16="http://schemas.microsoft.com/office/drawing/2014/main" id="{C1C15C4E-FE5B-4F94-A91F-D945BFE6937F}"/>
               </a:ext>
             </a:extLst>
           </p:cNvPr>
@@ -8129,7 +8129,7 @@
           <p:cNvPr id="24" name="">
             <a:extLst xmlns:a="http://schemas.openxmlformats.org/drawingml/2006/main">
               <a:ext uri="{FF2B5EF4-FFF2-40B4-BE49-F238E27FC236}">
-                <a16:creationId xmlns:a16="http://schemas.microsoft.com/office/drawing/2014/main" id="{B5F866FE-7D30-41B3-8481-A9A0E36677D0}"/>
+                <a16:creationId xmlns:a16="http://schemas.microsoft.com/office/drawing/2014/main" id="{CB7DF534-8F61-413F-94DB-03075B737B14}"/>
               </a:ext>
             </a:extLst>
           </p:cNvPr>
@@ -8244,7 +8244,7 @@
           <p:cNvPr id="25" name="">
             <a:extLst xmlns:a="http://schemas.openxmlformats.org/drawingml/2006/main">
               <a:ext uri="{FF2B5EF4-FFF2-40B4-BE49-F238E27FC236}">
-                <a16:creationId xmlns:a16="http://schemas.microsoft.com/office/drawing/2014/main" id="{DC2A7081-BAE1-4D24-B2D7-2296CD69171F}"/>
+                <a16:creationId xmlns:a16="http://schemas.microsoft.com/office/drawing/2014/main" id="{4B6C61C9-0B6C-4CF8-8712-5536C3B5D9E5}"/>
               </a:ext>
             </a:extLst>
           </p:cNvPr>
@@ -8313,7 +8313,7 @@
           <p:cNvPr id="26" name="">
             <a:extLst xmlns:a="http://schemas.openxmlformats.org/drawingml/2006/main">
               <a:ext uri="{FF2B5EF4-FFF2-40B4-BE49-F238E27FC236}">
-                <a16:creationId xmlns:a16="http://schemas.microsoft.com/office/drawing/2014/main" id="{CF801149-9323-4E1C-82A7-45218971F14E}"/>
+                <a16:creationId xmlns:a16="http://schemas.microsoft.com/office/drawing/2014/main" id="{D2DBEB00-95B2-4663-A737-1AD35436ACC0}"/>
               </a:ext>
             </a:extLst>
           </p:cNvPr>
@@ -8382,7 +8382,7 @@
           <p:cNvPr id="27" name="">
             <a:extLst xmlns:a="http://schemas.openxmlformats.org/drawingml/2006/main">
               <a:ext uri="{FF2B5EF4-FFF2-40B4-BE49-F238E27FC236}">
-                <a16:creationId xmlns:a16="http://schemas.microsoft.com/office/drawing/2014/main" id="{9D9BA055-DDA1-4196-A3A7-43CD1FD0EEC1}"/>
+                <a16:creationId xmlns:a16="http://schemas.microsoft.com/office/drawing/2014/main" id="{C168D006-7469-4280-B8ED-45B66DC5A58F}"/>
               </a:ext>
             </a:extLst>
           </p:cNvPr>
@@ -8449,7 +8449,7 @@
     </p:spTree>
     <p:extLst>
       <p:ext uri="{BB962C8B-B14F-4D97-AF65-F5344CB8AC3E}">
-        <p14:creationId xmlns:p14="http://schemas.microsoft.com/office/powerpoint/2010/main" val="1687691269"/>
+        <p14:creationId xmlns:p14="http://schemas.microsoft.com/office/powerpoint/2010/main" val="42974518"/>
       </p:ext>
     </p:extLst>
   </p:cSld>
@@ -8480,7 +8480,7 @@
           <p:cNvPr id="12" name="">
             <a:extLst xmlns:a="http://schemas.openxmlformats.org/drawingml/2006/main">
               <a:ext uri="{FF2B5EF4-FFF2-40B4-BE49-F238E27FC236}">
-                <a16:creationId xmlns:a16="http://schemas.microsoft.com/office/drawing/2014/main" id="{F54A0062-C47A-48AA-8B93-A0772E3942D6}"/>
+                <a16:creationId xmlns:a16="http://schemas.microsoft.com/office/drawing/2014/main" id="{B26D3347-5332-4F8B-819C-4458CCAC360B}"/>
               </a:ext>
             </a:extLst>
           </p:cNvPr>
@@ -8549,7 +8549,7 @@
           <p:cNvPr id="2" name="">
             <a:extLst xmlns:a="http://schemas.openxmlformats.org/drawingml/2006/main">
               <a:ext uri="{FF2B5EF4-FFF2-40B4-BE49-F238E27FC236}">
-                <a16:creationId xmlns:a16="http://schemas.microsoft.com/office/drawing/2014/main" id="{9F2D4B59-DBBB-42C7-9DEC-D348443B9AEB}"/>
+                <a16:creationId xmlns:a16="http://schemas.microsoft.com/office/drawing/2014/main" id="{2E2D5DCD-23C4-4C6D-95E5-7063CAA74D4D}"/>
               </a:ext>
             </a:extLst>
           </p:cNvPr>
@@ -8618,7 +8618,7 @@
           <p:cNvPr id="3" name="">
             <a:extLst xmlns:a="http://schemas.openxmlformats.org/drawingml/2006/main">
               <a:ext uri="{FF2B5EF4-FFF2-40B4-BE49-F238E27FC236}">
-                <a16:creationId xmlns:a16="http://schemas.microsoft.com/office/drawing/2014/main" id="{C694E9FC-02C2-48C1-A702-AE89CE66C48B}"/>
+                <a16:creationId xmlns:a16="http://schemas.microsoft.com/office/drawing/2014/main" id="{4668BFEF-6109-4276-96E0-954E2526F060}"/>
               </a:ext>
             </a:extLst>
           </p:cNvPr>
@@ -8687,7 +8687,7 @@
           <p:cNvPr id="4" name="">
             <a:extLst xmlns:a="http://schemas.openxmlformats.org/drawingml/2006/main">
               <a:ext uri="{FF2B5EF4-FFF2-40B4-BE49-F238E27FC236}">
-                <a16:creationId xmlns:a16="http://schemas.microsoft.com/office/drawing/2014/main" id="{4D94C9B6-4727-47F2-9942-2487526822B3}"/>
+                <a16:creationId xmlns:a16="http://schemas.microsoft.com/office/drawing/2014/main" id="{70379BE4-B16A-4A64-B3D8-C59A44CE6DE0}"/>
               </a:ext>
             </a:extLst>
           </p:cNvPr>
@@ -8720,7 +8720,7 @@
           <p:cNvPr id="5" name="">
             <a:extLst xmlns:a="http://schemas.openxmlformats.org/drawingml/2006/main">
               <a:ext uri="{FF2B5EF4-FFF2-40B4-BE49-F238E27FC236}">
-                <a16:creationId xmlns:a16="http://schemas.microsoft.com/office/drawing/2014/main" id="{3035EB5B-6CB6-4DD5-8940-E5D6962E3476}"/>
+                <a16:creationId xmlns:a16="http://schemas.microsoft.com/office/drawing/2014/main" id="{8ECE69F0-780A-4679-BFE5-6C878064362A}"/>
               </a:ext>
             </a:extLst>
           </p:cNvPr>
@@ -8789,7 +8789,7 @@
           <p:cNvPr id="6" name="">
             <a:extLst xmlns:a="http://schemas.openxmlformats.org/drawingml/2006/main">
               <a:ext uri="{FF2B5EF4-FFF2-40B4-BE49-F238E27FC236}">
-                <a16:creationId xmlns:a16="http://schemas.microsoft.com/office/drawing/2014/main" id="{4ECAE1D7-A399-46AF-A46F-E1BF36D89841}"/>
+                <a16:creationId xmlns:a16="http://schemas.microsoft.com/office/drawing/2014/main" id="{EC81023B-476E-4F6E-8740-5C66AA829011}"/>
               </a:ext>
             </a:extLst>
           </p:cNvPr>
@@ -9034,7 +9034,7 @@
           <p:cNvPr id="7" name="">
             <a:extLst xmlns:a="http://schemas.openxmlformats.org/drawingml/2006/main">
               <a:ext uri="{FF2B5EF4-FFF2-40B4-BE49-F238E27FC236}">
-                <a16:creationId xmlns:a16="http://schemas.microsoft.com/office/drawing/2014/main" id="{8C40576E-8758-407D-84ED-21FFDE1932D7}"/>
+                <a16:creationId xmlns:a16="http://schemas.microsoft.com/office/drawing/2014/main" id="{0CB2DFEF-F6C8-4708-838D-3BCBBC95EFB7}"/>
               </a:ext>
             </a:extLst>
           </p:cNvPr>
@@ -9103,7 +9103,7 @@
           <p:cNvPr id="8" name="">
             <a:extLst xmlns:a="http://schemas.openxmlformats.org/drawingml/2006/main">
               <a:ext uri="{FF2B5EF4-FFF2-40B4-BE49-F238E27FC236}">
-                <a16:creationId xmlns:a16="http://schemas.microsoft.com/office/drawing/2014/main" id="{9E4745A3-5A4B-4F20-BD35-05499BAD9E01}"/>
+                <a16:creationId xmlns:a16="http://schemas.microsoft.com/office/drawing/2014/main" id="{5D415DBE-2D73-4A7B-B3F6-C93FECA6A120}"/>
               </a:ext>
             </a:extLst>
           </p:cNvPr>
@@ -9113,7 +9113,7 @@
           <p:nvPr/>
         </p:nvPicPr>
         <p:blipFill>
-          <a:blip xmlns:r="http://schemas.openxmlformats.org/officeDocument/2006/relationships" xmlns:a="http://schemas.openxmlformats.org/drawingml/2006/main" r:embed="Rbccd1841250844dc"/>
+          <a:blip xmlns:r="http://schemas.openxmlformats.org/officeDocument/2006/relationships" xmlns:a="http://schemas.openxmlformats.org/drawingml/2006/main" r:embed="R2303361aaf244d24"/>
           <a:stretch xmlns:a="http://schemas.openxmlformats.org/drawingml/2006/main"/>
         </p:blipFill>
         <p:spPr>
@@ -9133,7 +9133,7 @@
           <p:cNvPr id="9" name="">
             <a:extLst xmlns:a="http://schemas.openxmlformats.org/drawingml/2006/main">
               <a:ext uri="{FF2B5EF4-FFF2-40B4-BE49-F238E27FC236}">
-                <a16:creationId xmlns:a16="http://schemas.microsoft.com/office/drawing/2014/main" id="{290A4015-9E18-4705-91F5-1EB538915367}"/>
+                <a16:creationId xmlns:a16="http://schemas.microsoft.com/office/drawing/2014/main" id="{1A00CE74-AFB7-4178-9070-1FD4126DC623}"/>
               </a:ext>
             </a:extLst>
           </p:cNvPr>
@@ -9202,7 +9202,7 @@
           <p:cNvPr id="10" name="">
             <a:extLst xmlns:a="http://schemas.openxmlformats.org/drawingml/2006/main">
               <a:ext uri="{FF2B5EF4-FFF2-40B4-BE49-F238E27FC236}">
-                <a16:creationId xmlns:a16="http://schemas.microsoft.com/office/drawing/2014/main" id="{FAC114E1-EA5B-4274-BE7C-291D51A0AB40}"/>
+                <a16:creationId xmlns:a16="http://schemas.microsoft.com/office/drawing/2014/main" id="{31FF450E-1AD7-4B76-A7D9-6DC635CAD926}"/>
               </a:ext>
             </a:extLst>
           </p:cNvPr>
@@ -9271,7 +9271,7 @@
           <p:cNvPr id="11" name="">
             <a:extLst xmlns:a="http://schemas.openxmlformats.org/drawingml/2006/main">
               <a:ext uri="{FF2B5EF4-FFF2-40B4-BE49-F238E27FC236}">
-                <a16:creationId xmlns:a16="http://schemas.microsoft.com/office/drawing/2014/main" id="{643899D2-D254-4F43-BA46-59029DC5AA34}"/>
+                <a16:creationId xmlns:a16="http://schemas.microsoft.com/office/drawing/2014/main" id="{8C78DF8D-2970-46AB-A44F-22CFA85493A0}"/>
               </a:ext>
             </a:extLst>
           </p:cNvPr>
@@ -9338,7 +9338,7 @@
     </p:spTree>
     <p:extLst>
       <p:ext uri="{BB962C8B-B14F-4D97-AF65-F5344CB8AC3E}">
-        <p14:creationId xmlns:p14="http://schemas.microsoft.com/office/powerpoint/2010/main" val="593936720"/>
+        <p14:creationId xmlns:p14="http://schemas.microsoft.com/office/powerpoint/2010/main" val="1348363177"/>
       </p:ext>
     </p:extLst>
   </p:cSld>
@@ -9369,7 +9369,7 @@
           <p:cNvPr id="9" name="">
             <a:extLst xmlns:a="http://schemas.openxmlformats.org/drawingml/2006/main">
               <a:ext uri="{FF2B5EF4-FFF2-40B4-BE49-F238E27FC236}">
-                <a16:creationId xmlns:a16="http://schemas.microsoft.com/office/drawing/2014/main" id="{1EC35063-416D-480B-9DC5-AE32757AEC4A}"/>
+                <a16:creationId xmlns:a16="http://schemas.microsoft.com/office/drawing/2014/main" id="{0A9B81CE-40F1-4AB3-B855-5E5C41339A43}"/>
               </a:ext>
             </a:extLst>
           </p:cNvPr>
@@ -9438,7 +9438,7 @@
           <p:cNvPr id="2" name="">
             <a:extLst xmlns:a="http://schemas.openxmlformats.org/drawingml/2006/main">
               <a:ext uri="{FF2B5EF4-FFF2-40B4-BE49-F238E27FC236}">
-                <a16:creationId xmlns:a16="http://schemas.microsoft.com/office/drawing/2014/main" id="{1E56EF0D-DF48-4466-BCC1-68876053F82F}"/>
+                <a16:creationId xmlns:a16="http://schemas.microsoft.com/office/drawing/2014/main" id="{CB669C56-C0D6-4FBD-9422-DE437DFAB55D}"/>
               </a:ext>
             </a:extLst>
           </p:cNvPr>
@@ -9507,7 +9507,7 @@
           <p:cNvPr id="3" name="">
             <a:extLst xmlns:a="http://schemas.openxmlformats.org/drawingml/2006/main">
               <a:ext uri="{FF2B5EF4-FFF2-40B4-BE49-F238E27FC236}">
-                <a16:creationId xmlns:a16="http://schemas.microsoft.com/office/drawing/2014/main" id="{61AA809D-ECA0-466A-B887-C8B41AEA71E6}"/>
+                <a16:creationId xmlns:a16="http://schemas.microsoft.com/office/drawing/2014/main" id="{D5F90B7F-40CA-4A75-B1DA-E9ABD500F767}"/>
               </a:ext>
             </a:extLst>
           </p:cNvPr>
@@ -9576,7 +9576,7 @@
           <p:cNvPr id="4" name="">
             <a:extLst xmlns:a="http://schemas.openxmlformats.org/drawingml/2006/main">
               <a:ext uri="{FF2B5EF4-FFF2-40B4-BE49-F238E27FC236}">
-                <a16:creationId xmlns:a16="http://schemas.microsoft.com/office/drawing/2014/main" id="{8F651CBA-40A8-422A-A130-8BAF8155709E}"/>
+                <a16:creationId xmlns:a16="http://schemas.microsoft.com/office/drawing/2014/main" id="{1E6B631A-8F98-4C73-85AE-9AB948F4B056}"/>
               </a:ext>
             </a:extLst>
           </p:cNvPr>
@@ -9586,7 +9586,7 @@
           <p:nvPr/>
         </p:nvPicPr>
         <p:blipFill>
-          <a:blip xmlns:r="http://schemas.openxmlformats.org/officeDocument/2006/relationships" xmlns:a="http://schemas.openxmlformats.org/drawingml/2006/main" r:embed="R3131cd1c0415404c"/>
+          <a:blip xmlns:r="http://schemas.openxmlformats.org/officeDocument/2006/relationships" xmlns:a="http://schemas.openxmlformats.org/drawingml/2006/main" r:embed="Rf3af4c966cb543ff"/>
           <a:stretch xmlns:a="http://schemas.openxmlformats.org/drawingml/2006/main"/>
         </p:blipFill>
         <p:spPr>
@@ -9606,7 +9606,7 @@
           <p:cNvPr id="5" name="">
             <a:extLst xmlns:a="http://schemas.openxmlformats.org/drawingml/2006/main">
               <a:ext uri="{FF2B5EF4-FFF2-40B4-BE49-F238E27FC236}">
-                <a16:creationId xmlns:a16="http://schemas.microsoft.com/office/drawing/2014/main" id="{60DAFD29-7746-414A-86E3-31B3353267F1}"/>
+                <a16:creationId xmlns:a16="http://schemas.microsoft.com/office/drawing/2014/main" id="{4F25B45C-CE56-4C66-9815-AB68902921D7}"/>
               </a:ext>
             </a:extLst>
           </p:cNvPr>
@@ -9675,7 +9675,7 @@
           <p:cNvPr id="6" name="">
             <a:extLst xmlns:a="http://schemas.openxmlformats.org/drawingml/2006/main">
               <a:ext uri="{FF2B5EF4-FFF2-40B4-BE49-F238E27FC236}">
-                <a16:creationId xmlns:a16="http://schemas.microsoft.com/office/drawing/2014/main" id="{8EA6BBE8-9C01-4CBA-9732-1C747671605C}"/>
+                <a16:creationId xmlns:a16="http://schemas.microsoft.com/office/drawing/2014/main" id="{0632CF0B-9808-4F5B-8A42-D6E60CFCEB35}"/>
               </a:ext>
             </a:extLst>
           </p:cNvPr>
@@ -9744,7 +9744,7 @@
           <p:cNvPr id="7" name="">
             <a:extLst xmlns:a="http://schemas.openxmlformats.org/drawingml/2006/main">
               <a:ext uri="{FF2B5EF4-FFF2-40B4-BE49-F238E27FC236}">
-                <a16:creationId xmlns:a16="http://schemas.microsoft.com/office/drawing/2014/main" id="{089C8CF9-9435-421E-B68E-588D4A3D3B2A}"/>
+                <a16:creationId xmlns:a16="http://schemas.microsoft.com/office/drawing/2014/main" id="{6B43ABC9-FA6D-41C9-92CC-939012253B96}"/>
               </a:ext>
             </a:extLst>
           </p:cNvPr>
@@ -9813,7 +9813,7 @@
           <p:cNvPr id="8" name="">
             <a:extLst xmlns:a="http://schemas.openxmlformats.org/drawingml/2006/main">
               <a:ext uri="{FF2B5EF4-FFF2-40B4-BE49-F238E27FC236}">
-                <a16:creationId xmlns:a16="http://schemas.microsoft.com/office/drawing/2014/main" id="{38CFB80C-5D2A-4EBC-A86B-E8DBE4DF0496}"/>
+                <a16:creationId xmlns:a16="http://schemas.microsoft.com/office/drawing/2014/main" id="{CD1CF7CF-BF34-45F2-8593-576DB83556E0}"/>
               </a:ext>
             </a:extLst>
           </p:cNvPr>
@@ -9880,7 +9880,7 @@
     </p:spTree>
     <p:extLst>
       <p:ext uri="{BB962C8B-B14F-4D97-AF65-F5344CB8AC3E}">
-        <p14:creationId xmlns:p14="http://schemas.microsoft.com/office/powerpoint/2010/main" val="522166961"/>
+        <p14:creationId xmlns:p14="http://schemas.microsoft.com/office/powerpoint/2010/main" val="1379316737"/>
       </p:ext>
     </p:extLst>
   </p:cSld>
@@ -9911,7 +9911,7 @@
           <p:cNvPr id="13" name="">
             <a:extLst xmlns:a="http://schemas.openxmlformats.org/drawingml/2006/main">
               <a:ext uri="{FF2B5EF4-FFF2-40B4-BE49-F238E27FC236}">
-                <a16:creationId xmlns:a16="http://schemas.microsoft.com/office/drawing/2014/main" id="{F8801596-4061-4591-B183-7A19A7FC7F32}"/>
+                <a16:creationId xmlns:a16="http://schemas.microsoft.com/office/drawing/2014/main" id="{2A45C5A4-ADBE-4F9F-851D-B1D28C300CC9}"/>
               </a:ext>
             </a:extLst>
           </p:cNvPr>
@@ -9980,7 +9980,7 @@
           <p:cNvPr id="2" name="">
             <a:extLst xmlns:a="http://schemas.openxmlformats.org/drawingml/2006/main">
               <a:ext uri="{FF2B5EF4-FFF2-40B4-BE49-F238E27FC236}">
-                <a16:creationId xmlns:a16="http://schemas.microsoft.com/office/drawing/2014/main" id="{0D1B679D-8586-4760-9483-85608D09A29F}"/>
+                <a16:creationId xmlns:a16="http://schemas.microsoft.com/office/drawing/2014/main" id="{DD3BA5EC-15C7-406C-B1C4-63F1EDE1C254}"/>
               </a:ext>
             </a:extLst>
           </p:cNvPr>
@@ -10049,7 +10049,7 @@
           <p:cNvPr id="3" name="">
             <a:extLst xmlns:a="http://schemas.openxmlformats.org/drawingml/2006/main">
               <a:ext uri="{FF2B5EF4-FFF2-40B4-BE49-F238E27FC236}">
-                <a16:creationId xmlns:a16="http://schemas.microsoft.com/office/drawing/2014/main" id="{5751C8F1-CBEE-4E00-A6AE-403EB900116F}"/>
+                <a16:creationId xmlns:a16="http://schemas.microsoft.com/office/drawing/2014/main" id="{B18D83D7-697F-4E03-A360-B14678598035}"/>
               </a:ext>
             </a:extLst>
           </p:cNvPr>
@@ -10118,7 +10118,7 @@
           <p:cNvPr id="4" name="">
             <a:extLst xmlns:a="http://schemas.openxmlformats.org/drawingml/2006/main">
               <a:ext uri="{FF2B5EF4-FFF2-40B4-BE49-F238E27FC236}">
-                <a16:creationId xmlns:a16="http://schemas.microsoft.com/office/drawing/2014/main" id="{C9C25209-3849-481F-A001-65E53DCA4F84}"/>
+                <a16:creationId xmlns:a16="http://schemas.microsoft.com/office/drawing/2014/main" id="{AEC3D193-5CD7-4594-B6ED-630BCFFD1025}"/>
               </a:ext>
             </a:extLst>
           </p:cNvPr>
@@ -10151,7 +10151,7 @@
           <p:cNvPr id="5" name="">
             <a:extLst xmlns:a="http://schemas.openxmlformats.org/drawingml/2006/main">
               <a:ext uri="{FF2B5EF4-FFF2-40B4-BE49-F238E27FC236}">
-                <a16:creationId xmlns:a16="http://schemas.microsoft.com/office/drawing/2014/main" id="{9A7047E8-CEBF-40BB-8CF3-DC79F3392266}"/>
+                <a16:creationId xmlns:a16="http://schemas.microsoft.com/office/drawing/2014/main" id="{15EC84D6-6135-49A6-A277-EADE5904C97C}"/>
               </a:ext>
             </a:extLst>
           </p:cNvPr>
@@ -10161,7 +10161,7 @@
           <p:nvPr/>
         </p:nvPicPr>
         <p:blipFill>
-          <a:blip xmlns:r="http://schemas.openxmlformats.org/officeDocument/2006/relationships" xmlns:a="http://schemas.openxmlformats.org/drawingml/2006/main" r:embed="R0fe99951fb6546ef"/>
+          <a:blip xmlns:r="http://schemas.openxmlformats.org/officeDocument/2006/relationships" xmlns:a="http://schemas.openxmlformats.org/drawingml/2006/main" r:embed="Ra8b30ab79eae4f1d"/>
           <a:stretch xmlns:a="http://schemas.openxmlformats.org/drawingml/2006/main"/>
         </p:blipFill>
         <p:spPr>
@@ -10181,7 +10181,7 @@
           <p:cNvPr id="6" name="">
             <a:extLst xmlns:a="http://schemas.openxmlformats.org/drawingml/2006/main">
               <a:ext uri="{FF2B5EF4-FFF2-40B4-BE49-F238E27FC236}">
-                <a16:creationId xmlns:a16="http://schemas.microsoft.com/office/drawing/2014/main" id="{307376B3-31AF-4270-9BB1-51014A729A5A}"/>
+                <a16:creationId xmlns:a16="http://schemas.microsoft.com/office/drawing/2014/main" id="{42F7A92C-316D-4B9D-BE5C-2155726B66A2}"/>
               </a:ext>
             </a:extLst>
           </p:cNvPr>
@@ -10191,7 +10191,7 @@
           <p:nvPr/>
         </p:nvPicPr>
         <p:blipFill>
-          <a:blip xmlns:r="http://schemas.openxmlformats.org/officeDocument/2006/relationships" xmlns:a="http://schemas.openxmlformats.org/drawingml/2006/main" r:embed="Re9bc7792299b4217"/>
+          <a:blip xmlns:r="http://schemas.openxmlformats.org/officeDocument/2006/relationships" xmlns:a="http://schemas.openxmlformats.org/drawingml/2006/main" r:embed="R4a34a16f7d0f4384"/>
           <a:stretch xmlns:a="http://schemas.openxmlformats.org/drawingml/2006/main"/>
         </p:blipFill>
         <p:spPr>
@@ -10211,7 +10211,7 @@
           <p:cNvPr id="7" name="">
             <a:extLst xmlns:a="http://schemas.openxmlformats.org/drawingml/2006/main">
               <a:ext uri="{FF2B5EF4-FFF2-40B4-BE49-F238E27FC236}">
-                <a16:creationId xmlns:a16="http://schemas.microsoft.com/office/drawing/2014/main" id="{78F9A79F-D293-45C3-A6F4-7C1919E09A0F}"/>
+                <a16:creationId xmlns:a16="http://schemas.microsoft.com/office/drawing/2014/main" id="{0D852BA5-FBC5-44C3-AB64-0A1E7E4DEED3}"/>
               </a:ext>
             </a:extLst>
           </p:cNvPr>
@@ -10280,7 +10280,7 @@
           <p:cNvPr id="8" name="">
             <a:extLst xmlns:a="http://schemas.openxmlformats.org/drawingml/2006/main">
               <a:ext uri="{FF2B5EF4-FFF2-40B4-BE49-F238E27FC236}">
-                <a16:creationId xmlns:a16="http://schemas.microsoft.com/office/drawing/2014/main" id="{7ADA4443-4EA6-4359-B0BF-0BEB747AE4BD}"/>
+                <a16:creationId xmlns:a16="http://schemas.microsoft.com/office/drawing/2014/main" id="{9535FAD5-BE2A-4251-AE29-0961C8CF46F8}"/>
               </a:ext>
             </a:extLst>
           </p:cNvPr>
@@ -10349,7 +10349,7 @@
           <p:cNvPr id="9" name="">
             <a:extLst xmlns:a="http://schemas.openxmlformats.org/drawingml/2006/main">
               <a:ext uri="{FF2B5EF4-FFF2-40B4-BE49-F238E27FC236}">
-                <a16:creationId xmlns:a16="http://schemas.microsoft.com/office/drawing/2014/main" id="{2F6D112D-ED22-4FAB-964B-F35BA05D1F08}"/>
+                <a16:creationId xmlns:a16="http://schemas.microsoft.com/office/drawing/2014/main" id="{DFB77FBD-ED0A-4D98-9BB6-7050C251A6EC}"/>
               </a:ext>
             </a:extLst>
           </p:cNvPr>
@@ -10418,7 +10418,7 @@
           <p:cNvPr id="10" name="">
             <a:extLst xmlns:a="http://schemas.openxmlformats.org/drawingml/2006/main">
               <a:ext uri="{FF2B5EF4-FFF2-40B4-BE49-F238E27FC236}">
-                <a16:creationId xmlns:a16="http://schemas.microsoft.com/office/drawing/2014/main" id="{1E335879-91D1-481F-AECE-F5D0AB43E92B}"/>
+                <a16:creationId xmlns:a16="http://schemas.microsoft.com/office/drawing/2014/main" id="{01ABC60D-2220-41F7-ABA7-2FF507F32713}"/>
               </a:ext>
             </a:extLst>
           </p:cNvPr>
@@ -10487,7 +10487,7 @@
           <p:cNvPr id="11" name="">
             <a:extLst xmlns:a="http://schemas.openxmlformats.org/drawingml/2006/main">
               <a:ext uri="{FF2B5EF4-FFF2-40B4-BE49-F238E27FC236}">
-                <a16:creationId xmlns:a16="http://schemas.microsoft.com/office/drawing/2014/main" id="{A8C745D7-06DC-4838-B874-BA36AF17BE0B}"/>
+                <a16:creationId xmlns:a16="http://schemas.microsoft.com/office/drawing/2014/main" id="{70335858-42C8-4E7C-92AC-FC6C952876B8}"/>
               </a:ext>
             </a:extLst>
           </p:cNvPr>
@@ -10556,7 +10556,7 @@
           <p:cNvPr id="12" name="">
             <a:extLst xmlns:a="http://schemas.openxmlformats.org/drawingml/2006/main">
               <a:ext uri="{FF2B5EF4-FFF2-40B4-BE49-F238E27FC236}">
-                <a16:creationId xmlns:a16="http://schemas.microsoft.com/office/drawing/2014/main" id="{70BC1970-1C6A-4C59-9DE9-91F25F005C0C}"/>
+                <a16:creationId xmlns:a16="http://schemas.microsoft.com/office/drawing/2014/main" id="{747508B3-8D7D-420E-9ABE-C785603DCD16}"/>
               </a:ext>
             </a:extLst>
           </p:cNvPr>
@@ -10623,7 +10623,7 @@
     </p:spTree>
     <p:extLst>
       <p:ext uri="{BB962C8B-B14F-4D97-AF65-F5344CB8AC3E}">
-        <p14:creationId xmlns:p14="http://schemas.microsoft.com/office/powerpoint/2010/main" val="18744954"/>
+        <p14:creationId xmlns:p14="http://schemas.microsoft.com/office/powerpoint/2010/main" val="928839273"/>
       </p:ext>
     </p:extLst>
   </p:cSld>
@@ -10654,7 +10654,7 @@
           <p:cNvPr id="20" name="">
             <a:extLst xmlns:a="http://schemas.openxmlformats.org/drawingml/2006/main">
               <a:ext uri="{FF2B5EF4-FFF2-40B4-BE49-F238E27FC236}">
-                <a16:creationId xmlns:a16="http://schemas.microsoft.com/office/drawing/2014/main" id="{52F66435-3C99-409F-97C0-0BFE9731C5F3}"/>
+                <a16:creationId xmlns:a16="http://schemas.microsoft.com/office/drawing/2014/main" id="{C009943C-E231-4B80-A3AB-DB4697A77D55}"/>
               </a:ext>
             </a:extLst>
           </p:cNvPr>
@@ -10723,7 +10723,7 @@
           <p:cNvPr id="2" name="">
             <a:extLst xmlns:a="http://schemas.openxmlformats.org/drawingml/2006/main">
               <a:ext uri="{FF2B5EF4-FFF2-40B4-BE49-F238E27FC236}">
-                <a16:creationId xmlns:a16="http://schemas.microsoft.com/office/drawing/2014/main" id="{86A8DAC2-49BF-4528-9E3F-16D2F6AE2D70}"/>
+                <a16:creationId xmlns:a16="http://schemas.microsoft.com/office/drawing/2014/main" id="{9AE209E3-F63D-4BD8-A525-B9976F2084EF}"/>
               </a:ext>
             </a:extLst>
           </p:cNvPr>
@@ -10792,7 +10792,7 @@
           <p:cNvPr id="3" name="">
             <a:extLst xmlns:a="http://schemas.openxmlformats.org/drawingml/2006/main">
               <a:ext uri="{FF2B5EF4-FFF2-40B4-BE49-F238E27FC236}">
-                <a16:creationId xmlns:a16="http://schemas.microsoft.com/office/drawing/2014/main" id="{C76D82DA-6BD5-46E5-8047-7D4690943DD0}"/>
+                <a16:creationId xmlns:a16="http://schemas.microsoft.com/office/drawing/2014/main" id="{0CC01FA1-A0A3-49BF-AD29-4DA0260032EE}"/>
               </a:ext>
             </a:extLst>
           </p:cNvPr>
@@ -10861,7 +10861,7 @@
           <p:cNvPr id="4" name="">
             <a:extLst xmlns:a="http://schemas.openxmlformats.org/drawingml/2006/main">
               <a:ext uri="{FF2B5EF4-FFF2-40B4-BE49-F238E27FC236}">
-                <a16:creationId xmlns:a16="http://schemas.microsoft.com/office/drawing/2014/main" id="{AD4C068D-1CE1-4A2F-ABA3-C182610704FA}"/>
+                <a16:creationId xmlns:a16="http://schemas.microsoft.com/office/drawing/2014/main" id="{DF7E5696-70D6-48F7-ACCA-5AD376AC88EC}"/>
               </a:ext>
             </a:extLst>
           </p:cNvPr>
@@ -10894,7 +10894,7 @@
           <p:cNvPr id="5" name="">
             <a:extLst xmlns:a="http://schemas.openxmlformats.org/drawingml/2006/main">
               <a:ext uri="{FF2B5EF4-FFF2-40B4-BE49-F238E27FC236}">
-                <a16:creationId xmlns:a16="http://schemas.microsoft.com/office/drawing/2014/main" id="{B10F6A49-C397-4C69-AFE9-484EA56301EE}"/>
+                <a16:creationId xmlns:a16="http://schemas.microsoft.com/office/drawing/2014/main" id="{753574BA-E065-4394-B1E6-8C8D1E28E8AB}"/>
               </a:ext>
             </a:extLst>
           </p:cNvPr>
@@ -10963,7 +10963,7 @@
           <p:cNvPr id="6" name="">
             <a:extLst xmlns:a="http://schemas.openxmlformats.org/drawingml/2006/main">
               <a:ext uri="{FF2B5EF4-FFF2-40B4-BE49-F238E27FC236}">
-                <a16:creationId xmlns:a16="http://schemas.microsoft.com/office/drawing/2014/main" id="{5D91322C-6BD5-4B18-AACB-6B1FB28CA45A}"/>
+                <a16:creationId xmlns:a16="http://schemas.microsoft.com/office/drawing/2014/main" id="{71C8CA6E-6FA0-4878-8149-E28E6D5A7366}"/>
               </a:ext>
             </a:extLst>
           </p:cNvPr>
@@ -11032,7 +11032,7 @@
           <p:cNvPr id="7" name="">
             <a:extLst xmlns:a="http://schemas.openxmlformats.org/drawingml/2006/main">
               <a:ext uri="{FF2B5EF4-FFF2-40B4-BE49-F238E27FC236}">
-                <a16:creationId xmlns:a16="http://schemas.microsoft.com/office/drawing/2014/main" id="{69B787B6-ADF4-4546-93FB-946EA69009C4}"/>
+                <a16:creationId xmlns:a16="http://schemas.microsoft.com/office/drawing/2014/main" id="{31CFF305-4AFB-4310-A74C-9384B9525B7E}"/>
               </a:ext>
             </a:extLst>
           </p:cNvPr>
@@ -11101,7 +11101,7 @@
           <p:cNvPr id="8" name="">
             <a:extLst xmlns:a="http://schemas.openxmlformats.org/drawingml/2006/main">
               <a:ext uri="{FF2B5EF4-FFF2-40B4-BE49-F238E27FC236}">
-                <a16:creationId xmlns:a16="http://schemas.microsoft.com/office/drawing/2014/main" id="{F70526EE-2BF1-4D9B-8B5A-C7D7D1C25924}"/>
+                <a16:creationId xmlns:a16="http://schemas.microsoft.com/office/drawing/2014/main" id="{2086561B-0981-45C7-864D-323A12CD052B}"/>
               </a:ext>
             </a:extLst>
           </p:cNvPr>
@@ -11170,7 +11170,7 @@
           <p:cNvPr id="9" name="">
             <a:extLst xmlns:a="http://schemas.openxmlformats.org/drawingml/2006/main">
               <a:ext uri="{FF2B5EF4-FFF2-40B4-BE49-F238E27FC236}">
-                <a16:creationId xmlns:a16="http://schemas.microsoft.com/office/drawing/2014/main" id="{F2D7551A-1EF7-4C8E-9A17-4596166ACB2D}"/>
+                <a16:creationId xmlns:a16="http://schemas.microsoft.com/office/drawing/2014/main" id="{A11D858A-5ABB-4110-A05F-CA2DB391EFBF}"/>
               </a:ext>
             </a:extLst>
           </p:cNvPr>
@@ -11203,7 +11203,7 @@
           <p:cNvPr id="10" name="">
             <a:extLst xmlns:a="http://schemas.openxmlformats.org/drawingml/2006/main">
               <a:ext uri="{FF2B5EF4-FFF2-40B4-BE49-F238E27FC236}">
-                <a16:creationId xmlns:a16="http://schemas.microsoft.com/office/drawing/2014/main" id="{BCF647E3-D125-491A-A220-DB9E504382F0}"/>
+                <a16:creationId xmlns:a16="http://schemas.microsoft.com/office/drawing/2014/main" id="{12CFFB5B-29C9-49FB-9E0B-23DCAB40FB21}"/>
               </a:ext>
             </a:extLst>
           </p:cNvPr>
@@ -11272,7 +11272,7 @@
           <p:cNvPr id="11" name="">
             <a:extLst xmlns:a="http://schemas.openxmlformats.org/drawingml/2006/main">
               <a:ext uri="{FF2B5EF4-FFF2-40B4-BE49-F238E27FC236}">
-                <a16:creationId xmlns:a16="http://schemas.microsoft.com/office/drawing/2014/main" id="{DF622202-996B-4114-974F-70F04559C89B}"/>
+                <a16:creationId xmlns:a16="http://schemas.microsoft.com/office/drawing/2014/main" id="{7597CC80-F90B-4E6A-A958-FF411979CD25}"/>
               </a:ext>
             </a:extLst>
           </p:cNvPr>
@@ -11341,7 +11341,7 @@
           <p:cNvPr id="12" name="">
             <a:extLst xmlns:a="http://schemas.openxmlformats.org/drawingml/2006/main">
               <a:ext uri="{FF2B5EF4-FFF2-40B4-BE49-F238E27FC236}">
-                <a16:creationId xmlns:a16="http://schemas.microsoft.com/office/drawing/2014/main" id="{20BAAAAE-5E8D-49AB-A488-6C09D1094F99}"/>
+                <a16:creationId xmlns:a16="http://schemas.microsoft.com/office/drawing/2014/main" id="{C1ED1302-92C1-42AE-A77A-D36F74D11A8F}"/>
               </a:ext>
             </a:extLst>
           </p:cNvPr>
@@ -11374,7 +11374,7 @@
           <p:cNvPr id="13" name="">
             <a:extLst xmlns:a="http://schemas.openxmlformats.org/drawingml/2006/main">
               <a:ext uri="{FF2B5EF4-FFF2-40B4-BE49-F238E27FC236}">
-                <a16:creationId xmlns:a16="http://schemas.microsoft.com/office/drawing/2014/main" id="{F90CFA46-F884-45D1-9118-3B408286AFBF}"/>
+                <a16:creationId xmlns:a16="http://schemas.microsoft.com/office/drawing/2014/main" id="{BFC7740A-706E-4F0D-9D64-028C93C2107F}"/>
               </a:ext>
             </a:extLst>
           </p:cNvPr>
@@ -11443,7 +11443,7 @@
           <p:cNvPr id="14" name="">
             <a:extLst xmlns:a="http://schemas.openxmlformats.org/drawingml/2006/main">
               <a:ext uri="{FF2B5EF4-FFF2-40B4-BE49-F238E27FC236}">
-                <a16:creationId xmlns:a16="http://schemas.microsoft.com/office/drawing/2014/main" id="{C8DD52EC-3C36-4F70-BCA0-B53B04FFC8DD}"/>
+                <a16:creationId xmlns:a16="http://schemas.microsoft.com/office/drawing/2014/main" id="{5B68D04F-8A65-4307-8D3C-E2C7348A4843}"/>
               </a:ext>
             </a:extLst>
           </p:cNvPr>
@@ -11512,7 +11512,7 @@
           <p:cNvPr id="15" name="">
             <a:extLst xmlns:a="http://schemas.openxmlformats.org/drawingml/2006/main">
               <a:ext uri="{FF2B5EF4-FFF2-40B4-BE49-F238E27FC236}">
-                <a16:creationId xmlns:a16="http://schemas.microsoft.com/office/drawing/2014/main" id="{FCB3FC61-9B84-42DA-90DA-D072ACD8BC91}"/>
+                <a16:creationId xmlns:a16="http://schemas.microsoft.com/office/drawing/2014/main" id="{3130E046-8F0C-4B0A-849A-E12326497EA8}"/>
               </a:ext>
             </a:extLst>
           </p:cNvPr>
@@ -11545,7 +11545,7 @@
           <p:cNvPr id="16" name="">
             <a:extLst xmlns:a="http://schemas.openxmlformats.org/drawingml/2006/main">
               <a:ext uri="{FF2B5EF4-FFF2-40B4-BE49-F238E27FC236}">
-                <a16:creationId xmlns:a16="http://schemas.microsoft.com/office/drawing/2014/main" id="{7238A0F4-AFCB-4F63-BF9D-295B7954695B}"/>
+                <a16:creationId xmlns:a16="http://schemas.microsoft.com/office/drawing/2014/main" id="{76B03663-36C8-43AA-9885-8379EA4ABAA7}"/>
               </a:ext>
             </a:extLst>
           </p:cNvPr>
@@ -11614,7 +11614,7 @@
           <p:cNvPr id="17" name="">
             <a:extLst xmlns:a="http://schemas.openxmlformats.org/drawingml/2006/main">
               <a:ext uri="{FF2B5EF4-FFF2-40B4-BE49-F238E27FC236}">
-                <a16:creationId xmlns:a16="http://schemas.microsoft.com/office/drawing/2014/main" id="{8DDA1F36-96AB-463D-90E9-2E2CF0614D15}"/>
+                <a16:creationId xmlns:a16="http://schemas.microsoft.com/office/drawing/2014/main" id="{E74CFAA0-6E38-4B7C-985F-04924197CB57}"/>
               </a:ext>
             </a:extLst>
           </p:cNvPr>
@@ -11683,7 +11683,7 @@
           <p:cNvPr id="18" name="">
             <a:extLst xmlns:a="http://schemas.openxmlformats.org/drawingml/2006/main">
               <a:ext uri="{FF2B5EF4-FFF2-40B4-BE49-F238E27FC236}">
-                <a16:creationId xmlns:a16="http://schemas.microsoft.com/office/drawing/2014/main" id="{299760C6-37B1-443F-B0DB-E6F52B0A300F}"/>
+                <a16:creationId xmlns:a16="http://schemas.microsoft.com/office/drawing/2014/main" id="{9055EA3E-B3E4-42E0-8786-A667A7572EA2}"/>
               </a:ext>
             </a:extLst>
           </p:cNvPr>
@@ -11752,7 +11752,7 @@
           <p:cNvPr id="19" name="">
             <a:extLst xmlns:a="http://schemas.openxmlformats.org/drawingml/2006/main">
               <a:ext uri="{FF2B5EF4-FFF2-40B4-BE49-F238E27FC236}">
-                <a16:creationId xmlns:a16="http://schemas.microsoft.com/office/drawing/2014/main" id="{94992FE2-8887-49B5-B298-6358009192D6}"/>
+                <a16:creationId xmlns:a16="http://schemas.microsoft.com/office/drawing/2014/main" id="{FA78E7A5-3404-4797-9CA4-0C29C385EFE4}"/>
               </a:ext>
             </a:extLst>
           </p:cNvPr>
@@ -11819,7 +11819,7 @@
     </p:spTree>
     <p:extLst>
       <p:ext uri="{BB962C8B-B14F-4D97-AF65-F5344CB8AC3E}">
-        <p14:creationId xmlns:p14="http://schemas.microsoft.com/office/powerpoint/2010/main" val="932078162"/>
+        <p14:creationId xmlns:p14="http://schemas.microsoft.com/office/powerpoint/2010/main" val="54360524"/>
       </p:ext>
     </p:extLst>
   </p:cSld>
@@ -11850,7 +11850,7 @@
           <p:cNvPr id="9" name="">
             <a:extLst xmlns:a="http://schemas.openxmlformats.org/drawingml/2006/main">
               <a:ext uri="{FF2B5EF4-FFF2-40B4-BE49-F238E27FC236}">
-                <a16:creationId xmlns:a16="http://schemas.microsoft.com/office/drawing/2014/main" id="{3BC24E86-C06B-4FEA-B02A-BD32B1FC8613}"/>
+                <a16:creationId xmlns:a16="http://schemas.microsoft.com/office/drawing/2014/main" id="{ABB4D4D5-B257-441E-A01F-9ED5B9CBE5EC}"/>
               </a:ext>
             </a:extLst>
           </p:cNvPr>
@@ -11919,7 +11919,7 @@
           <p:cNvPr id="2" name="">
             <a:extLst xmlns:a="http://schemas.openxmlformats.org/drawingml/2006/main">
               <a:ext uri="{FF2B5EF4-FFF2-40B4-BE49-F238E27FC236}">
-                <a16:creationId xmlns:a16="http://schemas.microsoft.com/office/drawing/2014/main" id="{EDD46234-9531-4FB0-A505-FBB6392EDE95}"/>
+                <a16:creationId xmlns:a16="http://schemas.microsoft.com/office/drawing/2014/main" id="{BF0A8A42-34F5-4D50-AC85-EA544AABE4B8}"/>
               </a:ext>
             </a:extLst>
           </p:cNvPr>
@@ -11988,7 +11988,7 @@
           <p:cNvPr id="3" name="">
             <a:extLst xmlns:a="http://schemas.openxmlformats.org/drawingml/2006/main">
               <a:ext uri="{FF2B5EF4-FFF2-40B4-BE49-F238E27FC236}">
-                <a16:creationId xmlns:a16="http://schemas.microsoft.com/office/drawing/2014/main" id="{B0D11A32-062E-46F7-BFD6-BE10EC54B409}"/>
+                <a16:creationId xmlns:a16="http://schemas.microsoft.com/office/drawing/2014/main" id="{2B691A23-8087-49D3-9094-50B114BD2C9C}"/>
               </a:ext>
             </a:extLst>
           </p:cNvPr>
@@ -12057,7 +12057,7 @@
           <p:cNvPr id="4" name="">
             <a:extLst xmlns:a="http://schemas.openxmlformats.org/drawingml/2006/main">
               <a:ext uri="{FF2B5EF4-FFF2-40B4-BE49-F238E27FC236}">
-                <a16:creationId xmlns:a16="http://schemas.microsoft.com/office/drawing/2014/main" id="{B6932C68-3569-4015-BEC1-A3606647B98D}"/>
+                <a16:creationId xmlns:a16="http://schemas.microsoft.com/office/drawing/2014/main" id="{58CA1227-173E-45F5-BBD2-D8F74C11C6A1}"/>
               </a:ext>
             </a:extLst>
           </p:cNvPr>
@@ -12090,7 +12090,7 @@
           <p:cNvPr id="5" name="">
             <a:extLst xmlns:a="http://schemas.openxmlformats.org/drawingml/2006/main">
               <a:ext uri="{FF2B5EF4-FFF2-40B4-BE49-F238E27FC236}">
-                <a16:creationId xmlns:a16="http://schemas.microsoft.com/office/drawing/2014/main" id="{82C60DEB-E5A4-42A5-8E14-1AE7F5D38970}"/>
+                <a16:creationId xmlns:a16="http://schemas.microsoft.com/office/drawing/2014/main" id="{3A26B6F5-97AB-4574-B266-EE8133B72AF5}"/>
               </a:ext>
             </a:extLst>
           </p:cNvPr>
@@ -12566,7 +12566,7 @@
           <p:cNvPr id="6" name="">
             <a:extLst xmlns:a="http://schemas.openxmlformats.org/drawingml/2006/main">
               <a:ext uri="{FF2B5EF4-FFF2-40B4-BE49-F238E27FC236}">
-                <a16:creationId xmlns:a16="http://schemas.microsoft.com/office/drawing/2014/main" id="{C8F457B8-2BCB-4DBF-8A34-B454ADBB61B9}"/>
+                <a16:creationId xmlns:a16="http://schemas.microsoft.com/office/drawing/2014/main" id="{5BC0FFED-5B59-4A2C-8260-F70627B6C2F9}"/>
               </a:ext>
             </a:extLst>
           </p:cNvPr>
@@ -12597,7 +12597,7 @@
             <a:defPPr algn="ctr">
               <a:defRPr sz="1425" b="1">
                 <a:solidFill>
-                  <a:srgbClr val="F4C95D"/>
+                  <a:srgbClr val="42D392"/>
                 </a:solidFill>
                 <a:latin typeface="Arial"/>
                 <a:ea typeface="Arial"/>
@@ -12609,7 +12609,7 @@
             <a:pPr algn="ctr">
               <a:defRPr sz="1425" b="1">
                 <a:solidFill>
-                  <a:srgbClr val="F4C95D"/>
+                  <a:srgbClr val="42D392"/>
                 </a:solidFill>
                 <a:latin typeface="Arial"/>
                 <a:ea typeface="Arial"/>
@@ -12619,13 +12619,13 @@
             <a:r>
               <a:rPr sz="1425" b="1">
                 <a:solidFill>
-                  <a:srgbClr val="F4C95D"/>
+                  <a:srgbClr val="42D392"/>
                 </a:solidFill>
                 <a:latin typeface="Arial"/>
                 <a:ea typeface="Arial"/>
                 <a:cs typeface="Arial"/>
               </a:rPr>
-              <a:t>Antes do envio: preencher os nomes e a turma na capa e no README.</a:t>
+              <a:t>Entrega final: integrante, turma, documentação e evidências conferidos.</a:t>
             </a:r>
           </a:p>
         </p:txBody>
@@ -12635,7 +12635,7 @@
           <p:cNvPr id="7" name="">
             <a:extLst xmlns:a="http://schemas.openxmlformats.org/drawingml/2006/main">
               <a:ext uri="{FF2B5EF4-FFF2-40B4-BE49-F238E27FC236}">
-                <a16:creationId xmlns:a16="http://schemas.microsoft.com/office/drawing/2014/main" id="{5EC9E890-9461-4B8E-B7D5-8336A7998BA0}"/>
+                <a16:creationId xmlns:a16="http://schemas.microsoft.com/office/drawing/2014/main" id="{17D15550-950D-4904-8AFD-BBB4C209D18D}"/>
               </a:ext>
             </a:extLst>
           </p:cNvPr>
@@ -12704,7 +12704,7 @@
           <p:cNvPr id="8" name="">
             <a:extLst xmlns:a="http://schemas.openxmlformats.org/drawingml/2006/main">
               <a:ext uri="{FF2B5EF4-FFF2-40B4-BE49-F238E27FC236}">
-                <a16:creationId xmlns:a16="http://schemas.microsoft.com/office/drawing/2014/main" id="{95824EC5-8390-4FDF-8E9E-39268B1B63B9}"/>
+                <a16:creationId xmlns:a16="http://schemas.microsoft.com/office/drawing/2014/main" id="{25B9C43E-7310-4DAF-8212-60179B701AD2}"/>
               </a:ext>
             </a:extLst>
           </p:cNvPr>
@@ -12771,7 +12771,7 @@
     </p:spTree>
     <p:extLst>
       <p:ext uri="{BB962C8B-B14F-4D97-AF65-F5344CB8AC3E}">
-        <p14:creationId xmlns:p14="http://schemas.microsoft.com/office/powerpoint/2010/main" val="943487516"/>
+        <p14:creationId xmlns:p14="http://schemas.microsoft.com/office/powerpoint/2010/main" val="1151612641"/>
       </p:ext>
     </p:extLst>
   </p:cSld>

</xml_diff>